<commit_message>
docs: remove ai box from final slide
</commit_message>
<xml_diff>
--- a/Presentacion-Proyecto2.pptx
+++ b/Presentacion-Proyecto2.pptx
@@ -4,6 +4,9 @@
   <p:sldMasterIdLst>
     <p:sldMasterId id="2147483648" r:id="rId1"/>
   </p:sldMasterIdLst>
+  <p:notesMasterIdLst>
+    <p:notesMasterId r:id="rId15"/>
+  </p:notesMasterIdLst>
   <p:sldIdLst>
     <p:sldId id="256" r:id="rId2"/>
     <p:sldId id="257" r:id="rId3"/>
@@ -19,9 +22,6 @@
     <p:sldId id="267" r:id="rId13"/>
     <p:sldId id="268" r:id="rId14"/>
   </p:sldIdLst>
-  <p:notesMasterIdLst>
-    <p:notesMasterId r:id="rId15"/>
-  </p:notesMasterIdLst>
   <p:sldSz cx="12192000" cy="6858000"/>
   <p:notesSz cx="6858000" cy="12192000"/>
   <p:defaultTextStyle>
@@ -116,6 +116,11 @@
       </a:defRPr>
     </a:lvl9pPr>
   </p:defaultTextStyle>
+  <p:extLst>
+    <p:ext uri="{EFAFB233-063F-42B5-8137-9DF3F51BA10A}">
+      <p15:sldGuideLst xmlns:p15="http://schemas.microsoft.com/office/powerpoint/2012/main"/>
+    </p:ext>
+  </p:extLst>
 </p:presentation>
 </file>
 
@@ -141,234 +146,10 @@
           <a:chExt cx="0" cy="0"/>
         </a:xfrm>
       </p:grpSpPr>
-      <p:sp>
-        <p:nvSpPr>
-          <p:cNvPr id="2" name="Header Placeholder 1"/>
-          <p:cNvSpPr>
-            <a:spLocks noGrp="1"/>
-          </p:cNvSpPr>
-          <p:nvPr>
-            <p:ph type="hdr" sz="quarter"/>
-          </p:nvPr>
-        </p:nvSpPr>
-        <p:spPr>
-          <a:xfrm>
-            <a:off x="0" y="0"/>
-            <a:ext cx="2971800" cy="458788"/>
-          </a:xfrm>
-          <a:prstGeom prst="rect">
-            <a:avLst/>
-          </a:prstGeom>
-        </p:spPr>
-        <p:txBody>
-          <a:bodyPr vert="horz" lIns="91440" tIns="45720" rIns="91440" bIns="45720" rtlCol="0"/>
-          <a:lstStyle>
-            <a:lvl1pPr algn="l">
-              <a:defRPr sz="1200"/>
-            </a:lvl1pPr>
-          </a:lstStyle>
-          <a:p>
-            <a:endParaRPr lang="en-US"/>
-          </a:p>
-        </p:txBody>
-      </p:sp>
-      <p:sp>
-        <p:nvSpPr>
-          <p:cNvPr id="3" name="Date Placeholder 2"/>
-          <p:cNvSpPr>
-            <a:spLocks noGrp="1"/>
-          </p:cNvSpPr>
-          <p:nvPr>
-            <p:ph type="dt" idx="1"/>
-          </p:nvPr>
-        </p:nvSpPr>
-        <p:spPr>
-          <a:xfrm>
-            <a:off x="3884613" y="0"/>
-            <a:ext cx="2971800" cy="458788"/>
-          </a:xfrm>
-          <a:prstGeom prst="rect">
-            <a:avLst/>
-          </a:prstGeom>
-        </p:spPr>
-        <p:txBody>
-          <a:bodyPr vert="horz" lIns="91440" tIns="45720" rIns="91440" bIns="45720" rtlCol="0"/>
-          <a:lstStyle>
-            <a:lvl1pPr algn="r">
-              <a:defRPr sz="1200"/>
-            </a:lvl1pPr>
-          </a:lstStyle>
-          <a:p>
-            <a:fld id="{5282F153-3F37-0F45-9E97-73ACFA13230C}" type="datetimeFigureOut">
-              <a:rPr lang="en-US"/>
-              <a:t>7/23/19</a:t>
-            </a:fld>
-            <a:endParaRPr lang="en-US"/>
-          </a:p>
-        </p:txBody>
-      </p:sp>
-      <p:sp>
-        <p:nvSpPr>
-          <p:cNvPr id="4" name="Slide Image Placeholder 3"/>
-          <p:cNvSpPr>
-            <a:spLocks noGrp="1" noRot="1" noChangeAspect="1"/>
-          </p:cNvSpPr>
-          <p:nvPr>
-            <p:ph type="sldImg" idx="2"/>
-          </p:nvPr>
-        </p:nvSpPr>
-        <p:spPr>
-          <a:xfrm>
-            <a:off x="685800" y="1143000"/>
-            <a:ext cx="5486400" cy="3086100"/>
-          </a:xfrm>
-          <a:prstGeom prst="rect">
-            <a:avLst/>
-          </a:prstGeom>
-          <a:noFill/>
-          <a:ln w="12700">
-            <a:solidFill>
-              <a:prstClr val="black"/>
-            </a:solidFill>
-          </a:ln>
-        </p:spPr>
-        <p:txBody>
-          <a:bodyPr vert="horz" lIns="91440" tIns="45720" rIns="91440" bIns="45720" rtlCol="0" anchor="ctr"/>
-          <a:lstStyle/>
-          <a:p>
-            <a:endParaRPr lang="en-US"/>
-          </a:p>
-        </p:txBody>
-      </p:sp>
-      <p:sp>
-        <p:nvSpPr>
-          <p:cNvPr id="5" name="Notes Placeholder 4"/>
-          <p:cNvSpPr>
-            <a:spLocks noGrp="1"/>
-          </p:cNvSpPr>
-          <p:nvPr>
-            <p:ph type="body" sz="quarter" idx="3"/>
-          </p:nvPr>
-        </p:nvSpPr>
-        <p:spPr>
-          <a:xfrm>
-            <a:off x="685800" y="4400550"/>
-            <a:ext cx="5486400" cy="3600450"/>
-          </a:xfrm>
-          <a:prstGeom prst="rect">
-            <a:avLst/>
-          </a:prstGeom>
-        </p:spPr>
-        <p:txBody>
-          <a:bodyPr vert="horz" lIns="91440" tIns="45720" rIns="91440" bIns="45720" rtlCol="0"/>
-          <a:lstStyle/>
-          <a:p>
-            <a:pPr lvl="0"/>
-            <a:r>
-              <a:rPr lang="en-US"/>
-              <a:t>Click to edit Master text styles</a:t>
-            </a:r>
-          </a:p>
-          <a:p>
-            <a:pPr lvl="1"/>
-            <a:r>
-              <a:rPr lang="en-US"/>
-              <a:t>Second level</a:t>
-            </a:r>
-          </a:p>
-          <a:p>
-            <a:pPr lvl="2"/>
-            <a:r>
-              <a:rPr lang="en-US"/>
-              <a:t>Third level</a:t>
-            </a:r>
-          </a:p>
-          <a:p>
-            <a:pPr lvl="3"/>
-            <a:r>
-              <a:rPr lang="en-US"/>
-              <a:t>Fourth level</a:t>
-            </a:r>
-          </a:p>
-          <a:p>
-            <a:pPr lvl="4"/>
-            <a:r>
-              <a:rPr lang="en-US"/>
-              <a:t>Fifth level</a:t>
-            </a:r>
-          </a:p>
-        </p:txBody>
-      </p:sp>
-      <p:sp>
-        <p:nvSpPr>
-          <p:cNvPr id="6" name="Footer Placeholder 5"/>
-          <p:cNvSpPr>
-            <a:spLocks noGrp="1"/>
-          </p:cNvSpPr>
-          <p:nvPr>
-            <p:ph type="ftr" sz="quarter" idx="4"/>
-          </p:nvPr>
-        </p:nvSpPr>
-        <p:spPr>
-          <a:xfrm>
-            <a:off x="0" y="8685213"/>
-            <a:ext cx="2971800" cy="458787"/>
-          </a:xfrm>
-          <a:prstGeom prst="rect">
-            <a:avLst/>
-          </a:prstGeom>
-        </p:spPr>
-        <p:txBody>
-          <a:bodyPr vert="horz" lIns="91440" tIns="45720" rIns="91440" bIns="45720" rtlCol="0" anchor="b"/>
-          <a:lstStyle>
-            <a:lvl1pPr algn="l">
-              <a:defRPr sz="1200"/>
-            </a:lvl1pPr>
-          </a:lstStyle>
-          <a:p>
-            <a:endParaRPr lang="en-US"/>
-          </a:p>
-        </p:txBody>
-      </p:sp>
-      <p:sp>
-        <p:nvSpPr>
-          <p:cNvPr id="7" name="Slide Number Placeholder 6"/>
-          <p:cNvSpPr>
-            <a:spLocks noGrp="1"/>
-          </p:cNvSpPr>
-          <p:nvPr>
-            <p:ph type="sldNum" sz="quarter" idx="5"/>
-          </p:nvPr>
-        </p:nvSpPr>
-        <p:spPr>
-          <a:xfrm>
-            <a:off x="3884613" y="8685213"/>
-            <a:ext cx="2971800" cy="458787"/>
-          </a:xfrm>
-          <a:prstGeom prst="rect">
-            <a:avLst/>
-          </a:prstGeom>
-        </p:spPr>
-        <p:txBody>
-          <a:bodyPr vert="horz" lIns="91440" tIns="45720" rIns="91440" bIns="45720" rtlCol="0" anchor="b"/>
-          <a:lstStyle>
-            <a:lvl1pPr algn="r">
-              <a:defRPr sz="1200"/>
-            </a:lvl1pPr>
-          </a:lstStyle>
-          <a:p>
-            <a:fld id="{CE5E9CC1-C706-0F49-92D6-E571CC5EEA8F}" type="slidenum">
-              <a:rPr lang="en-US"/>
-              <a:t>‹#›</a:t>
-            </a:fld>
-            <a:endParaRPr lang="en-US"/>
-          </a:p>
-        </p:txBody>
-      </p:sp>
     </p:spTree>
     <p:extLst>
       <p:ext uri="{BB962C8B-B14F-4D97-AF65-F5344CB8AC3E}">
-        <p14:creationId xmlns:p14="http://schemas.microsoft.com/office/powerpoint/2010/main" val="1024086991"/>
+        <p14:creationId xmlns:p14="http://schemas.microsoft.com/office/powerpoint/2010/main" val="1011212630"/>
       </p:ext>
     </p:extLst>
   </p:cSld>
@@ -516,7 +297,6 @@
               <a:rPr lang="en-US" dirty="0"/>
               <a:t>Presentamos un clasificador de tres clases para el estado de diabetes. Todo el código está en el repositorio Proyecto2-IA y corre de principio a fin.</a:t>
             </a:r>
-            <a:endParaRPr lang="en-US" dirty="0"/>
           </a:p>
         </p:txBody>
       </p:sp>
@@ -604,7 +384,6 @@
               <a:rPr lang="en-US" dirty="0"/>
               <a:t>Ejemplos concretos tomados del conjunto de prueba, ordenados por la probabilidad del modelo. La conclusión: una persona con diabetes y perfil sano no tiene nada en estas 21 variables que la distinga de una persona sana.</a:t>
             </a:r>
-            <a:endParaRPr lang="en-US" dirty="0"/>
           </a:p>
         </p:txBody>
       </p:sp>
@@ -692,7 +471,6 @@
               <a:rPr lang="en-US" dirty="0"/>
               <a:t>El sesgo por edad e ingreso viene de que esas personas con diabetes tienen, en promedio, un perfil más sano. Es un sesgo a reportar aunque el F1 macro por grupo sea parecido (0.40 a 0.44).</a:t>
             </a:r>
-            <a:endParaRPr lang="en-US" dirty="0"/>
           </a:p>
         </p:txBody>
       </p:sp>
@@ -780,7 +558,6 @@
               <a:rPr lang="en-US" dirty="0"/>
               <a:t>El techo de 0.44 aparece con cinco algoritmos distintos, lo que sugiere que el límite está en los datos y no en el modelo. El CDC estima que una parte importante de las personas con diabetes y la gran mayoría con prediabetes no lo saben.</a:t>
             </a:r>
-            <a:endParaRPr lang="en-US" dirty="0"/>
           </a:p>
         </p:txBody>
       </p:sp>
@@ -868,7 +645,6 @@
               <a:rPr lang="en-US" dirty="0"/>
               <a:t>Cierre: el modelo sirve como primer filtro para recomendar una prueba de diabetes, con el sesgo conocido hacia personas jóvenes y de ingresos altos. Para prediabetes harían falta variables clínicas.</a:t>
             </a:r>
-            <a:endParaRPr lang="en-US" dirty="0"/>
           </a:p>
         </p:txBody>
       </p:sp>
@@ -956,7 +732,6 @@
               <a:rPr lang="en-US" dirty="0"/>
               <a:t>El costo más alto es no detectar a una persona con diabetes; una prueba médica de más cuesta poco. Por eso miramos también el recall por clase. Pregunta probable: por qué no accuracy. Respuesta: con 84% de personas sanas, predecir siempre sano da 84% de accuracy sin detectar a nadie.</a:t>
             </a:r>
-            <a:endParaRPr lang="en-US" dirty="0"/>
           </a:p>
         </p:txBody>
       </p:sp>
@@ -1044,7 +819,6 @@
               <a:rPr lang="en-US" dirty="0"/>
               <a:t>Usamos el archivo de Kaggle porque el de UCI solo trae la etiqueta binaria; tienen los mismos registros y variables. Con esta distribución, predecir siempre sin diabetes da 84% de accuracy sin detectar a nadie: por eso F1 macro, pesos de clase y partición estratificada.</a:t>
             </a:r>
-            <a:endParaRPr lang="en-US" dirty="0"/>
           </a:p>
         </p:txBody>
       </p:sp>
@@ -1132,7 +906,6 @@
               <a:rPr lang="en-US" dirty="0"/>
               <a:t>El análisis se hizo solo con el conjunto de entrenamiento (202,944 registros). La prediabetes casi siempre queda en un punto intermedio, más cerca de la diabetes: anticipa que será la clase más difícil, por eso reportamos el recall de cada clase además del F1 macro.</a:t>
             </a:r>
-            <a:endParaRPr lang="en-US" dirty="0"/>
           </a:p>
         </p:txBody>
       </p:sp>
@@ -1220,7 +993,6 @@
               <a:rPr lang="en-US" dirty="0"/>
               <a:t>Los atípicos de MentHlth y PhysHlth según el rango intercuartílico son respuestas válidas: la mayoría responde 0 días. Los árboles no necesitan escalar porque solo usan umbrales.</a:t>
             </a:r>
-            <a:endParaRPr lang="en-US" dirty="0"/>
           </a:p>
         </p:txBody>
       </p:sp>
@@ -1308,7 +1080,6 @@
               <a:rPr lang="en-US" dirty="0"/>
               <a:t>La búsqueda de la logística probó C en 0.01, 0.1, 1 y 10, con y sin pesos; C casi no importa con 200 mil registros. El árbol se controla con profundidad, mínimo para dividir, mínimo por hoja, criterio y pesos de clase. Variables más importantes del árbol: presión alta, IMC, salud general y edad.</a:t>
             </a:r>
-            <a:endParaRPr lang="en-US" dirty="0"/>
           </a:p>
         </p:txBody>
       </p:sp>
@@ -1396,7 +1167,6 @@
               <a:rPr lang="en-US" dirty="0"/>
               <a:t>Random forest: 100 árboles, profundidad 20, hojas de 10, max_features 0.5, pesos balanced_subsample. Gradient boosting: HistGradientBoosting, learning rate 0.05, 63 hojas, parada temprana en 65 árboles con un 10% interno de validación. La desviación del F1 entre particiones es de 0.002, así que la ventaja del random forest sobre la logística (0.012) no es ruido.</a:t>
             </a:r>
-            <a:endParaRPr lang="en-US" dirty="0"/>
           </a:p>
         </p:txBody>
       </p:sp>
@@ -1484,7 +1254,6 @@
               <a:rPr lang="en-US" dirty="0"/>
               <a:t>Diagnóstico de sobreajuste: la brecha es F1 de entrenamiento menos F1 de validación. En el árbol, el F1 de validación se estanca desde profundidad 15 mientras el de entrenamiento sigue subiendo. En el random forest la brecha es esperada por la profundidad de sus árboles, y lo que importa es que validación y prueba coinciden.</a:t>
             </a:r>
-            <a:endParaRPr lang="en-US" dirty="0"/>
           </a:p>
         </p:txBody>
       </p:sp>
@@ -1572,7 +1341,6 @@
               <a:rPr lang="en-US" dirty="0"/>
               <a:t>Elegimos el modelo con la regla de la propuesta (mayor F1 macro) antes de ver la prueba, y la prueba se usó una sola vez. De las 14,726 personas marcadas como diabetes, el 34% la tiene y el 37% tiene diabetes o prediabetes. Como filtro para recomendar una prueba médica, es preferible una prueba de más que dejar pasar a alguien con diabetes.</a:t>
             </a:r>
-            <a:endParaRPr lang="en-US" dirty="0"/>
           </a:p>
         </p:txBody>
       </p:sp>
@@ -1645,6 +1413,11 @@
 <file path=ppt/slideMasters/slideMaster1.xml><?xml version="1.0" encoding="utf-8"?>
 <p:sldMaster xmlns:a="http://schemas.openxmlformats.org/drawingml/2006/main" xmlns:r="http://schemas.openxmlformats.org/officeDocument/2006/relationships" xmlns:p="http://schemas.openxmlformats.org/presentationml/2006/main">
   <p:cSld>
+    <p:bg>
+      <p:bgRef idx="1001">
+        <a:schemeClr val="bg1"/>
+      </p:bgRef>
+    </p:bg>
     <p:spTree>
       <p:nvGrpSpPr>
         <p:cNvPr id="1" name=""/>
@@ -1927,6 +1700,7 @@
         <a:solidFill>
           <a:srgbClr val="0E4D45"/>
         </a:solidFill>
+        <a:effectLst/>
       </p:bgPr>
     </p:bg>
     <p:spTree>
@@ -1962,6 +1736,13 @@
           </a:solidFill>
           <a:ln/>
         </p:spPr>
+        <p:txBody>
+          <a:bodyPr/>
+          <a:lstStyle/>
+          <a:p>
+            <a:endParaRPr lang="en-US"/>
+          </a:p>
+        </p:txBody>
       </p:sp>
       <p:sp>
         <p:nvSpPr>
@@ -1982,6 +1763,13 @@
           </a:solidFill>
           <a:ln/>
         </p:spPr>
+        <p:txBody>
+          <a:bodyPr/>
+          <a:lstStyle/>
+          <a:p>
+            <a:endParaRPr lang="en-US"/>
+          </a:p>
+        </p:txBody>
       </p:sp>
       <p:sp>
         <p:nvSpPr>
@@ -2004,11 +1792,11 @@
           <a:bodyPr wrap="square" lIns="0" tIns="0" rIns="0" bIns="0" rtlCol="0" anchor="ctr"/>
           <a:lstStyle/>
           <a:p>
-            <a:pPr indent="0" marL="0">
-              <a:buNone/>
-            </a:pPr>
-            <a:r>
-              <a:rPr lang="en-US" sz="1300" b="1" spc="200" kern="0" dirty="0">
+            <a:pPr marL="0" indent="0">
+              <a:buNone/>
+            </a:pPr>
+            <a:r>
+              <a:rPr lang="en-US" sz="1300" b="1" kern="0" spc="200" dirty="0">
                 <a:solidFill>
                   <a:srgbClr val="A8D08D"/>
                 </a:solidFill>
@@ -2043,7 +1831,7 @@
           <a:bodyPr wrap="square" lIns="0" tIns="0" rIns="0" bIns="0" rtlCol="0" anchor="ctr"/>
           <a:lstStyle/>
           <a:p>
-            <a:pPr indent="0" marL="0">
+            <a:pPr marL="0" indent="0">
               <a:lnSpc>
                 <a:spcPts val="4400"/>
               </a:lnSpc>
@@ -2085,7 +1873,7 @@
           <a:bodyPr wrap="square" lIns="0" tIns="0" rIns="0" bIns="0" rtlCol="0" anchor="ctr"/>
           <a:lstStyle/>
           <a:p>
-            <a:pPr indent="0" marL="0">
+            <a:pPr marL="0" indent="0">
               <a:buNone/>
             </a:pPr>
             <a:r>
@@ -2124,7 +1912,7 @@
           <a:bodyPr wrap="square" lIns="0" tIns="0" rIns="0" bIns="0" rtlCol="0" anchor="ctr"/>
           <a:lstStyle/>
           <a:p>
-            <a:pPr indent="0" marL="0">
+            <a:pPr marL="0" indent="0">
               <a:buNone/>
             </a:pPr>
             <a:r>
@@ -2163,7 +1951,7 @@
           <a:bodyPr wrap="square" lIns="0" tIns="0" rIns="0" bIns="0" rtlCol="0" anchor="ctr"/>
           <a:lstStyle/>
           <a:p>
-            <a:pPr indent="0" marL="0">
+            <a:pPr marL="0" indent="0">
               <a:buNone/>
             </a:pPr>
             <a:r>
@@ -2202,7 +1990,7 @@
           <a:bodyPr wrap="square" lIns="0" tIns="0" rIns="0" bIns="0" rtlCol="0" anchor="ctr"/>
           <a:lstStyle/>
           <a:p>
-            <a:pPr indent="0" marL="0">
+            <a:pPr marL="0" indent="0">
               <a:buNone/>
             </a:pPr>
             <a:r>
@@ -2264,6 +2052,13 @@
           </a:solidFill>
           <a:ln/>
         </p:spPr>
+        <p:txBody>
+          <a:bodyPr/>
+          <a:lstStyle/>
+          <a:p>
+            <a:endParaRPr lang="en-US"/>
+          </a:p>
+        </p:txBody>
       </p:sp>
       <p:sp>
         <p:nvSpPr>
@@ -2286,7 +2081,7 @@
           <a:bodyPr wrap="square" lIns="0" tIns="0" rIns="0" bIns="0" rtlCol="0" anchor="ctr"/>
           <a:lstStyle/>
           <a:p>
-            <a:pPr algn="ctr" indent="0" marL="0">
+            <a:pPr marL="0" indent="0" algn="ctr">
               <a:buNone/>
             </a:pPr>
             <a:r>
@@ -2325,11 +2120,11 @@
           <a:bodyPr wrap="square" lIns="0" tIns="0" rIns="0" bIns="0" rtlCol="0" anchor="ctr"/>
           <a:lstStyle/>
           <a:p>
-            <a:pPr indent="0" marL="0">
-              <a:buNone/>
-            </a:pPr>
-            <a:r>
-              <a:rPr lang="en-US" sz="1100" b="1" spc="140" kern="0" dirty="0">
+            <a:pPr marL="0" indent="0">
+              <a:buNone/>
+            </a:pPr>
+            <a:r>
+              <a:rPr lang="en-US" sz="1100" b="1" kern="0" spc="140" dirty="0">
                 <a:solidFill>
                   <a:srgbClr val="3F8A26"/>
                 </a:solidFill>
@@ -2364,7 +2159,7 @@
           <a:bodyPr wrap="square" lIns="0" tIns="0" rIns="0" bIns="0" rtlCol="0" anchor="t"/>
           <a:lstStyle/>
           <a:p>
-            <a:pPr indent="0" marL="0">
+            <a:pPr marL="0" indent="0">
               <a:buNone/>
             </a:pPr>
             <a:r>
@@ -2408,6 +2203,13 @@
             <a:prstDash val="solid"/>
           </a:ln>
         </p:spPr>
+        <p:txBody>
+          <a:bodyPr/>
+          <a:lstStyle/>
+          <a:p>
+            <a:endParaRPr lang="en-US"/>
+          </a:p>
+        </p:txBody>
       </p:sp>
       <p:sp>
         <p:nvSpPr>
@@ -2430,7 +2232,7 @@
           <a:bodyPr wrap="square" lIns="0" tIns="0" rIns="0" bIns="0" rtlCol="0" anchor="ctr"/>
           <a:lstStyle/>
           <a:p>
-            <a:pPr indent="0" marL="0">
+            <a:pPr marL="0" indent="0">
               <a:buNone/>
             </a:pPr>
             <a:r>
@@ -2559,6 +2361,13 @@
             <a:prstDash val="solid"/>
           </a:ln>
         </p:spPr>
+        <p:txBody>
+          <a:bodyPr/>
+          <a:lstStyle/>
+          <a:p>
+            <a:endParaRPr lang="en-US"/>
+          </a:p>
+        </p:txBody>
       </p:sp>
       <p:sp>
         <p:nvSpPr>
@@ -2581,7 +2390,7 @@
           <a:bodyPr wrap="square" lIns="0" tIns="0" rIns="0" bIns="0" rtlCol="0" anchor="ctr"/>
           <a:lstStyle/>
           <a:p>
-            <a:pPr indent="0" marL="0">
+            <a:pPr marL="0" indent="0">
               <a:buNone/>
             </a:pPr>
             <a:r>
@@ -2689,6 +2498,13 @@
             <a:prstDash val="solid"/>
           </a:ln>
         </p:spPr>
+        <p:txBody>
+          <a:bodyPr/>
+          <a:lstStyle/>
+          <a:p>
+            <a:endParaRPr lang="en-US"/>
+          </a:p>
+        </p:txBody>
       </p:sp>
       <p:sp>
         <p:nvSpPr>
@@ -2711,7 +2527,7 @@
           <a:bodyPr wrap="square" lIns="0" tIns="0" rIns="0" bIns="0" rtlCol="0" anchor="ctr"/>
           <a:lstStyle/>
           <a:p>
-            <a:pPr indent="0" marL="0">
+            <a:pPr marL="0" indent="0">
               <a:buNone/>
             </a:pPr>
             <a:r>
@@ -2814,7 +2630,7 @@
           <a:bodyPr wrap="square" lIns="0" tIns="0" rIns="0" bIns="0" rtlCol="0" anchor="ctr"/>
           <a:lstStyle/>
           <a:p>
-            <a:pPr algn="r" indent="0" marL="0">
+            <a:pPr marL="0" indent="0" algn="r">
               <a:buNone/>
             </a:pPr>
             <a:r>
@@ -2876,6 +2692,13 @@
           </a:solidFill>
           <a:ln/>
         </p:spPr>
+        <p:txBody>
+          <a:bodyPr/>
+          <a:lstStyle/>
+          <a:p>
+            <a:endParaRPr lang="en-US"/>
+          </a:p>
+        </p:txBody>
       </p:sp>
       <p:sp>
         <p:nvSpPr>
@@ -2898,7 +2721,7 @@
           <a:bodyPr wrap="square" lIns="0" tIns="0" rIns="0" bIns="0" rtlCol="0" anchor="ctr"/>
           <a:lstStyle/>
           <a:p>
-            <a:pPr algn="ctr" indent="0" marL="0">
+            <a:pPr marL="0" indent="0" algn="ctr">
               <a:buNone/>
             </a:pPr>
             <a:r>
@@ -2937,11 +2760,11 @@
           <a:bodyPr wrap="square" lIns="0" tIns="0" rIns="0" bIns="0" rtlCol="0" anchor="ctr"/>
           <a:lstStyle/>
           <a:p>
-            <a:pPr indent="0" marL="0">
-              <a:buNone/>
-            </a:pPr>
-            <a:r>
-              <a:rPr lang="en-US" sz="1100" b="1" spc="140" kern="0" dirty="0">
+            <a:pPr marL="0" indent="0">
+              <a:buNone/>
+            </a:pPr>
+            <a:r>
+              <a:rPr lang="en-US" sz="1100" b="1" kern="0" spc="140" dirty="0">
                 <a:solidFill>
                   <a:srgbClr val="3F8A26"/>
                 </a:solidFill>
@@ -2976,7 +2799,7 @@
           <a:bodyPr wrap="square" lIns="0" tIns="0" rIns="0" bIns="0" rtlCol="0" anchor="t"/>
           <a:lstStyle/>
           <a:p>
-            <a:pPr indent="0" marL="0">
+            <a:pPr marL="0" indent="0">
               <a:buNone/>
             </a:pPr>
             <a:r>
@@ -3020,6 +2843,13 @@
             <a:prstDash val="solid"/>
           </a:ln>
         </p:spPr>
+        <p:txBody>
+          <a:bodyPr/>
+          <a:lstStyle/>
+          <a:p>
+            <a:endParaRPr lang="en-US"/>
+          </a:p>
+        </p:txBody>
       </p:sp>
       <p:sp>
         <p:nvSpPr>
@@ -3042,7 +2872,7 @@
           <a:bodyPr wrap="square" lIns="0" tIns="0" rIns="0" bIns="0" rtlCol="0" anchor="ctr"/>
           <a:lstStyle/>
           <a:p>
-            <a:pPr indent="0" marL="0">
+            <a:pPr marL="0" indent="0">
               <a:buNone/>
             </a:pPr>
             <a:r>
@@ -3171,6 +3001,13 @@
             <a:prstDash val="solid"/>
           </a:ln>
         </p:spPr>
+        <p:txBody>
+          <a:bodyPr/>
+          <a:lstStyle/>
+          <a:p>
+            <a:endParaRPr lang="en-US"/>
+          </a:p>
+        </p:txBody>
       </p:sp>
       <p:sp>
         <p:nvSpPr>
@@ -3193,7 +3030,7 @@
           <a:bodyPr wrap="square" lIns="0" tIns="0" rIns="0" bIns="0" rtlCol="0" anchor="ctr"/>
           <a:lstStyle/>
           <a:p>
-            <a:pPr indent="0" marL="0">
+            <a:pPr marL="0" indent="0">
               <a:buNone/>
             </a:pPr>
             <a:r>
@@ -3338,7 +3175,7 @@
           <a:bodyPr wrap="square" lIns="0" tIns="0" rIns="0" bIns="0" rtlCol="0" anchor="ctr"/>
           <a:lstStyle/>
           <a:p>
-            <a:pPr algn="r" indent="0" marL="0">
+            <a:pPr marL="0" indent="0" algn="r">
               <a:buNone/>
             </a:pPr>
             <a:r>
@@ -3400,6 +3237,13 @@
           </a:solidFill>
           <a:ln/>
         </p:spPr>
+        <p:txBody>
+          <a:bodyPr/>
+          <a:lstStyle/>
+          <a:p>
+            <a:endParaRPr lang="en-US"/>
+          </a:p>
+        </p:txBody>
       </p:sp>
       <p:sp>
         <p:nvSpPr>
@@ -3422,7 +3266,7 @@
           <a:bodyPr wrap="square" lIns="0" tIns="0" rIns="0" bIns="0" rtlCol="0" anchor="ctr"/>
           <a:lstStyle/>
           <a:p>
-            <a:pPr algn="ctr" indent="0" marL="0">
+            <a:pPr marL="0" indent="0" algn="ctr">
               <a:buNone/>
             </a:pPr>
             <a:r>
@@ -3461,11 +3305,11 @@
           <a:bodyPr wrap="square" lIns="0" tIns="0" rIns="0" bIns="0" rtlCol="0" anchor="ctr"/>
           <a:lstStyle/>
           <a:p>
-            <a:pPr indent="0" marL="0">
-              <a:buNone/>
-            </a:pPr>
-            <a:r>
-              <a:rPr lang="en-US" sz="1100" b="1" spc="140" kern="0" dirty="0">
+            <a:pPr marL="0" indent="0">
+              <a:buNone/>
+            </a:pPr>
+            <a:r>
+              <a:rPr lang="en-US" sz="1100" b="1" kern="0" spc="140" dirty="0">
                 <a:solidFill>
                   <a:srgbClr val="3F8A26"/>
                 </a:solidFill>
@@ -3500,7 +3344,7 @@
           <a:bodyPr wrap="square" lIns="0" tIns="0" rIns="0" bIns="0" rtlCol="0" anchor="t"/>
           <a:lstStyle/>
           <a:p>
-            <a:pPr indent="0" marL="0">
+            <a:pPr marL="0" indent="0">
               <a:buNone/>
             </a:pPr>
             <a:r>
@@ -3544,6 +3388,13 @@
             <a:prstDash val="solid"/>
           </a:ln>
         </p:spPr>
+        <p:txBody>
+          <a:bodyPr/>
+          <a:lstStyle/>
+          <a:p>
+            <a:endParaRPr lang="en-US"/>
+          </a:p>
+        </p:txBody>
       </p:sp>
       <p:sp>
         <p:nvSpPr>
@@ -3566,7 +3417,7 @@
           <a:bodyPr wrap="square" lIns="0" tIns="0" rIns="0" bIns="0" rtlCol="0" anchor="ctr"/>
           <a:lstStyle/>
           <a:p>
-            <a:pPr indent="0" marL="0">
+            <a:pPr marL="0" indent="0">
               <a:buNone/>
             </a:pPr>
             <a:r>
@@ -3674,6 +3525,13 @@
             <a:prstDash val="solid"/>
           </a:ln>
         </p:spPr>
+        <p:txBody>
+          <a:bodyPr/>
+          <a:lstStyle/>
+          <a:p>
+            <a:endParaRPr lang="en-US"/>
+          </a:p>
+        </p:txBody>
       </p:sp>
       <p:sp>
         <p:nvSpPr>
@@ -3696,7 +3554,7 @@
           <a:bodyPr wrap="square" lIns="0" tIns="0" rIns="0" bIns="0" rtlCol="0" anchor="ctr"/>
           <a:lstStyle/>
           <a:p>
-            <a:pPr indent="0" marL="0">
+            <a:pPr marL="0" indent="0">
               <a:buNone/>
             </a:pPr>
             <a:r>
@@ -3825,6 +3683,13 @@
             <a:prstDash val="solid"/>
           </a:ln>
         </p:spPr>
+        <p:txBody>
+          <a:bodyPr/>
+          <a:lstStyle/>
+          <a:p>
+            <a:endParaRPr lang="en-US"/>
+          </a:p>
+        </p:txBody>
       </p:sp>
       <p:sp>
         <p:nvSpPr>
@@ -3847,7 +3712,7 @@
           <a:bodyPr wrap="square" lIns="0" tIns="0" rIns="0" bIns="0" rtlCol="0" anchor="ctr"/>
           <a:lstStyle/>
           <a:p>
-            <a:pPr indent="0" marL="0">
+            <a:pPr marL="0" indent="0">
               <a:buNone/>
             </a:pPr>
             <a:r>
@@ -3971,7 +3836,7 @@
           <a:bodyPr wrap="square" lIns="0" tIns="0" rIns="0" bIns="0" rtlCol="0" anchor="ctr"/>
           <a:lstStyle/>
           <a:p>
-            <a:pPr algn="r" indent="0" marL="0">
+            <a:pPr marL="0" indent="0" algn="r">
               <a:buNone/>
             </a:pPr>
             <a:r>
@@ -4033,6 +3898,13 @@
           </a:solidFill>
           <a:ln/>
         </p:spPr>
+        <p:txBody>
+          <a:bodyPr/>
+          <a:lstStyle/>
+          <a:p>
+            <a:endParaRPr lang="en-US"/>
+          </a:p>
+        </p:txBody>
       </p:sp>
       <p:sp>
         <p:nvSpPr>
@@ -4055,7 +3927,7 @@
           <a:bodyPr wrap="square" lIns="0" tIns="0" rIns="0" bIns="0" rtlCol="0" anchor="ctr"/>
           <a:lstStyle/>
           <a:p>
-            <a:pPr algn="ctr" indent="0" marL="0">
+            <a:pPr marL="0" indent="0" algn="ctr">
               <a:buNone/>
             </a:pPr>
             <a:r>
@@ -4094,11 +3966,11 @@
           <a:bodyPr wrap="square" lIns="0" tIns="0" rIns="0" bIns="0" rtlCol="0" anchor="ctr"/>
           <a:lstStyle/>
           <a:p>
-            <a:pPr indent="0" marL="0">
-              <a:buNone/>
-            </a:pPr>
-            <a:r>
-              <a:rPr lang="en-US" sz="1100" b="1" spc="140" kern="0" dirty="0">
+            <a:pPr marL="0" indent="0">
+              <a:buNone/>
+            </a:pPr>
+            <a:r>
+              <a:rPr lang="en-US" sz="1100" b="1" kern="0" spc="140" dirty="0">
                 <a:solidFill>
                   <a:srgbClr val="3F8A26"/>
                 </a:solidFill>
@@ -4133,7 +4005,7 @@
           <a:bodyPr wrap="square" lIns="0" tIns="0" rIns="0" bIns="0" rtlCol="0" anchor="t"/>
           <a:lstStyle/>
           <a:p>
-            <a:pPr indent="0" marL="0">
+            <a:pPr marL="0" indent="0">
               <a:buNone/>
             </a:pPr>
             <a:r>
@@ -4177,6 +4049,13 @@
             <a:prstDash val="solid"/>
           </a:ln>
         </p:spPr>
+        <p:txBody>
+          <a:bodyPr/>
+          <a:lstStyle/>
+          <a:p>
+            <a:endParaRPr lang="en-US"/>
+          </a:p>
+        </p:txBody>
       </p:sp>
       <p:sp>
         <p:nvSpPr>
@@ -4199,7 +4078,7 @@
           <a:bodyPr wrap="square" lIns="0" tIns="0" rIns="0" bIns="0" rtlCol="0" anchor="ctr"/>
           <a:lstStyle/>
           <a:p>
-            <a:pPr indent="0" marL="0">
+            <a:pPr marL="0" indent="0">
               <a:buNone/>
             </a:pPr>
             <a:r>
@@ -4310,7 +4189,7 @@
         </p:nvSpPr>
         <p:spPr>
           <a:xfrm>
-            <a:off x="548640" y="4123944"/>
+            <a:off x="3403092" y="4134767"/>
             <a:ext cx="5385816" cy="2048256"/>
           </a:xfrm>
           <a:prstGeom prst="roundRect">
@@ -4328,6 +4207,13 @@
             <a:prstDash val="solid"/>
           </a:ln>
         </p:spPr>
+        <p:txBody>
+          <a:bodyPr/>
+          <a:lstStyle/>
+          <a:p>
+            <a:endParaRPr lang="en-US"/>
+          </a:p>
+        </p:txBody>
       </p:sp>
       <p:sp>
         <p:nvSpPr>
@@ -4337,7 +4223,7 @@
         </p:nvSpPr>
         <p:spPr>
           <a:xfrm>
-            <a:off x="804672" y="4325112"/>
+            <a:off x="3659124" y="4335935"/>
             <a:ext cx="4873752" cy="347472"/>
           </a:xfrm>
           <a:prstGeom prst="rect">
@@ -4350,7 +4236,7 @@
           <a:bodyPr wrap="square" lIns="0" tIns="0" rIns="0" bIns="0" rtlCol="0" anchor="ctr"/>
           <a:lstStyle/>
           <a:p>
-            <a:pPr indent="0" marL="0">
+            <a:pPr marL="0" indent="0">
               <a:buNone/>
             </a:pPr>
             <a:r>
@@ -4376,7 +4262,7 @@
         </p:nvSpPr>
         <p:spPr>
           <a:xfrm>
-            <a:off x="804672" y="4727448"/>
+            <a:off x="3659124" y="4738271"/>
             <a:ext cx="4873752" cy="1225296"/>
           </a:xfrm>
           <a:prstGeom prst="rect">
@@ -4434,111 +4320,6 @@
       </p:sp>
       <p:sp>
         <p:nvSpPr>
-          <p:cNvPr id="12" name="Shape 10"/>
-          <p:cNvSpPr/>
-          <p:nvPr/>
-        </p:nvSpPr>
-        <p:spPr>
-          <a:xfrm>
-            <a:off x="6227064" y="4123944"/>
-            <a:ext cx="5385816" cy="2048256"/>
-          </a:xfrm>
-          <a:prstGeom prst="roundRect">
-            <a:avLst>
-              <a:gd name="adj" fmla="val 2232"/>
-            </a:avLst>
-          </a:prstGeom>
-          <a:solidFill>
-            <a:srgbClr val="EEF4EF"/>
-          </a:solidFill>
-          <a:ln w="9525">
-            <a:solidFill>
-              <a:srgbClr val="D4E2D6"/>
-            </a:solidFill>
-            <a:prstDash val="solid"/>
-          </a:ln>
-        </p:spPr>
-      </p:sp>
-      <p:sp>
-        <p:nvSpPr>
-          <p:cNvPr id="13" name="Text 11"/>
-          <p:cNvSpPr/>
-          <p:nvPr/>
-        </p:nvSpPr>
-        <p:spPr>
-          <a:xfrm>
-            <a:off x="6483096" y="4325112"/>
-            <a:ext cx="4873752" cy="347472"/>
-          </a:xfrm>
-          <a:prstGeom prst="rect">
-            <a:avLst/>
-          </a:prstGeom>
-          <a:noFill/>
-          <a:ln/>
-        </p:spPr>
-        <p:txBody>
-          <a:bodyPr wrap="square" lIns="0" tIns="0" rIns="0" bIns="0" rtlCol="0" anchor="ctr"/>
-          <a:lstStyle/>
-          <a:p>
-            <a:pPr indent="0" marL="0">
-              <a:buNone/>
-            </a:pPr>
-            <a:r>
-              <a:rPr lang="en-US" sz="1300" b="1" dirty="0">
-                <a:solidFill>
-                  <a:srgbClr val="3F8A26"/>
-                </a:solidFill>
-                <a:latin typeface="Calibri" pitchFamily="34" charset="0"/>
-                <a:ea typeface="Calibri" pitchFamily="34" charset="-122"/>
-                <a:cs typeface="Calibri" pitchFamily="34" charset="-120"/>
-              </a:rPr>
-              <a:t>Uso de IA</a:t>
-            </a:r>
-            <a:endParaRPr lang="en-US" sz="1300" dirty="0"/>
-          </a:p>
-        </p:txBody>
-      </p:sp>
-      <p:sp>
-        <p:nvSpPr>
-          <p:cNvPr id="14" name="Text 12"/>
-          <p:cNvSpPr/>
-          <p:nvPr/>
-        </p:nvSpPr>
-        <p:spPr>
-          <a:xfrm>
-            <a:off x="6483096" y="4727448"/>
-            <a:ext cx="4873752" cy="1225296"/>
-          </a:xfrm>
-          <a:prstGeom prst="rect">
-            <a:avLst/>
-          </a:prstGeom>
-          <a:noFill/>
-          <a:ln/>
-        </p:spPr>
-        <p:txBody>
-          <a:bodyPr wrap="square" lIns="0" tIns="0" rIns="0" bIns="0" rtlCol="0" anchor="t"/>
-          <a:lstStyle/>
-          <a:p>
-            <a:pPr indent="0" marL="0">
-              <a:buNone/>
-            </a:pPr>
-            <a:r>
-              <a:rPr lang="en-US" sz="1200" dirty="0">
-                <a:solidFill>
-                  <a:srgbClr val="1E2A28"/>
-                </a:solidFill>
-                <a:latin typeface="Calibri" pitchFamily="34" charset="0"/>
-                <a:ea typeface="Calibri" pitchFamily="34" charset="-122"/>
-                <a:cs typeface="Calibri" pitchFamily="34" charset="-120"/>
-              </a:rPr>
-              <a:t>Usamos Claude Code como apoyo para escribir y depurar código y para el borrador del informe y la presentación. Revisamos, ejecutamos y verificamos todo a mano.</a:t>
-            </a:r>
-            <a:endParaRPr lang="en-US" sz="1200" dirty="0"/>
-          </a:p>
-        </p:txBody>
-      </p:sp>
-      <p:sp>
-        <p:nvSpPr>
           <p:cNvPr id="16" name="Text 13"/>
           <p:cNvSpPr/>
           <p:nvPr/>
@@ -4558,7 +4339,7 @@
           <a:bodyPr wrap="square" lIns="0" tIns="0" rIns="0" bIns="0" rtlCol="0" anchor="ctr"/>
           <a:lstStyle/>
           <a:p>
-            <a:pPr algn="r" indent="0" marL="0">
+            <a:pPr marL="0" indent="0" algn="r">
               <a:buNone/>
             </a:pPr>
             <a:r>
@@ -4573,6 +4354,38 @@
               <a:t>13</a:t>
             </a:r>
             <a:endParaRPr lang="en-US" sz="1000" dirty="0"/>
+          </a:p>
+        </p:txBody>
+      </p:sp>
+      <p:sp>
+        <p:nvSpPr>
+          <p:cNvPr id="15" name="TextBox 14">
+            <a:extLst>
+              <a:ext uri="{FF2B5EF4-FFF2-40B4-BE49-F238E27FC236}">
+                <a16:creationId xmlns:a16="http://schemas.microsoft.com/office/drawing/2014/main" id="{EBC31374-5D14-F461-251D-6583939C312F}"/>
+              </a:ext>
+            </a:extLst>
+          </p:cNvPr>
+          <p:cNvSpPr txBox="1"/>
+          <p:nvPr/>
+        </p:nvSpPr>
+        <p:spPr>
+          <a:xfrm>
+            <a:off x="6600497" y="5759669"/>
+            <a:ext cx="184731" cy="369332"/>
+          </a:xfrm>
+          <a:prstGeom prst="rect">
+            <a:avLst/>
+          </a:prstGeom>
+          <a:noFill/>
+        </p:spPr>
+        <p:txBody>
+          <a:bodyPr wrap="none" rtlCol="0">
+            <a:spAutoFit/>
+          </a:bodyPr>
+          <a:lstStyle/>
+          <a:p>
+            <a:endParaRPr lang="en-US" dirty="0"/>
           </a:p>
         </p:txBody>
       </p:sp>
@@ -4620,6 +4433,13 @@
           </a:solidFill>
           <a:ln/>
         </p:spPr>
+        <p:txBody>
+          <a:bodyPr/>
+          <a:lstStyle/>
+          <a:p>
+            <a:endParaRPr lang="en-US"/>
+          </a:p>
+        </p:txBody>
       </p:sp>
       <p:sp>
         <p:nvSpPr>
@@ -4642,7 +4462,7 @@
           <a:bodyPr wrap="square" lIns="0" tIns="0" rIns="0" bIns="0" rtlCol="0" anchor="ctr"/>
           <a:lstStyle/>
           <a:p>
-            <a:pPr algn="ctr" indent="0" marL="0">
+            <a:pPr marL="0" indent="0" algn="ctr">
               <a:buNone/>
             </a:pPr>
             <a:r>
@@ -4681,11 +4501,11 @@
           <a:bodyPr wrap="square" lIns="0" tIns="0" rIns="0" bIns="0" rtlCol="0" anchor="ctr"/>
           <a:lstStyle/>
           <a:p>
-            <a:pPr indent="0" marL="0">
-              <a:buNone/>
-            </a:pPr>
-            <a:r>
-              <a:rPr lang="en-US" sz="1100" b="1" spc="140" kern="0" dirty="0">
+            <a:pPr marL="0" indent="0">
+              <a:buNone/>
+            </a:pPr>
+            <a:r>
+              <a:rPr lang="en-US" sz="1100" b="1" kern="0" spc="140" dirty="0">
                 <a:solidFill>
                   <a:srgbClr val="3F8A26"/>
                 </a:solidFill>
@@ -4720,7 +4540,7 @@
           <a:bodyPr wrap="square" lIns="0" tIns="0" rIns="0" bIns="0" rtlCol="0" anchor="t"/>
           <a:lstStyle/>
           <a:p>
-            <a:pPr indent="0" marL="0">
+            <a:pPr marL="0" indent="0">
               <a:buNone/>
             </a:pPr>
             <a:r>
@@ -4764,6 +4584,13 @@
             <a:prstDash val="solid"/>
           </a:ln>
         </p:spPr>
+        <p:txBody>
+          <a:bodyPr/>
+          <a:lstStyle/>
+          <a:p>
+            <a:endParaRPr lang="en-US"/>
+          </a:p>
+        </p:txBody>
       </p:sp>
       <p:sp>
         <p:nvSpPr>
@@ -4786,7 +4613,7 @@
           <a:bodyPr wrap="square" lIns="0" tIns="0" rIns="0" bIns="0" rtlCol="0" anchor="ctr"/>
           <a:lstStyle/>
           <a:p>
-            <a:pPr indent="0" marL="0">
+            <a:pPr marL="0" indent="0">
               <a:buNone/>
             </a:pPr>
             <a:r>
@@ -4915,6 +4742,13 @@
             <a:prstDash val="solid"/>
           </a:ln>
         </p:spPr>
+        <p:txBody>
+          <a:bodyPr/>
+          <a:lstStyle/>
+          <a:p>
+            <a:endParaRPr lang="en-US"/>
+          </a:p>
+        </p:txBody>
       </p:sp>
       <p:sp>
         <p:nvSpPr>
@@ -4937,7 +4771,7 @@
           <a:bodyPr wrap="square" lIns="0" tIns="0" rIns="0" bIns="0" rtlCol="0" anchor="ctr"/>
           <a:lstStyle/>
           <a:p>
-            <a:pPr indent="0" marL="0">
+            <a:pPr marL="0" indent="0">
               <a:buNone/>
             </a:pPr>
             <a:r>
@@ -4976,7 +4810,7 @@
           <a:bodyPr wrap="square" lIns="0" tIns="0" rIns="0" bIns="0" rtlCol="0" anchor="t"/>
           <a:lstStyle/>
           <a:p>
-            <a:pPr indent="0" marL="0">
+            <a:pPr marL="0" indent="0">
               <a:buNone/>
             </a:pPr>
             <a:r>
@@ -5020,6 +4854,13 @@
             <a:prstDash val="solid"/>
           </a:ln>
         </p:spPr>
+        <p:txBody>
+          <a:bodyPr/>
+          <a:lstStyle/>
+          <a:p>
+            <a:endParaRPr lang="en-US"/>
+          </a:p>
+        </p:txBody>
       </p:sp>
       <p:sp>
         <p:nvSpPr>
@@ -5042,7 +4883,7 @@
           <a:bodyPr wrap="square" lIns="0" tIns="0" rIns="0" bIns="0" rtlCol="0" anchor="ctr"/>
           <a:lstStyle/>
           <a:p>
-            <a:pPr indent="0" marL="0">
+            <a:pPr marL="0" indent="0">
               <a:buNone/>
             </a:pPr>
             <a:r>
@@ -5081,7 +4922,7 @@
           <a:bodyPr wrap="square" lIns="0" tIns="0" rIns="0" bIns="0" rtlCol="0" anchor="t"/>
           <a:lstStyle/>
           <a:p>
-            <a:pPr indent="0" marL="0">
+            <a:pPr marL="0" indent="0">
               <a:buNone/>
             </a:pPr>
             <a:r>
@@ -5120,7 +4961,7 @@
           <a:bodyPr wrap="square" lIns="0" tIns="0" rIns="0" bIns="0" rtlCol="0" anchor="ctr"/>
           <a:lstStyle/>
           <a:p>
-            <a:pPr algn="r" indent="0" marL="0">
+            <a:pPr marL="0" indent="0" algn="r">
               <a:buNone/>
             </a:pPr>
             <a:r>
@@ -5182,6 +5023,13 @@
           </a:solidFill>
           <a:ln/>
         </p:spPr>
+        <p:txBody>
+          <a:bodyPr/>
+          <a:lstStyle/>
+          <a:p>
+            <a:endParaRPr lang="en-US"/>
+          </a:p>
+        </p:txBody>
       </p:sp>
       <p:sp>
         <p:nvSpPr>
@@ -5204,7 +5052,7 @@
           <a:bodyPr wrap="square" lIns="0" tIns="0" rIns="0" bIns="0" rtlCol="0" anchor="ctr"/>
           <a:lstStyle/>
           <a:p>
-            <a:pPr algn="ctr" indent="0" marL="0">
+            <a:pPr marL="0" indent="0" algn="ctr">
               <a:buNone/>
             </a:pPr>
             <a:r>
@@ -5243,11 +5091,11 @@
           <a:bodyPr wrap="square" lIns="0" tIns="0" rIns="0" bIns="0" rtlCol="0" anchor="ctr"/>
           <a:lstStyle/>
           <a:p>
-            <a:pPr indent="0" marL="0">
-              <a:buNone/>
-            </a:pPr>
-            <a:r>
-              <a:rPr lang="en-US" sz="1100" b="1" spc="140" kern="0" dirty="0">
+            <a:pPr marL="0" indent="0">
+              <a:buNone/>
+            </a:pPr>
+            <a:r>
+              <a:rPr lang="en-US" sz="1100" b="1" kern="0" spc="140" dirty="0">
                 <a:solidFill>
                   <a:srgbClr val="3F8A26"/>
                 </a:solidFill>
@@ -5282,7 +5130,7 @@
           <a:bodyPr wrap="square" lIns="0" tIns="0" rIns="0" bIns="0" rtlCol="0" anchor="t"/>
           <a:lstStyle/>
           <a:p>
-            <a:pPr indent="0" marL="0">
+            <a:pPr marL="0" indent="0">
               <a:buNone/>
             </a:pPr>
             <a:r>
@@ -5302,14 +5150,14 @@
       </p:sp>
       <p:pic>
         <p:nvPicPr>
-          <p:cNvPr id="6" name="Image 0" descr="/private/tmp/claude-501/-Users-fabianprado-Documents-projects-2026---2--ai-proyecto2/d453a1b3-ccc3-45e2-95e4-06fb0c8b1ac2/scratchpad/figs/eda_objetivo.png">    </p:cNvPr>
+          <p:cNvPr id="6" name="Image 0" descr="/private/tmp/claude-501/-Users-fabianprado-Documents-projects-2026---2--ai-proyecto2/d453a1b3-ccc3-45e2-95e4-06fb0c8b1ac2/scratchpad/figs/eda_objetivo.png"/>
           <p:cNvPicPr>
             <a:picLocks noChangeAspect="1"/>
           </p:cNvPicPr>
           <p:nvPr/>
         </p:nvPicPr>
         <p:blipFill>
-          <a:blip r:embed="rId1"/>
+          <a:blip r:embed="rId3"/>
           <a:stretch>
             <a:fillRect/>
           </a:stretch>
@@ -5350,6 +5198,13 @@
             <a:prstDash val="solid"/>
           </a:ln>
         </p:spPr>
+        <p:txBody>
+          <a:bodyPr/>
+          <a:lstStyle/>
+          <a:p>
+            <a:endParaRPr lang="en-US"/>
+          </a:p>
+        </p:txBody>
       </p:sp>
       <p:sp>
         <p:nvSpPr>
@@ -5372,7 +5227,7 @@
           <a:bodyPr wrap="square" lIns="0" tIns="0" rIns="0" bIns="0" rtlCol="0" anchor="ctr"/>
           <a:lstStyle/>
           <a:p>
-            <a:pPr indent="0" marL="0">
+            <a:pPr marL="0" indent="0">
               <a:buNone/>
             </a:pPr>
             <a:r>
@@ -5538,7 +5393,7 @@
           <a:bodyPr wrap="square" lIns="0" tIns="0" rIns="0" bIns="0" rtlCol="0" anchor="ctr"/>
           <a:lstStyle/>
           <a:p>
-            <a:pPr algn="r" indent="0" marL="0">
+            <a:pPr marL="0" indent="0" algn="r">
               <a:buNone/>
             </a:pPr>
             <a:r>
@@ -5600,6 +5455,13 @@
           </a:solidFill>
           <a:ln/>
         </p:spPr>
+        <p:txBody>
+          <a:bodyPr/>
+          <a:lstStyle/>
+          <a:p>
+            <a:endParaRPr lang="en-US"/>
+          </a:p>
+        </p:txBody>
       </p:sp>
       <p:sp>
         <p:nvSpPr>
@@ -5622,7 +5484,7 @@
           <a:bodyPr wrap="square" lIns="0" tIns="0" rIns="0" bIns="0" rtlCol="0" anchor="ctr"/>
           <a:lstStyle/>
           <a:p>
-            <a:pPr algn="ctr" indent="0" marL="0">
+            <a:pPr marL="0" indent="0" algn="ctr">
               <a:buNone/>
             </a:pPr>
             <a:r>
@@ -5661,11 +5523,11 @@
           <a:bodyPr wrap="square" lIns="0" tIns="0" rIns="0" bIns="0" rtlCol="0" anchor="ctr"/>
           <a:lstStyle/>
           <a:p>
-            <a:pPr indent="0" marL="0">
-              <a:buNone/>
-            </a:pPr>
-            <a:r>
-              <a:rPr lang="en-US" sz="1100" b="1" spc="140" kern="0" dirty="0">
+            <a:pPr marL="0" indent="0">
+              <a:buNone/>
+            </a:pPr>
+            <a:r>
+              <a:rPr lang="en-US" sz="1100" b="1" kern="0" spc="140" dirty="0">
                 <a:solidFill>
                   <a:srgbClr val="3F8A26"/>
                 </a:solidFill>
@@ -5700,7 +5562,7 @@
           <a:bodyPr wrap="square" lIns="0" tIns="0" rIns="0" bIns="0" rtlCol="0" anchor="t"/>
           <a:lstStyle/>
           <a:p>
-            <a:pPr indent="0" marL="0">
+            <a:pPr marL="0" indent="0">
               <a:buNone/>
             </a:pPr>
             <a:r>
@@ -5720,14 +5582,14 @@
       </p:sp>
       <p:pic>
         <p:nvPicPr>
-          <p:cNvPr id="6" name="Image 0" descr="/private/tmp/claude-501/-Users-fabianprado-Documents-projects-2026---2--ai-proyecto2/d453a1b3-ccc3-45e2-95e4-06fb0c8b1ac2/scratchpad/figs/eda_factores.png">    </p:cNvPr>
+          <p:cNvPr id="6" name="Image 0" descr="/private/tmp/claude-501/-Users-fabianprado-Documents-projects-2026---2--ai-proyecto2/d453a1b3-ccc3-45e2-95e4-06fb0c8b1ac2/scratchpad/figs/eda_factores.png"/>
           <p:cNvPicPr>
             <a:picLocks noChangeAspect="1"/>
           </p:cNvPicPr>
           <p:nvPr/>
         </p:nvPicPr>
         <p:blipFill>
-          <a:blip r:embed="rId1"/>
+          <a:blip r:embed="rId3"/>
           <a:stretch>
             <a:fillRect/>
           </a:stretch>
@@ -5768,6 +5630,13 @@
             <a:prstDash val="solid"/>
           </a:ln>
         </p:spPr>
+        <p:txBody>
+          <a:bodyPr/>
+          <a:lstStyle/>
+          <a:p>
+            <a:endParaRPr lang="en-US"/>
+          </a:p>
+        </p:txBody>
       </p:sp>
       <p:sp>
         <p:nvSpPr>
@@ -5790,7 +5659,7 @@
           <a:bodyPr wrap="square" lIns="0" tIns="0" rIns="0" bIns="0" rtlCol="0" anchor="ctr"/>
           <a:lstStyle/>
           <a:p>
-            <a:pPr indent="0" marL="0">
+            <a:pPr marL="0" indent="0">
               <a:buNone/>
             </a:pPr>
             <a:r>
@@ -5935,7 +5804,7 @@
           <a:bodyPr wrap="square" lIns="0" tIns="0" rIns="0" bIns="0" rtlCol="0" anchor="ctr"/>
           <a:lstStyle/>
           <a:p>
-            <a:pPr algn="r" indent="0" marL="0">
+            <a:pPr marL="0" indent="0" algn="r">
               <a:buNone/>
             </a:pPr>
             <a:r>
@@ -5997,6 +5866,13 @@
           </a:solidFill>
           <a:ln/>
         </p:spPr>
+        <p:txBody>
+          <a:bodyPr/>
+          <a:lstStyle/>
+          <a:p>
+            <a:endParaRPr lang="en-US"/>
+          </a:p>
+        </p:txBody>
       </p:sp>
       <p:sp>
         <p:nvSpPr>
@@ -6019,7 +5895,7 @@
           <a:bodyPr wrap="square" lIns="0" tIns="0" rIns="0" bIns="0" rtlCol="0" anchor="ctr"/>
           <a:lstStyle/>
           <a:p>
-            <a:pPr algn="ctr" indent="0" marL="0">
+            <a:pPr marL="0" indent="0" algn="ctr">
               <a:buNone/>
             </a:pPr>
             <a:r>
@@ -6058,11 +5934,11 @@
           <a:bodyPr wrap="square" lIns="0" tIns="0" rIns="0" bIns="0" rtlCol="0" anchor="ctr"/>
           <a:lstStyle/>
           <a:p>
-            <a:pPr indent="0" marL="0">
-              <a:buNone/>
-            </a:pPr>
-            <a:r>
-              <a:rPr lang="en-US" sz="1100" b="1" spc="140" kern="0" dirty="0">
+            <a:pPr marL="0" indent="0">
+              <a:buNone/>
+            </a:pPr>
+            <a:r>
+              <a:rPr lang="en-US" sz="1100" b="1" kern="0" spc="140" dirty="0">
                 <a:solidFill>
                   <a:srgbClr val="3F8A26"/>
                 </a:solidFill>
@@ -6097,7 +5973,7 @@
           <a:bodyPr wrap="square" lIns="0" tIns="0" rIns="0" bIns="0" rtlCol="0" anchor="t"/>
           <a:lstStyle/>
           <a:p>
-            <a:pPr indent="0" marL="0">
+            <a:pPr marL="0" indent="0">
               <a:buNone/>
             </a:pPr>
             <a:r>
@@ -6141,6 +6017,13 @@
             <a:prstDash val="solid"/>
           </a:ln>
         </p:spPr>
+        <p:txBody>
+          <a:bodyPr/>
+          <a:lstStyle/>
+          <a:p>
+            <a:endParaRPr lang="en-US"/>
+          </a:p>
+        </p:txBody>
       </p:sp>
       <p:sp>
         <p:nvSpPr>
@@ -6161,6 +6044,13 @@
           </a:solidFill>
           <a:ln/>
         </p:spPr>
+        <p:txBody>
+          <a:bodyPr/>
+          <a:lstStyle/>
+          <a:p>
+            <a:endParaRPr lang="en-US"/>
+          </a:p>
+        </p:txBody>
       </p:sp>
       <p:sp>
         <p:nvSpPr>
@@ -6183,7 +6073,7 @@
           <a:bodyPr wrap="square" lIns="0" tIns="0" rIns="0" bIns="0" rtlCol="0" anchor="ctr"/>
           <a:lstStyle/>
           <a:p>
-            <a:pPr algn="ctr" indent="0" marL="0">
+            <a:pPr marL="0" indent="0" algn="ctr">
               <a:buNone/>
             </a:pPr>
             <a:r>
@@ -6222,7 +6112,7 @@
           <a:bodyPr wrap="square" lIns="0" tIns="0" rIns="0" bIns="0" rtlCol="0" anchor="ctr"/>
           <a:lstStyle/>
           <a:p>
-            <a:pPr indent="0" marL="0">
+            <a:pPr marL="0" indent="0">
               <a:buNone/>
             </a:pPr>
             <a:r>
@@ -6351,6 +6241,13 @@
             <a:prstDash val="solid"/>
           </a:ln>
         </p:spPr>
+        <p:txBody>
+          <a:bodyPr/>
+          <a:lstStyle/>
+          <a:p>
+            <a:endParaRPr lang="en-US"/>
+          </a:p>
+        </p:txBody>
       </p:sp>
       <p:sp>
         <p:nvSpPr>
@@ -6371,6 +6268,13 @@
           </a:solidFill>
           <a:ln/>
         </p:spPr>
+        <p:txBody>
+          <a:bodyPr/>
+          <a:lstStyle/>
+          <a:p>
+            <a:endParaRPr lang="en-US"/>
+          </a:p>
+        </p:txBody>
       </p:sp>
       <p:sp>
         <p:nvSpPr>
@@ -6393,7 +6297,7 @@
           <a:bodyPr wrap="square" lIns="0" tIns="0" rIns="0" bIns="0" rtlCol="0" anchor="ctr"/>
           <a:lstStyle/>
           <a:p>
-            <a:pPr algn="ctr" indent="0" marL="0">
+            <a:pPr marL="0" indent="0" algn="ctr">
               <a:buNone/>
             </a:pPr>
             <a:r>
@@ -6432,7 +6336,7 @@
           <a:bodyPr wrap="square" lIns="0" tIns="0" rIns="0" bIns="0" rtlCol="0" anchor="ctr"/>
           <a:lstStyle/>
           <a:p>
-            <a:pPr indent="0" marL="0">
+            <a:pPr marL="0" indent="0">
               <a:buNone/>
             </a:pPr>
             <a:r>
@@ -6540,6 +6444,13 @@
             <a:prstDash val="solid"/>
           </a:ln>
         </p:spPr>
+        <p:txBody>
+          <a:bodyPr/>
+          <a:lstStyle/>
+          <a:p>
+            <a:endParaRPr lang="en-US"/>
+          </a:p>
+        </p:txBody>
       </p:sp>
       <p:sp>
         <p:nvSpPr>
@@ -6560,6 +6471,13 @@
           </a:solidFill>
           <a:ln/>
         </p:spPr>
+        <p:txBody>
+          <a:bodyPr/>
+          <a:lstStyle/>
+          <a:p>
+            <a:endParaRPr lang="en-US"/>
+          </a:p>
+        </p:txBody>
       </p:sp>
       <p:sp>
         <p:nvSpPr>
@@ -6582,7 +6500,7 @@
           <a:bodyPr wrap="square" lIns="0" tIns="0" rIns="0" bIns="0" rtlCol="0" anchor="ctr"/>
           <a:lstStyle/>
           <a:p>
-            <a:pPr algn="ctr" indent="0" marL="0">
+            <a:pPr marL="0" indent="0" algn="ctr">
               <a:buNone/>
             </a:pPr>
             <a:r>
@@ -6621,7 +6539,7 @@
           <a:bodyPr wrap="square" lIns="0" tIns="0" rIns="0" bIns="0" rtlCol="0" anchor="ctr"/>
           <a:lstStyle/>
           <a:p>
-            <a:pPr indent="0" marL="0">
+            <a:pPr marL="0" indent="0">
               <a:buNone/>
             </a:pPr>
             <a:r>
@@ -6729,6 +6647,13 @@
             <a:prstDash val="solid"/>
           </a:ln>
         </p:spPr>
+        <p:txBody>
+          <a:bodyPr/>
+          <a:lstStyle/>
+          <a:p>
+            <a:endParaRPr lang="en-US"/>
+          </a:p>
+        </p:txBody>
       </p:sp>
       <p:sp>
         <p:nvSpPr>
@@ -6749,6 +6674,13 @@
           </a:solidFill>
           <a:ln/>
         </p:spPr>
+        <p:txBody>
+          <a:bodyPr/>
+          <a:lstStyle/>
+          <a:p>
+            <a:endParaRPr lang="en-US"/>
+          </a:p>
+        </p:txBody>
       </p:sp>
       <p:sp>
         <p:nvSpPr>
@@ -6771,7 +6703,7 @@
           <a:bodyPr wrap="square" lIns="0" tIns="0" rIns="0" bIns="0" rtlCol="0" anchor="ctr"/>
           <a:lstStyle/>
           <a:p>
-            <a:pPr algn="ctr" indent="0" marL="0">
+            <a:pPr marL="0" indent="0" algn="ctr">
               <a:buNone/>
             </a:pPr>
             <a:r>
@@ -6810,7 +6742,7 @@
           <a:bodyPr wrap="square" lIns="0" tIns="0" rIns="0" bIns="0" rtlCol="0" anchor="ctr"/>
           <a:lstStyle/>
           <a:p>
-            <a:pPr indent="0" marL="0">
+            <a:pPr marL="0" indent="0">
               <a:buNone/>
             </a:pPr>
             <a:r>
@@ -6913,7 +6845,7 @@
           <a:bodyPr wrap="square" lIns="0" tIns="0" rIns="0" bIns="0" rtlCol="0" anchor="ctr"/>
           <a:lstStyle/>
           <a:p>
-            <a:pPr algn="r" indent="0" marL="0">
+            <a:pPr marL="0" indent="0" algn="r">
               <a:buNone/>
             </a:pPr>
             <a:r>
@@ -6975,6 +6907,13 @@
           </a:solidFill>
           <a:ln/>
         </p:spPr>
+        <p:txBody>
+          <a:bodyPr/>
+          <a:lstStyle/>
+          <a:p>
+            <a:endParaRPr lang="en-US"/>
+          </a:p>
+        </p:txBody>
       </p:sp>
       <p:sp>
         <p:nvSpPr>
@@ -6997,7 +6936,7 @@
           <a:bodyPr wrap="square" lIns="0" tIns="0" rIns="0" bIns="0" rtlCol="0" anchor="ctr"/>
           <a:lstStyle/>
           <a:p>
-            <a:pPr algn="ctr" indent="0" marL="0">
+            <a:pPr marL="0" indent="0" algn="ctr">
               <a:buNone/>
             </a:pPr>
             <a:r>
@@ -7036,11 +6975,11 @@
           <a:bodyPr wrap="square" lIns="0" tIns="0" rIns="0" bIns="0" rtlCol="0" anchor="ctr"/>
           <a:lstStyle/>
           <a:p>
-            <a:pPr indent="0" marL="0">
-              <a:buNone/>
-            </a:pPr>
-            <a:r>
-              <a:rPr lang="en-US" sz="1100" b="1" spc="140" kern="0" dirty="0">
+            <a:pPr marL="0" indent="0">
+              <a:buNone/>
+            </a:pPr>
+            <a:r>
+              <a:rPr lang="en-US" sz="1100" b="1" kern="0" spc="140" dirty="0">
                 <a:solidFill>
                   <a:srgbClr val="3F8A26"/>
                 </a:solidFill>
@@ -7075,7 +7014,7 @@
           <a:bodyPr wrap="square" lIns="0" tIns="0" rIns="0" bIns="0" rtlCol="0" anchor="t"/>
           <a:lstStyle/>
           <a:p>
-            <a:pPr indent="0" marL="0">
+            <a:pPr marL="0" indent="0">
               <a:buNone/>
             </a:pPr>
             <a:r>
@@ -7119,6 +7058,13 @@
             <a:prstDash val="solid"/>
           </a:ln>
         </p:spPr>
+        <p:txBody>
+          <a:bodyPr/>
+          <a:lstStyle/>
+          <a:p>
+            <a:endParaRPr lang="en-US"/>
+          </a:p>
+        </p:txBody>
       </p:sp>
       <p:sp>
         <p:nvSpPr>
@@ -7141,7 +7087,7 @@
           <a:bodyPr wrap="square" lIns="0" tIns="0" rIns="0" bIns="0" rtlCol="0" anchor="ctr"/>
           <a:lstStyle/>
           <a:p>
-            <a:pPr indent="0" marL="0">
+            <a:pPr marL="0" indent="0">
               <a:buNone/>
             </a:pPr>
             <a:r>
@@ -7270,6 +7216,13 @@
             <a:prstDash val="solid"/>
           </a:ln>
         </p:spPr>
+        <p:txBody>
+          <a:bodyPr/>
+          <a:lstStyle/>
+          <a:p>
+            <a:endParaRPr lang="en-US"/>
+          </a:p>
+        </p:txBody>
       </p:sp>
       <p:sp>
         <p:nvSpPr>
@@ -7292,7 +7245,7 @@
           <a:bodyPr wrap="square" lIns="0" tIns="0" rIns="0" bIns="0" rtlCol="0" anchor="ctr"/>
           <a:lstStyle/>
           <a:p>
-            <a:pPr indent="0" marL="0">
+            <a:pPr marL="0" indent="0">
               <a:buNone/>
             </a:pPr>
             <a:r>
@@ -7442,6 +7395,13 @@
             <a:prstDash val="solid"/>
           </a:ln>
         </p:spPr>
+        <p:txBody>
+          <a:bodyPr/>
+          <a:lstStyle/>
+          <a:p>
+            <a:endParaRPr lang="en-US"/>
+          </a:p>
+        </p:txBody>
       </p:sp>
       <p:sp>
         <p:nvSpPr>
@@ -7464,7 +7424,7 @@
           <a:bodyPr wrap="square" lIns="0" tIns="0" rIns="0" bIns="0" rtlCol="0" anchor="ctr"/>
           <a:lstStyle/>
           <a:p>
-            <a:pPr indent="0" marL="0">
+            <a:pPr marL="0" indent="0">
               <a:buNone/>
             </a:pPr>
             <a:r>
@@ -7609,7 +7569,7 @@
           <a:bodyPr wrap="square" lIns="0" tIns="0" rIns="0" bIns="0" rtlCol="0" anchor="ctr"/>
           <a:lstStyle/>
           <a:p>
-            <a:pPr algn="r" indent="0" marL="0">
+            <a:pPr marL="0" indent="0" algn="r">
               <a:buNone/>
             </a:pPr>
             <a:r>
@@ -7671,6 +7631,13 @@
           </a:solidFill>
           <a:ln/>
         </p:spPr>
+        <p:txBody>
+          <a:bodyPr/>
+          <a:lstStyle/>
+          <a:p>
+            <a:endParaRPr lang="en-US"/>
+          </a:p>
+        </p:txBody>
       </p:sp>
       <p:sp>
         <p:nvSpPr>
@@ -7693,7 +7660,7 @@
           <a:bodyPr wrap="square" lIns="0" tIns="0" rIns="0" bIns="0" rtlCol="0" anchor="ctr"/>
           <a:lstStyle/>
           <a:p>
-            <a:pPr algn="ctr" indent="0" marL="0">
+            <a:pPr marL="0" indent="0" algn="ctr">
               <a:buNone/>
             </a:pPr>
             <a:r>
@@ -7732,11 +7699,11 @@
           <a:bodyPr wrap="square" lIns="0" tIns="0" rIns="0" bIns="0" rtlCol="0" anchor="ctr"/>
           <a:lstStyle/>
           <a:p>
-            <a:pPr indent="0" marL="0">
-              <a:buNone/>
-            </a:pPr>
-            <a:r>
-              <a:rPr lang="en-US" sz="1100" b="1" spc="140" kern="0" dirty="0">
+            <a:pPr marL="0" indent="0">
+              <a:buNone/>
+            </a:pPr>
+            <a:r>
+              <a:rPr lang="en-US" sz="1100" b="1" kern="0" spc="140" dirty="0">
                 <a:solidFill>
                   <a:srgbClr val="3F8A26"/>
                 </a:solidFill>
@@ -7771,7 +7738,7 @@
           <a:bodyPr wrap="square" lIns="0" tIns="0" rIns="0" bIns="0" rtlCol="0" anchor="t"/>
           <a:lstStyle/>
           <a:p>
-            <a:pPr indent="0" marL="0">
+            <a:pPr marL="0" indent="0">
               <a:buNone/>
             </a:pPr>
             <a:r>
@@ -7815,6 +7782,13 @@
             <a:prstDash val="solid"/>
           </a:ln>
         </p:spPr>
+        <p:txBody>
+          <a:bodyPr/>
+          <a:lstStyle/>
+          <a:p>
+            <a:endParaRPr lang="en-US"/>
+          </a:p>
+        </p:txBody>
       </p:sp>
       <p:sp>
         <p:nvSpPr>
@@ -7837,7 +7811,7 @@
           <a:bodyPr wrap="square" lIns="0" tIns="0" rIns="0" bIns="0" rtlCol="0" anchor="ctr"/>
           <a:lstStyle/>
           <a:p>
-            <a:pPr indent="0" marL="0">
+            <a:pPr marL="0" indent="0">
               <a:buNone/>
             </a:pPr>
             <a:r>
@@ -7876,7 +7850,7 @@
           <a:bodyPr wrap="square" lIns="0" tIns="0" rIns="0" bIns="0" rtlCol="0" anchor="t"/>
           <a:lstStyle/>
           <a:p>
-            <a:pPr indent="0" marL="0">
+            <a:pPr marL="0" indent="0">
               <a:lnSpc>
                 <a:spcPts val="1620"/>
               </a:lnSpc>
@@ -7896,7 +7870,7 @@
             <a:endParaRPr lang="en-US" sz="1200" dirty="0"/>
           </a:p>
           <a:p>
-            <a:pPr indent="0" marL="0">
+            <a:pPr marL="0" indent="0">
               <a:lnSpc>
                 <a:spcPts val="1620"/>
               </a:lnSpc>
@@ -7916,7 +7890,7 @@
             <a:endParaRPr lang="en-US" sz="1200" dirty="0"/>
           </a:p>
           <a:p>
-            <a:pPr indent="0" marL="0">
+            <a:pPr marL="0" indent="0">
               <a:lnSpc>
                 <a:spcPts val="1620"/>
               </a:lnSpc>
@@ -7936,7 +7910,7 @@
             <a:endParaRPr lang="en-US" sz="1200" dirty="0"/>
           </a:p>
           <a:p>
-            <a:pPr indent="0" marL="0">
+            <a:pPr marL="0" indent="0">
               <a:lnSpc>
                 <a:spcPts val="1620"/>
               </a:lnSpc>
@@ -7956,7 +7930,7 @@
             <a:endParaRPr lang="en-US" sz="1200" dirty="0"/>
           </a:p>
           <a:p>
-            <a:pPr indent="0" marL="0">
+            <a:pPr marL="0" indent="0">
               <a:lnSpc>
                 <a:spcPts val="1620"/>
               </a:lnSpc>
@@ -7976,7 +7950,7 @@
             <a:endParaRPr lang="en-US" sz="1200" dirty="0"/>
           </a:p>
           <a:p>
-            <a:pPr indent="0" marL="0">
+            <a:pPr marL="0" indent="0">
               <a:lnSpc>
                 <a:spcPts val="1620"/>
               </a:lnSpc>
@@ -7996,7 +7970,7 @@
             <a:endParaRPr lang="en-US" sz="1200" dirty="0"/>
           </a:p>
           <a:p>
-            <a:pPr indent="0" marL="0">
+            <a:pPr marL="0" indent="0">
               <a:lnSpc>
                 <a:spcPts val="1620"/>
               </a:lnSpc>
@@ -8043,6 +8017,13 @@
             <a:prstDash val="solid"/>
           </a:ln>
         </p:spPr>
+        <p:txBody>
+          <a:bodyPr/>
+          <a:lstStyle/>
+          <a:p>
+            <a:endParaRPr lang="en-US"/>
+          </a:p>
+        </p:txBody>
       </p:sp>
       <p:sp>
         <p:nvSpPr>
@@ -8065,7 +8046,7 @@
           <a:bodyPr wrap="square" lIns="0" tIns="0" rIns="0" bIns="0" rtlCol="0" anchor="ctr"/>
           <a:lstStyle/>
           <a:p>
-            <a:pPr indent="0" marL="0">
+            <a:pPr marL="0" indent="0">
               <a:buNone/>
             </a:pPr>
             <a:r>
@@ -8104,7 +8085,7 @@
           <a:bodyPr wrap="square" lIns="0" tIns="0" rIns="0" bIns="0" rtlCol="0" anchor="t"/>
           <a:lstStyle/>
           <a:p>
-            <a:pPr indent="0" marL="0">
+            <a:pPr marL="0" indent="0">
               <a:buNone/>
             </a:pPr>
             <a:r>
@@ -8148,6 +8129,13 @@
             <a:prstDash val="solid"/>
           </a:ln>
         </p:spPr>
+        <p:txBody>
+          <a:bodyPr/>
+          <a:lstStyle/>
+          <a:p>
+            <a:endParaRPr lang="en-US"/>
+          </a:p>
+        </p:txBody>
       </p:sp>
       <p:sp>
         <p:nvSpPr>
@@ -8170,7 +8158,7 @@
           <a:bodyPr wrap="square" lIns="0" tIns="0" rIns="0" bIns="0" rtlCol="0" anchor="ctr"/>
           <a:lstStyle/>
           <a:p>
-            <a:pPr indent="0" marL="0">
+            <a:pPr marL="0" indent="0">
               <a:buNone/>
             </a:pPr>
             <a:r>
@@ -8209,7 +8197,7 @@
           <a:bodyPr wrap="square" lIns="0" tIns="0" rIns="0" bIns="0" rtlCol="0" anchor="t"/>
           <a:lstStyle/>
           <a:p>
-            <a:pPr indent="0" marL="0">
+            <a:pPr marL="0" indent="0">
               <a:buNone/>
             </a:pPr>
             <a:r>
@@ -8253,6 +8241,13 @@
             <a:prstDash val="solid"/>
           </a:ln>
         </p:spPr>
+        <p:txBody>
+          <a:bodyPr/>
+          <a:lstStyle/>
+          <a:p>
+            <a:endParaRPr lang="en-US"/>
+          </a:p>
+        </p:txBody>
       </p:sp>
       <p:sp>
         <p:nvSpPr>
@@ -8275,7 +8270,7 @@
           <a:bodyPr wrap="square" lIns="0" tIns="0" rIns="0" bIns="0" rtlCol="0" anchor="ctr"/>
           <a:lstStyle/>
           <a:p>
-            <a:pPr indent="0" marL="0">
+            <a:pPr marL="0" indent="0">
               <a:buNone/>
             </a:pPr>
             <a:r>
@@ -8314,7 +8309,7 @@
           <a:bodyPr wrap="square" lIns="0" tIns="0" rIns="0" bIns="0" rtlCol="0" anchor="t"/>
           <a:lstStyle/>
           <a:p>
-            <a:pPr indent="0" marL="0">
+            <a:pPr marL="0" indent="0">
               <a:buNone/>
             </a:pPr>
             <a:r>
@@ -8353,7 +8348,7 @@
           <a:bodyPr wrap="square" lIns="0" tIns="0" rIns="0" bIns="0" rtlCol="0" anchor="ctr"/>
           <a:lstStyle/>
           <a:p>
-            <a:pPr algn="r" indent="0" marL="0">
+            <a:pPr marL="0" indent="0" algn="r">
               <a:buNone/>
             </a:pPr>
             <a:r>
@@ -8415,6 +8410,13 @@
           </a:solidFill>
           <a:ln/>
         </p:spPr>
+        <p:txBody>
+          <a:bodyPr/>
+          <a:lstStyle/>
+          <a:p>
+            <a:endParaRPr lang="en-US"/>
+          </a:p>
+        </p:txBody>
       </p:sp>
       <p:sp>
         <p:nvSpPr>
@@ -8437,7 +8439,7 @@
           <a:bodyPr wrap="square" lIns="0" tIns="0" rIns="0" bIns="0" rtlCol="0" anchor="ctr"/>
           <a:lstStyle/>
           <a:p>
-            <a:pPr algn="ctr" indent="0" marL="0">
+            <a:pPr marL="0" indent="0" algn="ctr">
               <a:buNone/>
             </a:pPr>
             <a:r>
@@ -8476,11 +8478,11 @@
           <a:bodyPr wrap="square" lIns="0" tIns="0" rIns="0" bIns="0" rtlCol="0" anchor="ctr"/>
           <a:lstStyle/>
           <a:p>
-            <a:pPr indent="0" marL="0">
-              <a:buNone/>
-            </a:pPr>
-            <a:r>
-              <a:rPr lang="en-US" sz="1100" b="1" spc="140" kern="0" dirty="0">
+            <a:pPr marL="0" indent="0">
+              <a:buNone/>
+            </a:pPr>
+            <a:r>
+              <a:rPr lang="en-US" sz="1100" b="1" kern="0" spc="140" dirty="0">
                 <a:solidFill>
                   <a:srgbClr val="3F8A26"/>
                 </a:solidFill>
@@ -8515,7 +8517,7 @@
           <a:bodyPr wrap="square" lIns="0" tIns="0" rIns="0" bIns="0" rtlCol="0" anchor="t"/>
           <a:lstStyle/>
           <a:p>
-            <a:pPr indent="0" marL="0">
+            <a:pPr marL="0" indent="0">
               <a:buNone/>
             </a:pPr>
             <a:r>
@@ -8535,14 +8537,14 @@
       </p:sp>
       <p:pic>
         <p:nvPicPr>
-          <p:cNvPr id="6" name="Image 0" descr="/Users/fabianprado/Documents/projects/2026 - 2 /ai/proyecto2/resultados/figuras/comparacion_modelos.png">    </p:cNvPr>
+          <p:cNvPr id="6" name="Image 0" descr="/Users/fabianprado/Documents/projects/2026 - 2 /ai/proyecto2/resultados/figuras/comparacion_modelos.png"/>
           <p:cNvPicPr>
             <a:picLocks noChangeAspect="1"/>
           </p:cNvPicPr>
           <p:nvPr/>
         </p:nvPicPr>
         <p:blipFill>
-          <a:blip r:embed="rId1"/>
+          <a:blip r:embed="rId3"/>
           <a:stretch>
             <a:fillRect/>
           </a:stretch>
@@ -8583,6 +8585,13 @@
             <a:prstDash val="solid"/>
           </a:ln>
         </p:spPr>
+        <p:txBody>
+          <a:bodyPr/>
+          <a:lstStyle/>
+          <a:p>
+            <a:endParaRPr lang="en-US"/>
+          </a:p>
+        </p:txBody>
       </p:sp>
       <p:sp>
         <p:nvSpPr>
@@ -8605,7 +8614,7 @@
           <a:bodyPr wrap="square" lIns="0" tIns="0" rIns="0" bIns="0" rtlCol="0" anchor="ctr"/>
           <a:lstStyle/>
           <a:p>
-            <a:pPr indent="0" marL="0">
+            <a:pPr marL="0" indent="0">
               <a:buNone/>
             </a:pPr>
             <a:r>
@@ -8644,7 +8653,7 @@
           <a:bodyPr wrap="square" lIns="0" tIns="0" rIns="0" bIns="0" rtlCol="0" anchor="t"/>
           <a:lstStyle/>
           <a:p>
-            <a:pPr indent="0" marL="0">
+            <a:pPr marL="0" indent="0">
               <a:buNone/>
             </a:pPr>
             <a:r>
@@ -8683,7 +8692,7 @@
           <a:bodyPr wrap="square" lIns="0" tIns="0" rIns="0" bIns="0" rtlCol="0" anchor="ctr"/>
           <a:lstStyle/>
           <a:p>
-            <a:pPr algn="r" indent="0" marL="0">
+            <a:pPr marL="0" indent="0" algn="r">
               <a:buNone/>
             </a:pPr>
             <a:r>
@@ -8745,6 +8754,13 @@
           </a:solidFill>
           <a:ln/>
         </p:spPr>
+        <p:txBody>
+          <a:bodyPr/>
+          <a:lstStyle/>
+          <a:p>
+            <a:endParaRPr lang="en-US"/>
+          </a:p>
+        </p:txBody>
       </p:sp>
       <p:sp>
         <p:nvSpPr>
@@ -8767,7 +8783,7 @@
           <a:bodyPr wrap="square" lIns="0" tIns="0" rIns="0" bIns="0" rtlCol="0" anchor="ctr"/>
           <a:lstStyle/>
           <a:p>
-            <a:pPr algn="ctr" indent="0" marL="0">
+            <a:pPr marL="0" indent="0" algn="ctr">
               <a:buNone/>
             </a:pPr>
             <a:r>
@@ -8806,11 +8822,11 @@
           <a:bodyPr wrap="square" lIns="0" tIns="0" rIns="0" bIns="0" rtlCol="0" anchor="ctr"/>
           <a:lstStyle/>
           <a:p>
-            <a:pPr indent="0" marL="0">
-              <a:buNone/>
-            </a:pPr>
-            <a:r>
-              <a:rPr lang="en-US" sz="1100" b="1" spc="140" kern="0" dirty="0">
+            <a:pPr marL="0" indent="0">
+              <a:buNone/>
+            </a:pPr>
+            <a:r>
+              <a:rPr lang="en-US" sz="1100" b="1" kern="0" spc="140" dirty="0">
                 <a:solidFill>
                   <a:srgbClr val="3F8A26"/>
                 </a:solidFill>
@@ -8845,7 +8861,7 @@
           <a:bodyPr wrap="square" lIns="0" tIns="0" rIns="0" bIns="0" rtlCol="0" anchor="t"/>
           <a:lstStyle/>
           <a:p>
-            <a:pPr indent="0" marL="0">
+            <a:pPr marL="0" indent="0">
               <a:buNone/>
             </a:pPr>
             <a:r>
@@ -8865,14 +8881,14 @@
       </p:sp>
       <p:pic>
         <p:nvPicPr>
-          <p:cNvPr id="6" name="Image 0" descr="/Users/fabianprado/Documents/projects/2026 - 2 /ai/proyecto2/resultados/figuras/matriz_confusion_test.png">    </p:cNvPr>
+          <p:cNvPr id="6" name="Image 0" descr="/Users/fabianprado/Documents/projects/2026 - 2 /ai/proyecto2/resultados/figuras/matriz_confusion_test.png"/>
           <p:cNvPicPr>
             <a:picLocks noChangeAspect="1"/>
           </p:cNvPicPr>
           <p:nvPr/>
         </p:nvPicPr>
         <p:blipFill>
-          <a:blip r:embed="rId1"/>
+          <a:blip r:embed="rId3"/>
           <a:stretch>
             <a:fillRect/>
           </a:stretch>
@@ -8913,6 +8929,13 @@
             <a:prstDash val="solid"/>
           </a:ln>
         </p:spPr>
+        <p:txBody>
+          <a:bodyPr/>
+          <a:lstStyle/>
+          <a:p>
+            <a:endParaRPr lang="en-US"/>
+          </a:p>
+        </p:txBody>
       </p:sp>
       <p:sp>
         <p:nvSpPr>
@@ -8935,7 +8958,7 @@
           <a:bodyPr wrap="square" lIns="0" tIns="0" rIns="0" bIns="0" rtlCol="0" anchor="ctr"/>
           <a:lstStyle/>
           <a:p>
-            <a:pPr indent="0" marL="0">
+            <a:pPr marL="0" indent="0">
               <a:buNone/>
             </a:pPr>
             <a:r>
@@ -8974,7 +8997,7 @@
           <a:bodyPr wrap="square" lIns="0" tIns="0" rIns="0" bIns="0" rtlCol="0" anchor="t"/>
           <a:lstStyle/>
           <a:p>
-            <a:pPr indent="0" marL="0">
+            <a:pPr marL="0" indent="0">
               <a:buNone/>
             </a:pPr>
             <a:r>
@@ -9013,7 +9036,7 @@
           <a:bodyPr wrap="square" lIns="0" tIns="0" rIns="0" bIns="0" rtlCol="0" anchor="ctr"/>
           <a:lstStyle/>
           <a:p>
-            <a:pPr algn="r" indent="0" marL="0">
+            <a:pPr marL="0" indent="0" algn="r">
               <a:buNone/>
             </a:pPr>
             <a:r>
@@ -9332,4 +9355,319 @@
     </a:ext>
   </a:extLst>
 </a:theme>
+</file>
+
+<file path=ppt/theme/theme2.xml><?xml version="1.0" encoding="utf-8"?>
+<a:theme xmlns:a="http://schemas.openxmlformats.org/drawingml/2006/main" name="Office Theme">
+  <a:themeElements>
+    <a:clrScheme name="Office">
+      <a:dk1>
+        <a:sysClr val="windowText" lastClr="000000"/>
+      </a:dk1>
+      <a:lt1>
+        <a:sysClr val="window" lastClr="FFFFFF"/>
+      </a:lt1>
+      <a:dk2>
+        <a:srgbClr val="0E2841"/>
+      </a:dk2>
+      <a:lt2>
+        <a:srgbClr val="E8E8E8"/>
+      </a:lt2>
+      <a:accent1>
+        <a:srgbClr val="156082"/>
+      </a:accent1>
+      <a:accent2>
+        <a:srgbClr val="E97132"/>
+      </a:accent2>
+      <a:accent3>
+        <a:srgbClr val="196B24"/>
+      </a:accent3>
+      <a:accent4>
+        <a:srgbClr val="0F9ED5"/>
+      </a:accent4>
+      <a:accent5>
+        <a:srgbClr val="A02B93"/>
+      </a:accent5>
+      <a:accent6>
+        <a:srgbClr val="4EA72E"/>
+      </a:accent6>
+      <a:hlink>
+        <a:srgbClr val="467886"/>
+      </a:hlink>
+      <a:folHlink>
+        <a:srgbClr val="96607D"/>
+      </a:folHlink>
+    </a:clrScheme>
+    <a:fontScheme name="Office">
+      <a:majorFont>
+        <a:latin typeface="Aptos Display" panose="02110004020202020204"/>
+        <a:ea typeface=""/>
+        <a:cs typeface=""/>
+        <a:font script="Jpan" typeface="游ゴシック Light"/>
+        <a:font script="Hang" typeface="맑은 고딕"/>
+        <a:font script="Hans" typeface="等线 Light"/>
+        <a:font script="Hant" typeface="新細明體"/>
+        <a:font script="Arab" typeface="Times New Roman"/>
+        <a:font script="Hebr" typeface="Times New Roman"/>
+        <a:font script="Thai" typeface="Angsana New"/>
+        <a:font script="Ethi" typeface="Nyala"/>
+        <a:font script="Beng" typeface="Vrinda"/>
+        <a:font script="Gujr" typeface="Shruti"/>
+        <a:font script="Khmr" typeface="MoolBoran"/>
+        <a:font script="Knda" typeface="Tunga"/>
+        <a:font script="Guru" typeface="Raavi"/>
+        <a:font script="Cans" typeface="Euphemia"/>
+        <a:font script="Cher" typeface="Plantagenet Cherokee"/>
+        <a:font script="Yiii" typeface="Microsoft Yi Baiti"/>
+        <a:font script="Tibt" typeface="Microsoft Himalaya"/>
+        <a:font script="Thaa" typeface="MV Boli"/>
+        <a:font script="Deva" typeface="Mangal"/>
+        <a:font script="Telu" typeface="Gautami"/>
+        <a:font script="Taml" typeface="Latha"/>
+        <a:font script="Syrc" typeface="Estrangelo Edessa"/>
+        <a:font script="Orya" typeface="Kalinga"/>
+        <a:font script="Mlym" typeface="Kartika"/>
+        <a:font script="Laoo" typeface="DokChampa"/>
+        <a:font script="Sinh" typeface="Iskoola Pota"/>
+        <a:font script="Mong" typeface="Mongolian Baiti"/>
+        <a:font script="Viet" typeface="Times New Roman"/>
+        <a:font script="Uigh" typeface="Microsoft Uighur"/>
+        <a:font script="Geor" typeface="Sylfaen"/>
+        <a:font script="Armn" typeface="Arial"/>
+        <a:font script="Bugi" typeface="Leelawadee UI"/>
+        <a:font script="Bopo" typeface="Microsoft JhengHei"/>
+        <a:font script="Java" typeface="Javanese Text"/>
+        <a:font script="Lisu" typeface="Segoe UI"/>
+        <a:font script="Mymr" typeface="Myanmar Text"/>
+        <a:font script="Nkoo" typeface="Ebrima"/>
+        <a:font script="Olck" typeface="Nirmala UI"/>
+        <a:font script="Osma" typeface="Ebrima"/>
+        <a:font script="Phag" typeface="Phagspa"/>
+        <a:font script="Syrn" typeface="Estrangelo Edessa"/>
+        <a:font script="Syrj" typeface="Estrangelo Edessa"/>
+        <a:font script="Syre" typeface="Estrangelo Edessa"/>
+        <a:font script="Sora" typeface="Nirmala UI"/>
+        <a:font script="Tale" typeface="Microsoft Tai Le"/>
+        <a:font script="Talu" typeface="Microsoft New Tai Lue"/>
+        <a:font script="Tfng" typeface="Ebrima"/>
+      </a:majorFont>
+      <a:minorFont>
+        <a:latin typeface="Aptos" panose="02110004020202020204"/>
+        <a:ea typeface=""/>
+        <a:cs typeface=""/>
+        <a:font script="Jpan" typeface="游ゴシック"/>
+        <a:font script="Hang" typeface="맑은 고딕"/>
+        <a:font script="Hans" typeface="等线"/>
+        <a:font script="Hant" typeface="新細明體"/>
+        <a:font script="Arab" typeface="Arial"/>
+        <a:font script="Hebr" typeface="Arial"/>
+        <a:font script="Thai" typeface="Cordia New"/>
+        <a:font script="Ethi" typeface="Nyala"/>
+        <a:font script="Beng" typeface="Vrinda"/>
+        <a:font script="Gujr" typeface="Shruti"/>
+        <a:font script="Khmr" typeface="DaunPenh"/>
+        <a:font script="Knda" typeface="Tunga"/>
+        <a:font script="Guru" typeface="Raavi"/>
+        <a:font script="Cans" typeface="Euphemia"/>
+        <a:font script="Cher" typeface="Plantagenet Cherokee"/>
+        <a:font script="Yiii" typeface="Microsoft Yi Baiti"/>
+        <a:font script="Tibt" typeface="Microsoft Himalaya"/>
+        <a:font script="Thaa" typeface="MV Boli"/>
+        <a:font script="Deva" typeface="Mangal"/>
+        <a:font script="Telu" typeface="Gautami"/>
+        <a:font script="Taml" typeface="Latha"/>
+        <a:font script="Syrc" typeface="Estrangelo Edessa"/>
+        <a:font script="Orya" typeface="Kalinga"/>
+        <a:font script="Mlym" typeface="Kartika"/>
+        <a:font script="Laoo" typeface="DokChampa"/>
+        <a:font script="Sinh" typeface="Iskoola Pota"/>
+        <a:font script="Mong" typeface="Mongolian Baiti"/>
+        <a:font script="Viet" typeface="Arial"/>
+        <a:font script="Uigh" typeface="Microsoft Uighur"/>
+        <a:font script="Geor" typeface="Sylfaen"/>
+        <a:font script="Armn" typeface="Arial"/>
+        <a:font script="Bugi" typeface="Leelawadee UI"/>
+        <a:font script="Bopo" typeface="Microsoft JhengHei"/>
+        <a:font script="Java" typeface="Javanese Text"/>
+        <a:font script="Lisu" typeface="Segoe UI"/>
+        <a:font script="Mymr" typeface="Myanmar Text"/>
+        <a:font script="Nkoo" typeface="Ebrima"/>
+        <a:font script="Olck" typeface="Nirmala UI"/>
+        <a:font script="Osma" typeface="Ebrima"/>
+        <a:font script="Phag" typeface="Phagspa"/>
+        <a:font script="Syrn" typeface="Estrangelo Edessa"/>
+        <a:font script="Syrj" typeface="Estrangelo Edessa"/>
+        <a:font script="Syre" typeface="Estrangelo Edessa"/>
+        <a:font script="Sora" typeface="Nirmala UI"/>
+        <a:font script="Tale" typeface="Microsoft Tai Le"/>
+        <a:font script="Talu" typeface="Microsoft New Tai Lue"/>
+        <a:font script="Tfng" typeface="Ebrima"/>
+      </a:minorFont>
+    </a:fontScheme>
+    <a:fmtScheme name="Office">
+      <a:fillStyleLst>
+        <a:solidFill>
+          <a:schemeClr val="phClr"/>
+        </a:solidFill>
+        <a:gradFill rotWithShape="1">
+          <a:gsLst>
+            <a:gs pos="0">
+              <a:schemeClr val="phClr">
+                <a:lumMod val="110000"/>
+                <a:satMod val="105000"/>
+                <a:tint val="67000"/>
+              </a:schemeClr>
+            </a:gs>
+            <a:gs pos="50000">
+              <a:schemeClr val="phClr">
+                <a:lumMod val="105000"/>
+                <a:satMod val="103000"/>
+                <a:tint val="73000"/>
+              </a:schemeClr>
+            </a:gs>
+            <a:gs pos="100000">
+              <a:schemeClr val="phClr">
+                <a:lumMod val="105000"/>
+                <a:satMod val="109000"/>
+                <a:tint val="81000"/>
+              </a:schemeClr>
+            </a:gs>
+          </a:gsLst>
+          <a:lin ang="5400000" scaled="0"/>
+        </a:gradFill>
+        <a:gradFill rotWithShape="1">
+          <a:gsLst>
+            <a:gs pos="0">
+              <a:schemeClr val="phClr">
+                <a:satMod val="103000"/>
+                <a:lumMod val="102000"/>
+                <a:tint val="94000"/>
+              </a:schemeClr>
+            </a:gs>
+            <a:gs pos="50000">
+              <a:schemeClr val="phClr">
+                <a:satMod val="110000"/>
+                <a:lumMod val="100000"/>
+                <a:shade val="100000"/>
+              </a:schemeClr>
+            </a:gs>
+            <a:gs pos="100000">
+              <a:schemeClr val="phClr">
+                <a:lumMod val="99000"/>
+                <a:satMod val="120000"/>
+                <a:shade val="78000"/>
+              </a:schemeClr>
+            </a:gs>
+          </a:gsLst>
+          <a:lin ang="5400000" scaled="0"/>
+        </a:gradFill>
+      </a:fillStyleLst>
+      <a:lnStyleLst>
+        <a:ln w="12700" cap="flat" cmpd="sng" algn="ctr">
+          <a:solidFill>
+            <a:schemeClr val="phClr"/>
+          </a:solidFill>
+          <a:prstDash val="solid"/>
+          <a:miter lim="800000"/>
+        </a:ln>
+        <a:ln w="19050" cap="flat" cmpd="sng" algn="ctr">
+          <a:solidFill>
+            <a:schemeClr val="phClr"/>
+          </a:solidFill>
+          <a:prstDash val="solid"/>
+          <a:miter lim="800000"/>
+        </a:ln>
+        <a:ln w="25400" cap="flat" cmpd="sng" algn="ctr">
+          <a:solidFill>
+            <a:schemeClr val="phClr"/>
+          </a:solidFill>
+          <a:prstDash val="solid"/>
+          <a:miter lim="800000"/>
+        </a:ln>
+      </a:lnStyleLst>
+      <a:effectStyleLst>
+        <a:effectStyle>
+          <a:effectLst/>
+        </a:effectStyle>
+        <a:effectStyle>
+          <a:effectLst/>
+        </a:effectStyle>
+        <a:effectStyle>
+          <a:effectLst>
+            <a:outerShdw blurRad="57150" dist="19050" dir="5400000" algn="ctr" rotWithShape="0">
+              <a:srgbClr val="000000">
+                <a:alpha val="63000"/>
+              </a:srgbClr>
+            </a:outerShdw>
+          </a:effectLst>
+        </a:effectStyle>
+      </a:effectStyleLst>
+      <a:bgFillStyleLst>
+        <a:solidFill>
+          <a:schemeClr val="phClr"/>
+        </a:solidFill>
+        <a:solidFill>
+          <a:schemeClr val="phClr">
+            <a:tint val="95000"/>
+            <a:satMod val="170000"/>
+          </a:schemeClr>
+        </a:solidFill>
+        <a:gradFill rotWithShape="1">
+          <a:gsLst>
+            <a:gs pos="0">
+              <a:schemeClr val="phClr">
+                <a:tint val="93000"/>
+                <a:satMod val="150000"/>
+                <a:shade val="98000"/>
+                <a:lumMod val="102000"/>
+              </a:schemeClr>
+            </a:gs>
+            <a:gs pos="50000">
+              <a:schemeClr val="phClr">
+                <a:tint val="98000"/>
+                <a:satMod val="130000"/>
+                <a:shade val="90000"/>
+                <a:lumMod val="103000"/>
+              </a:schemeClr>
+            </a:gs>
+            <a:gs pos="100000">
+              <a:schemeClr val="phClr">
+                <a:shade val="63000"/>
+                <a:satMod val="120000"/>
+              </a:schemeClr>
+            </a:gs>
+          </a:gsLst>
+          <a:lin ang="5400000" scaled="0"/>
+        </a:gradFill>
+      </a:bgFillStyleLst>
+    </a:fmtScheme>
+  </a:themeElements>
+  <a:objectDefaults>
+    <a:lnDef>
+      <a:spPr/>
+      <a:bodyPr/>
+      <a:lstStyle/>
+      <a:style>
+        <a:lnRef idx="2">
+          <a:schemeClr val="accent1"/>
+        </a:lnRef>
+        <a:fillRef idx="0">
+          <a:schemeClr val="accent1"/>
+        </a:fillRef>
+        <a:effectRef idx="1">
+          <a:schemeClr val="accent1"/>
+        </a:effectRef>
+        <a:fontRef idx="minor">
+          <a:schemeClr val="tx1"/>
+        </a:fontRef>
+      </a:style>
+    </a:lnDef>
+  </a:objectDefaults>
+  <a:extraClrSchemeLst/>
+  <a:extLst>
+    <a:ext uri="{05A4C25C-085E-4340-85A3-A5531E510DB2}">
+      <thm15:themeFamily xmlns:thm15="http://schemas.microsoft.com/office/thememl/2012/main" name="Office Theme" id="{2E142A2C-CD16-42D6-873A-C26D2A0506FA}" vid="{1BDDFF52-6CD6-40A5-AB3C-68EB2F1E4D0A}"/>
+    </a:ext>
+  </a:extLst>
+</a:theme>
 </file>
</xml_diff>

<commit_message>
docs: changes to ppt
</commit_message>
<xml_diff>
--- a/Presentacion-Proyecto2.pptx
+++ b/Presentacion-Proyecto2.pptx
@@ -4,6 +4,9 @@
   <p:sldMasterIdLst>
     <p:sldMasterId id="2147483648" r:id="rId1"/>
   </p:sldMasterIdLst>
+  <p:notesMasterIdLst>
+    <p:notesMasterId r:id="rId15"/>
+  </p:notesMasterIdLst>
   <p:sldIdLst>
     <p:sldId id="256" r:id="rId2"/>
     <p:sldId id="257" r:id="rId3"/>
@@ -19,9 +22,6 @@
     <p:sldId id="267" r:id="rId13"/>
     <p:sldId id="268" r:id="rId14"/>
   </p:sldIdLst>
-  <p:notesMasterIdLst>
-    <p:notesMasterId r:id="rId15"/>
-  </p:notesMasterIdLst>
   <p:sldSz cx="12192000" cy="6858000"/>
   <p:notesSz cx="6858000" cy="12192000"/>
   <p:defaultTextStyle>
@@ -116,6 +116,11 @@
       </a:defRPr>
     </a:lvl9pPr>
   </p:defaultTextStyle>
+  <p:extLst>
+    <p:ext uri="{EFAFB233-063F-42B5-8137-9DF3F51BA10A}">
+      <p15:sldGuideLst xmlns:p15="http://schemas.microsoft.com/office/powerpoint/2012/main"/>
+    </p:ext>
+  </p:extLst>
 </p:presentation>
 </file>
 
@@ -141,234 +146,10 @@
           <a:chExt cx="0" cy="0"/>
         </a:xfrm>
       </p:grpSpPr>
-      <p:sp>
-        <p:nvSpPr>
-          <p:cNvPr id="2" name="Header Placeholder 1"/>
-          <p:cNvSpPr>
-            <a:spLocks noGrp="1"/>
-          </p:cNvSpPr>
-          <p:nvPr>
-            <p:ph type="hdr" sz="quarter"/>
-          </p:nvPr>
-        </p:nvSpPr>
-        <p:spPr>
-          <a:xfrm>
-            <a:off x="0" y="0"/>
-            <a:ext cx="2971800" cy="458788"/>
-          </a:xfrm>
-          <a:prstGeom prst="rect">
-            <a:avLst/>
-          </a:prstGeom>
-        </p:spPr>
-        <p:txBody>
-          <a:bodyPr vert="horz" lIns="91440" tIns="45720" rIns="91440" bIns="45720" rtlCol="0"/>
-          <a:lstStyle>
-            <a:lvl1pPr algn="l">
-              <a:defRPr sz="1200"/>
-            </a:lvl1pPr>
-          </a:lstStyle>
-          <a:p>
-            <a:endParaRPr lang="en-US"/>
-          </a:p>
-        </p:txBody>
-      </p:sp>
-      <p:sp>
-        <p:nvSpPr>
-          <p:cNvPr id="3" name="Date Placeholder 2"/>
-          <p:cNvSpPr>
-            <a:spLocks noGrp="1"/>
-          </p:cNvSpPr>
-          <p:nvPr>
-            <p:ph type="dt" idx="1"/>
-          </p:nvPr>
-        </p:nvSpPr>
-        <p:spPr>
-          <a:xfrm>
-            <a:off x="3884613" y="0"/>
-            <a:ext cx="2971800" cy="458788"/>
-          </a:xfrm>
-          <a:prstGeom prst="rect">
-            <a:avLst/>
-          </a:prstGeom>
-        </p:spPr>
-        <p:txBody>
-          <a:bodyPr vert="horz" lIns="91440" tIns="45720" rIns="91440" bIns="45720" rtlCol="0"/>
-          <a:lstStyle>
-            <a:lvl1pPr algn="r">
-              <a:defRPr sz="1200"/>
-            </a:lvl1pPr>
-          </a:lstStyle>
-          <a:p>
-            <a:fld id="{5282F153-3F37-0F45-9E97-73ACFA13230C}" type="datetimeFigureOut">
-              <a:rPr lang="en-US"/>
-              <a:t>7/23/19</a:t>
-            </a:fld>
-            <a:endParaRPr lang="en-US"/>
-          </a:p>
-        </p:txBody>
-      </p:sp>
-      <p:sp>
-        <p:nvSpPr>
-          <p:cNvPr id="4" name="Slide Image Placeholder 3"/>
-          <p:cNvSpPr>
-            <a:spLocks noGrp="1" noRot="1" noChangeAspect="1"/>
-          </p:cNvSpPr>
-          <p:nvPr>
-            <p:ph type="sldImg" idx="2"/>
-          </p:nvPr>
-        </p:nvSpPr>
-        <p:spPr>
-          <a:xfrm>
-            <a:off x="685800" y="1143000"/>
-            <a:ext cx="5486400" cy="3086100"/>
-          </a:xfrm>
-          <a:prstGeom prst="rect">
-            <a:avLst/>
-          </a:prstGeom>
-          <a:noFill/>
-          <a:ln w="12700">
-            <a:solidFill>
-              <a:prstClr val="black"/>
-            </a:solidFill>
-          </a:ln>
-        </p:spPr>
-        <p:txBody>
-          <a:bodyPr vert="horz" lIns="91440" tIns="45720" rIns="91440" bIns="45720" rtlCol="0" anchor="ctr"/>
-          <a:lstStyle/>
-          <a:p>
-            <a:endParaRPr lang="en-US"/>
-          </a:p>
-        </p:txBody>
-      </p:sp>
-      <p:sp>
-        <p:nvSpPr>
-          <p:cNvPr id="5" name="Notes Placeholder 4"/>
-          <p:cNvSpPr>
-            <a:spLocks noGrp="1"/>
-          </p:cNvSpPr>
-          <p:nvPr>
-            <p:ph type="body" sz="quarter" idx="3"/>
-          </p:nvPr>
-        </p:nvSpPr>
-        <p:spPr>
-          <a:xfrm>
-            <a:off x="685800" y="4400550"/>
-            <a:ext cx="5486400" cy="3600450"/>
-          </a:xfrm>
-          <a:prstGeom prst="rect">
-            <a:avLst/>
-          </a:prstGeom>
-        </p:spPr>
-        <p:txBody>
-          <a:bodyPr vert="horz" lIns="91440" tIns="45720" rIns="91440" bIns="45720" rtlCol="0"/>
-          <a:lstStyle/>
-          <a:p>
-            <a:pPr lvl="0"/>
-            <a:r>
-              <a:rPr lang="en-US"/>
-              <a:t>Click to edit Master text styles</a:t>
-            </a:r>
-          </a:p>
-          <a:p>
-            <a:pPr lvl="1"/>
-            <a:r>
-              <a:rPr lang="en-US"/>
-              <a:t>Second level</a:t>
-            </a:r>
-          </a:p>
-          <a:p>
-            <a:pPr lvl="2"/>
-            <a:r>
-              <a:rPr lang="en-US"/>
-              <a:t>Third level</a:t>
-            </a:r>
-          </a:p>
-          <a:p>
-            <a:pPr lvl="3"/>
-            <a:r>
-              <a:rPr lang="en-US"/>
-              <a:t>Fourth level</a:t>
-            </a:r>
-          </a:p>
-          <a:p>
-            <a:pPr lvl="4"/>
-            <a:r>
-              <a:rPr lang="en-US"/>
-              <a:t>Fifth level</a:t>
-            </a:r>
-          </a:p>
-        </p:txBody>
-      </p:sp>
-      <p:sp>
-        <p:nvSpPr>
-          <p:cNvPr id="6" name="Footer Placeholder 5"/>
-          <p:cNvSpPr>
-            <a:spLocks noGrp="1"/>
-          </p:cNvSpPr>
-          <p:nvPr>
-            <p:ph type="ftr" sz="quarter" idx="4"/>
-          </p:nvPr>
-        </p:nvSpPr>
-        <p:spPr>
-          <a:xfrm>
-            <a:off x="0" y="8685213"/>
-            <a:ext cx="2971800" cy="458787"/>
-          </a:xfrm>
-          <a:prstGeom prst="rect">
-            <a:avLst/>
-          </a:prstGeom>
-        </p:spPr>
-        <p:txBody>
-          <a:bodyPr vert="horz" lIns="91440" tIns="45720" rIns="91440" bIns="45720" rtlCol="0" anchor="b"/>
-          <a:lstStyle>
-            <a:lvl1pPr algn="l">
-              <a:defRPr sz="1200"/>
-            </a:lvl1pPr>
-          </a:lstStyle>
-          <a:p>
-            <a:endParaRPr lang="en-US"/>
-          </a:p>
-        </p:txBody>
-      </p:sp>
-      <p:sp>
-        <p:nvSpPr>
-          <p:cNvPr id="7" name="Slide Number Placeholder 6"/>
-          <p:cNvSpPr>
-            <a:spLocks noGrp="1"/>
-          </p:cNvSpPr>
-          <p:nvPr>
-            <p:ph type="sldNum" sz="quarter" idx="5"/>
-          </p:nvPr>
-        </p:nvSpPr>
-        <p:spPr>
-          <a:xfrm>
-            <a:off x="3884613" y="8685213"/>
-            <a:ext cx="2971800" cy="458787"/>
-          </a:xfrm>
-          <a:prstGeom prst="rect">
-            <a:avLst/>
-          </a:prstGeom>
-        </p:spPr>
-        <p:txBody>
-          <a:bodyPr vert="horz" lIns="91440" tIns="45720" rIns="91440" bIns="45720" rtlCol="0" anchor="b"/>
-          <a:lstStyle>
-            <a:lvl1pPr algn="r">
-              <a:defRPr sz="1200"/>
-            </a:lvl1pPr>
-          </a:lstStyle>
-          <a:p>
-            <a:fld id="{CE5E9CC1-C706-0F49-92D6-E571CC5EEA8F}" type="slidenum">
-              <a:rPr lang="en-US"/>
-              <a:t>‹#›</a:t>
-            </a:fld>
-            <a:endParaRPr lang="en-US"/>
-          </a:p>
-        </p:txBody>
-      </p:sp>
     </p:spTree>
     <p:extLst>
       <p:ext uri="{BB962C8B-B14F-4D97-AF65-F5344CB8AC3E}">
-        <p14:creationId xmlns:p14="http://schemas.microsoft.com/office/powerpoint/2010/main" val="1024086991"/>
+        <p14:creationId xmlns:p14="http://schemas.microsoft.com/office/powerpoint/2010/main" val="1011212630"/>
       </p:ext>
     </p:extLst>
   </p:cSld>
@@ -516,7 +297,6 @@
               <a:rPr lang="en-US" dirty="0"/>
               <a:t>Presentamos un clasificador de tres clases para el estado de diabetes. Todo el código está en el repositorio Proyecto2-IA y corre de principio a fin.</a:t>
             </a:r>
-            <a:endParaRPr lang="en-US" dirty="0"/>
           </a:p>
         </p:txBody>
       </p:sp>
@@ -604,7 +384,6 @@
               <a:rPr lang="en-US" dirty="0"/>
               <a:t>Ejemplos concretos tomados del conjunto de prueba, ordenados por la probabilidad del modelo. La conclusión: una persona con diabetes y perfil sano no tiene nada en estas 21 variables que la distinga de una persona sana.</a:t>
             </a:r>
-            <a:endParaRPr lang="en-US" dirty="0"/>
           </a:p>
         </p:txBody>
       </p:sp>
@@ -692,7 +471,6 @@
               <a:rPr lang="en-US" dirty="0"/>
               <a:t>El sesgo por edad e ingreso viene de que esas personas con diabetes tienen, en promedio, un perfil más sano. Es un sesgo a reportar aunque el F1 macro por grupo sea parecido (0.40 a 0.44).</a:t>
             </a:r>
-            <a:endParaRPr lang="en-US" dirty="0"/>
           </a:p>
         </p:txBody>
       </p:sp>
@@ -780,7 +558,6 @@
               <a:rPr lang="en-US" dirty="0"/>
               <a:t>El techo de 0.44 aparece con cinco algoritmos distintos, lo que sugiere que el límite está en los datos y no en el modelo. El CDC estima que una parte importante de las personas con diabetes y la gran mayoría con prediabetes no lo saben.</a:t>
             </a:r>
-            <a:endParaRPr lang="en-US" dirty="0"/>
           </a:p>
         </p:txBody>
       </p:sp>
@@ -868,7 +645,6 @@
               <a:rPr lang="en-US" dirty="0"/>
               <a:t>Cierre: el modelo sirve como primer filtro para recomendar una prueba de diabetes, con el sesgo conocido hacia personas jóvenes y de ingresos altos. Para prediabetes harían falta variables clínicas.</a:t>
             </a:r>
-            <a:endParaRPr lang="en-US" dirty="0"/>
           </a:p>
         </p:txBody>
       </p:sp>
@@ -956,7 +732,6 @@
               <a:rPr lang="en-US" dirty="0"/>
               <a:t>El costo más alto es no detectar a una persona con diabetes; una prueba médica de más cuesta poco. Por eso miramos también el recall por clase. Pregunta probable: por qué no accuracy. Respuesta: con 84% de personas sanas, predecir siempre sano da 84% de accuracy sin detectar a nadie.</a:t>
             </a:r>
-            <a:endParaRPr lang="en-US" dirty="0"/>
           </a:p>
         </p:txBody>
       </p:sp>
@@ -1044,7 +819,6 @@
               <a:rPr lang="en-US" dirty="0"/>
               <a:t>Usamos el archivo de Kaggle porque el de UCI solo trae la etiqueta binaria; tienen los mismos registros y variables. Con esta distribución, predecir siempre sin diabetes da 84% de accuracy sin detectar a nadie: por eso F1 macro, pesos de clase y partición estratificada.</a:t>
             </a:r>
-            <a:endParaRPr lang="en-US" dirty="0"/>
           </a:p>
         </p:txBody>
       </p:sp>
@@ -1132,7 +906,6 @@
               <a:rPr lang="en-US" dirty="0"/>
               <a:t>El análisis se hizo solo con el conjunto de entrenamiento (202,944 registros). La prediabetes casi siempre queda en un punto intermedio, más cerca de la diabetes: anticipa que será la clase más difícil, por eso reportamos el recall de cada clase además del F1 macro.</a:t>
             </a:r>
-            <a:endParaRPr lang="en-US" dirty="0"/>
           </a:p>
         </p:txBody>
       </p:sp>
@@ -1220,7 +993,6 @@
               <a:rPr lang="en-US" dirty="0"/>
               <a:t>Los atípicos de MentHlth y PhysHlth según el rango intercuartílico son respuestas válidas: la mayoría responde 0 días. Los árboles no necesitan escalar porque solo usan umbrales.</a:t>
             </a:r>
-            <a:endParaRPr lang="en-US" dirty="0"/>
           </a:p>
         </p:txBody>
       </p:sp>
@@ -1308,7 +1080,6 @@
               <a:rPr lang="en-US" dirty="0"/>
               <a:t>La búsqueda de la logística probó C en 0.01, 0.1, 1 y 10, con y sin pesos; C casi no importa con 200 mil registros. El árbol se controla con profundidad, mínimo para dividir, mínimo por hoja, criterio y pesos de clase. Variables más importantes del árbol: presión alta, IMC, salud general y edad.</a:t>
             </a:r>
-            <a:endParaRPr lang="en-US" dirty="0"/>
           </a:p>
         </p:txBody>
       </p:sp>
@@ -1396,7 +1167,6 @@
               <a:rPr lang="en-US" dirty="0"/>
               <a:t>Random forest: 100 árboles, profundidad 20, hojas de 10, max_features 0.5, pesos balanced_subsample. Gradient boosting: HistGradientBoosting, learning rate 0.05, 63 hojas, parada temprana en 65 árboles con un 10% interno de validación. La desviación del F1 entre particiones es de 0.002, así que la ventaja del random forest sobre la logística (0.012) no es ruido.</a:t>
             </a:r>
-            <a:endParaRPr lang="en-US" dirty="0"/>
           </a:p>
         </p:txBody>
       </p:sp>
@@ -1484,7 +1254,6 @@
               <a:rPr lang="en-US" dirty="0"/>
               <a:t>Diagnóstico de sobreajuste: la brecha es F1 de entrenamiento menos F1 de validación. En el árbol, el F1 de validación se estanca desde profundidad 15 mientras el de entrenamiento sigue subiendo. En el random forest la brecha es esperada por la profundidad de sus árboles, y lo que importa es que validación y prueba coinciden.</a:t>
             </a:r>
-            <a:endParaRPr lang="en-US" dirty="0"/>
           </a:p>
         </p:txBody>
       </p:sp>
@@ -1572,7 +1341,6 @@
               <a:rPr lang="en-US" dirty="0"/>
               <a:t>Elegimos el modelo con la regla de la propuesta (mayor F1 macro) antes de ver la prueba, y la prueba se usó una sola vez. De las 14,726 personas marcadas como diabetes, el 34% la tiene y el 37% tiene diabetes o prediabetes. Como filtro para recomendar una prueba médica, es preferible una prueba de más que dejar pasar a alguien con diabetes.</a:t>
             </a:r>
-            <a:endParaRPr lang="en-US" dirty="0"/>
           </a:p>
         </p:txBody>
       </p:sp>
@@ -1645,6 +1413,11 @@
 <file path=ppt/slideMasters/slideMaster1.xml><?xml version="1.0" encoding="utf-8"?>
 <p:sldMaster xmlns:a="http://schemas.openxmlformats.org/drawingml/2006/main" xmlns:r="http://schemas.openxmlformats.org/officeDocument/2006/relationships" xmlns:p="http://schemas.openxmlformats.org/presentationml/2006/main">
   <p:cSld>
+    <p:bg>
+      <p:bgRef idx="1001">
+        <a:schemeClr val="bg1"/>
+      </p:bgRef>
+    </p:bg>
     <p:spTree>
       <p:nvGrpSpPr>
         <p:cNvPr id="1" name=""/>
@@ -1927,6 +1700,7 @@
         <a:solidFill>
           <a:srgbClr val="0E4D45"/>
         </a:solidFill>
+        <a:effectLst/>
       </p:bgPr>
     </p:bg>
     <p:spTree>
@@ -1962,6 +1736,13 @@
           </a:solidFill>
           <a:ln/>
         </p:spPr>
+        <p:txBody>
+          <a:bodyPr/>
+          <a:lstStyle/>
+          <a:p>
+            <a:endParaRPr lang="en-US"/>
+          </a:p>
+        </p:txBody>
       </p:sp>
       <p:sp>
         <p:nvSpPr>
@@ -1982,6 +1763,13 @@
           </a:solidFill>
           <a:ln/>
         </p:spPr>
+        <p:txBody>
+          <a:bodyPr/>
+          <a:lstStyle/>
+          <a:p>
+            <a:endParaRPr lang="en-US"/>
+          </a:p>
+        </p:txBody>
       </p:sp>
       <p:sp>
         <p:nvSpPr>
@@ -2004,11 +1792,11 @@
           <a:bodyPr wrap="square" lIns="0" tIns="0" rIns="0" bIns="0" rtlCol="0" anchor="ctr"/>
           <a:lstStyle/>
           <a:p>
-            <a:pPr indent="0" marL="0">
-              <a:buNone/>
-            </a:pPr>
-            <a:r>
-              <a:rPr lang="en-US" sz="1300" b="1" spc="200" kern="0" dirty="0">
+            <a:pPr marL="0" indent="0">
+              <a:buNone/>
+            </a:pPr>
+            <a:r>
+              <a:rPr lang="en-US" sz="1300" b="1" kern="0" spc="200" dirty="0">
                 <a:solidFill>
                   <a:srgbClr val="A8D08D"/>
                 </a:solidFill>
@@ -2043,7 +1831,7 @@
           <a:bodyPr wrap="square" lIns="0" tIns="0" rIns="0" bIns="0" rtlCol="0" anchor="ctr"/>
           <a:lstStyle/>
           <a:p>
-            <a:pPr indent="0" marL="0">
+            <a:pPr marL="0" indent="0">
               <a:lnSpc>
                 <a:spcPts val="4400"/>
               </a:lnSpc>
@@ -2085,7 +1873,7 @@
           <a:bodyPr wrap="square" lIns="0" tIns="0" rIns="0" bIns="0" rtlCol="0" anchor="ctr"/>
           <a:lstStyle/>
           <a:p>
-            <a:pPr indent="0" marL="0">
+            <a:pPr marL="0" indent="0">
               <a:buNone/>
             </a:pPr>
             <a:r>
@@ -2124,7 +1912,7 @@
           <a:bodyPr wrap="square" lIns="0" tIns="0" rIns="0" bIns="0" rtlCol="0" anchor="ctr"/>
           <a:lstStyle/>
           <a:p>
-            <a:pPr indent="0" marL="0">
+            <a:pPr marL="0" indent="0">
               <a:buNone/>
             </a:pPr>
             <a:r>
@@ -2163,7 +1951,7 @@
           <a:bodyPr wrap="square" lIns="0" tIns="0" rIns="0" bIns="0" rtlCol="0" anchor="ctr"/>
           <a:lstStyle/>
           <a:p>
-            <a:pPr indent="0" marL="0">
+            <a:pPr marL="0" indent="0">
               <a:buNone/>
             </a:pPr>
             <a:r>
@@ -2202,7 +1990,7 @@
           <a:bodyPr wrap="square" lIns="0" tIns="0" rIns="0" bIns="0" rtlCol="0" anchor="ctr"/>
           <a:lstStyle/>
           <a:p>
-            <a:pPr indent="0" marL="0">
+            <a:pPr marL="0" indent="0">
               <a:buNone/>
             </a:pPr>
             <a:r>
@@ -2264,6 +2052,13 @@
           </a:solidFill>
           <a:ln/>
         </p:spPr>
+        <p:txBody>
+          <a:bodyPr/>
+          <a:lstStyle/>
+          <a:p>
+            <a:endParaRPr lang="en-US"/>
+          </a:p>
+        </p:txBody>
       </p:sp>
       <p:sp>
         <p:nvSpPr>
@@ -2286,7 +2081,7 @@
           <a:bodyPr wrap="square" lIns="0" tIns="0" rIns="0" bIns="0" rtlCol="0" anchor="ctr"/>
           <a:lstStyle/>
           <a:p>
-            <a:pPr algn="ctr" indent="0" marL="0">
+            <a:pPr marL="0" indent="0" algn="ctr">
               <a:buNone/>
             </a:pPr>
             <a:r>
@@ -2325,11 +2120,11 @@
           <a:bodyPr wrap="square" lIns="0" tIns="0" rIns="0" bIns="0" rtlCol="0" anchor="ctr"/>
           <a:lstStyle/>
           <a:p>
-            <a:pPr indent="0" marL="0">
-              <a:buNone/>
-            </a:pPr>
-            <a:r>
-              <a:rPr lang="en-US" sz="1100" b="1" spc="140" kern="0" dirty="0">
+            <a:pPr marL="0" indent="0">
+              <a:buNone/>
+            </a:pPr>
+            <a:r>
+              <a:rPr lang="en-US" sz="1100" b="1" kern="0" spc="140" dirty="0">
                 <a:solidFill>
                   <a:srgbClr val="3F8A26"/>
                 </a:solidFill>
@@ -2364,7 +2159,7 @@
           <a:bodyPr wrap="square" lIns="0" tIns="0" rIns="0" bIns="0" rtlCol="0" anchor="t"/>
           <a:lstStyle/>
           <a:p>
-            <a:pPr indent="0" marL="0">
+            <a:pPr marL="0" indent="0">
               <a:buNone/>
             </a:pPr>
             <a:r>
@@ -2408,6 +2203,13 @@
             <a:prstDash val="solid"/>
           </a:ln>
         </p:spPr>
+        <p:txBody>
+          <a:bodyPr/>
+          <a:lstStyle/>
+          <a:p>
+            <a:endParaRPr lang="en-US"/>
+          </a:p>
+        </p:txBody>
       </p:sp>
       <p:sp>
         <p:nvSpPr>
@@ -2430,7 +2232,7 @@
           <a:bodyPr wrap="square" lIns="0" tIns="0" rIns="0" bIns="0" rtlCol="0" anchor="ctr"/>
           <a:lstStyle/>
           <a:p>
-            <a:pPr indent="0" marL="0">
+            <a:pPr marL="0" indent="0">
               <a:buNone/>
             </a:pPr>
             <a:r>
@@ -2559,6 +2361,13 @@
             <a:prstDash val="solid"/>
           </a:ln>
         </p:spPr>
+        <p:txBody>
+          <a:bodyPr/>
+          <a:lstStyle/>
+          <a:p>
+            <a:endParaRPr lang="en-US"/>
+          </a:p>
+        </p:txBody>
       </p:sp>
       <p:sp>
         <p:nvSpPr>
@@ -2581,7 +2390,7 @@
           <a:bodyPr wrap="square" lIns="0" tIns="0" rIns="0" bIns="0" rtlCol="0" anchor="ctr"/>
           <a:lstStyle/>
           <a:p>
-            <a:pPr indent="0" marL="0">
+            <a:pPr marL="0" indent="0">
               <a:buNone/>
             </a:pPr>
             <a:r>
@@ -2689,6 +2498,13 @@
             <a:prstDash val="solid"/>
           </a:ln>
         </p:spPr>
+        <p:txBody>
+          <a:bodyPr/>
+          <a:lstStyle/>
+          <a:p>
+            <a:endParaRPr lang="en-US"/>
+          </a:p>
+        </p:txBody>
       </p:sp>
       <p:sp>
         <p:nvSpPr>
@@ -2711,7 +2527,7 @@
           <a:bodyPr wrap="square" lIns="0" tIns="0" rIns="0" bIns="0" rtlCol="0" anchor="ctr"/>
           <a:lstStyle/>
           <a:p>
-            <a:pPr indent="0" marL="0">
+            <a:pPr marL="0" indent="0">
               <a:buNone/>
             </a:pPr>
             <a:r>
@@ -2814,7 +2630,7 @@
           <a:bodyPr wrap="square" lIns="0" tIns="0" rIns="0" bIns="0" rtlCol="0" anchor="ctr"/>
           <a:lstStyle/>
           <a:p>
-            <a:pPr algn="r" indent="0" marL="0">
+            <a:pPr marL="0" indent="0" algn="r">
               <a:buNone/>
             </a:pPr>
             <a:r>
@@ -2876,6 +2692,13 @@
           </a:solidFill>
           <a:ln/>
         </p:spPr>
+        <p:txBody>
+          <a:bodyPr/>
+          <a:lstStyle/>
+          <a:p>
+            <a:endParaRPr lang="en-US"/>
+          </a:p>
+        </p:txBody>
       </p:sp>
       <p:sp>
         <p:nvSpPr>
@@ -2898,7 +2721,7 @@
           <a:bodyPr wrap="square" lIns="0" tIns="0" rIns="0" bIns="0" rtlCol="0" anchor="ctr"/>
           <a:lstStyle/>
           <a:p>
-            <a:pPr algn="ctr" indent="0" marL="0">
+            <a:pPr marL="0" indent="0" algn="ctr">
               <a:buNone/>
             </a:pPr>
             <a:r>
@@ -2937,11 +2760,11 @@
           <a:bodyPr wrap="square" lIns="0" tIns="0" rIns="0" bIns="0" rtlCol="0" anchor="ctr"/>
           <a:lstStyle/>
           <a:p>
-            <a:pPr indent="0" marL="0">
-              <a:buNone/>
-            </a:pPr>
-            <a:r>
-              <a:rPr lang="en-US" sz="1100" b="1" spc="140" kern="0" dirty="0">
+            <a:pPr marL="0" indent="0">
+              <a:buNone/>
+            </a:pPr>
+            <a:r>
+              <a:rPr lang="en-US" sz="1100" b="1" kern="0" spc="140" dirty="0">
                 <a:solidFill>
                   <a:srgbClr val="3F8A26"/>
                 </a:solidFill>
@@ -2976,7 +2799,7 @@
           <a:bodyPr wrap="square" lIns="0" tIns="0" rIns="0" bIns="0" rtlCol="0" anchor="t"/>
           <a:lstStyle/>
           <a:p>
-            <a:pPr indent="0" marL="0">
+            <a:pPr marL="0" indent="0">
               <a:buNone/>
             </a:pPr>
             <a:r>
@@ -3020,6 +2843,13 @@
             <a:prstDash val="solid"/>
           </a:ln>
         </p:spPr>
+        <p:txBody>
+          <a:bodyPr/>
+          <a:lstStyle/>
+          <a:p>
+            <a:endParaRPr lang="en-US"/>
+          </a:p>
+        </p:txBody>
       </p:sp>
       <p:sp>
         <p:nvSpPr>
@@ -3042,7 +2872,7 @@
           <a:bodyPr wrap="square" lIns="0" tIns="0" rIns="0" bIns="0" rtlCol="0" anchor="ctr"/>
           <a:lstStyle/>
           <a:p>
-            <a:pPr indent="0" marL="0">
+            <a:pPr marL="0" indent="0">
               <a:buNone/>
             </a:pPr>
             <a:r>
@@ -3171,6 +3001,13 @@
             <a:prstDash val="solid"/>
           </a:ln>
         </p:spPr>
+        <p:txBody>
+          <a:bodyPr/>
+          <a:lstStyle/>
+          <a:p>
+            <a:endParaRPr lang="en-US"/>
+          </a:p>
+        </p:txBody>
       </p:sp>
       <p:sp>
         <p:nvSpPr>
@@ -3193,7 +3030,7 @@
           <a:bodyPr wrap="square" lIns="0" tIns="0" rIns="0" bIns="0" rtlCol="0" anchor="ctr"/>
           <a:lstStyle/>
           <a:p>
-            <a:pPr indent="0" marL="0">
+            <a:pPr marL="0" indent="0">
               <a:buNone/>
             </a:pPr>
             <a:r>
@@ -3338,7 +3175,7 @@
           <a:bodyPr wrap="square" lIns="0" tIns="0" rIns="0" bIns="0" rtlCol="0" anchor="ctr"/>
           <a:lstStyle/>
           <a:p>
-            <a:pPr algn="r" indent="0" marL="0">
+            <a:pPr marL="0" indent="0" algn="r">
               <a:buNone/>
             </a:pPr>
             <a:r>
@@ -3400,6 +3237,13 @@
           </a:solidFill>
           <a:ln/>
         </p:spPr>
+        <p:txBody>
+          <a:bodyPr/>
+          <a:lstStyle/>
+          <a:p>
+            <a:endParaRPr lang="en-US"/>
+          </a:p>
+        </p:txBody>
       </p:sp>
       <p:sp>
         <p:nvSpPr>
@@ -3422,7 +3266,7 @@
           <a:bodyPr wrap="square" lIns="0" tIns="0" rIns="0" bIns="0" rtlCol="0" anchor="ctr"/>
           <a:lstStyle/>
           <a:p>
-            <a:pPr algn="ctr" indent="0" marL="0">
+            <a:pPr marL="0" indent="0" algn="ctr">
               <a:buNone/>
             </a:pPr>
             <a:r>
@@ -3461,11 +3305,11 @@
           <a:bodyPr wrap="square" lIns="0" tIns="0" rIns="0" bIns="0" rtlCol="0" anchor="ctr"/>
           <a:lstStyle/>
           <a:p>
-            <a:pPr indent="0" marL="0">
-              <a:buNone/>
-            </a:pPr>
-            <a:r>
-              <a:rPr lang="en-US" sz="1100" b="1" spc="140" kern="0" dirty="0">
+            <a:pPr marL="0" indent="0">
+              <a:buNone/>
+            </a:pPr>
+            <a:r>
+              <a:rPr lang="en-US" sz="1100" b="1" kern="0" spc="140" dirty="0">
                 <a:solidFill>
                   <a:srgbClr val="3F8A26"/>
                 </a:solidFill>
@@ -3500,7 +3344,7 @@
           <a:bodyPr wrap="square" lIns="0" tIns="0" rIns="0" bIns="0" rtlCol="0" anchor="t"/>
           <a:lstStyle/>
           <a:p>
-            <a:pPr indent="0" marL="0">
+            <a:pPr marL="0" indent="0">
               <a:buNone/>
             </a:pPr>
             <a:r>
@@ -3544,6 +3388,13 @@
             <a:prstDash val="solid"/>
           </a:ln>
         </p:spPr>
+        <p:txBody>
+          <a:bodyPr/>
+          <a:lstStyle/>
+          <a:p>
+            <a:endParaRPr lang="en-US"/>
+          </a:p>
+        </p:txBody>
       </p:sp>
       <p:sp>
         <p:nvSpPr>
@@ -3566,7 +3417,7 @@
           <a:bodyPr wrap="square" lIns="0" tIns="0" rIns="0" bIns="0" rtlCol="0" anchor="ctr"/>
           <a:lstStyle/>
           <a:p>
-            <a:pPr indent="0" marL="0">
+            <a:pPr marL="0" indent="0">
               <a:buNone/>
             </a:pPr>
             <a:r>
@@ -3674,6 +3525,13 @@
             <a:prstDash val="solid"/>
           </a:ln>
         </p:spPr>
+        <p:txBody>
+          <a:bodyPr/>
+          <a:lstStyle/>
+          <a:p>
+            <a:endParaRPr lang="en-US"/>
+          </a:p>
+        </p:txBody>
       </p:sp>
       <p:sp>
         <p:nvSpPr>
@@ -3696,7 +3554,7 @@
           <a:bodyPr wrap="square" lIns="0" tIns="0" rIns="0" bIns="0" rtlCol="0" anchor="ctr"/>
           <a:lstStyle/>
           <a:p>
-            <a:pPr indent="0" marL="0">
+            <a:pPr marL="0" indent="0">
               <a:buNone/>
             </a:pPr>
             <a:r>
@@ -3825,6 +3683,13 @@
             <a:prstDash val="solid"/>
           </a:ln>
         </p:spPr>
+        <p:txBody>
+          <a:bodyPr/>
+          <a:lstStyle/>
+          <a:p>
+            <a:endParaRPr lang="en-US"/>
+          </a:p>
+        </p:txBody>
       </p:sp>
       <p:sp>
         <p:nvSpPr>
@@ -3847,7 +3712,7 @@
           <a:bodyPr wrap="square" lIns="0" tIns="0" rIns="0" bIns="0" rtlCol="0" anchor="ctr"/>
           <a:lstStyle/>
           <a:p>
-            <a:pPr indent="0" marL="0">
+            <a:pPr marL="0" indent="0">
               <a:buNone/>
             </a:pPr>
             <a:r>
@@ -3971,7 +3836,7 @@
           <a:bodyPr wrap="square" lIns="0" tIns="0" rIns="0" bIns="0" rtlCol="0" anchor="ctr"/>
           <a:lstStyle/>
           <a:p>
-            <a:pPr algn="r" indent="0" marL="0">
+            <a:pPr marL="0" indent="0" algn="r">
               <a:buNone/>
             </a:pPr>
             <a:r>
@@ -4033,6 +3898,13 @@
           </a:solidFill>
           <a:ln/>
         </p:spPr>
+        <p:txBody>
+          <a:bodyPr/>
+          <a:lstStyle/>
+          <a:p>
+            <a:endParaRPr lang="en-US"/>
+          </a:p>
+        </p:txBody>
       </p:sp>
       <p:sp>
         <p:nvSpPr>
@@ -4055,7 +3927,7 @@
           <a:bodyPr wrap="square" lIns="0" tIns="0" rIns="0" bIns="0" rtlCol="0" anchor="ctr"/>
           <a:lstStyle/>
           <a:p>
-            <a:pPr algn="ctr" indent="0" marL="0">
+            <a:pPr marL="0" indent="0" algn="ctr">
               <a:buNone/>
             </a:pPr>
             <a:r>
@@ -4094,11 +3966,11 @@
           <a:bodyPr wrap="square" lIns="0" tIns="0" rIns="0" bIns="0" rtlCol="0" anchor="ctr"/>
           <a:lstStyle/>
           <a:p>
-            <a:pPr indent="0" marL="0">
-              <a:buNone/>
-            </a:pPr>
-            <a:r>
-              <a:rPr lang="en-US" sz="1100" b="1" spc="140" kern="0" dirty="0">
+            <a:pPr marL="0" indent="0">
+              <a:buNone/>
+            </a:pPr>
+            <a:r>
+              <a:rPr lang="en-US" sz="1100" b="1" kern="0" spc="140" dirty="0">
                 <a:solidFill>
                   <a:srgbClr val="3F8A26"/>
                 </a:solidFill>
@@ -4133,7 +4005,7 @@
           <a:bodyPr wrap="square" lIns="0" tIns="0" rIns="0" bIns="0" rtlCol="0" anchor="t"/>
           <a:lstStyle/>
           <a:p>
-            <a:pPr indent="0" marL="0">
+            <a:pPr marL="0" indent="0">
               <a:buNone/>
             </a:pPr>
             <a:r>
@@ -4177,6 +4049,13 @@
             <a:prstDash val="solid"/>
           </a:ln>
         </p:spPr>
+        <p:txBody>
+          <a:bodyPr/>
+          <a:lstStyle/>
+          <a:p>
+            <a:endParaRPr lang="en-US"/>
+          </a:p>
+        </p:txBody>
       </p:sp>
       <p:sp>
         <p:nvSpPr>
@@ -4199,7 +4078,7 @@
           <a:bodyPr wrap="square" lIns="0" tIns="0" rIns="0" bIns="0" rtlCol="0" anchor="ctr"/>
           <a:lstStyle/>
           <a:p>
-            <a:pPr indent="0" marL="0">
+            <a:pPr marL="0" indent="0">
               <a:buNone/>
             </a:pPr>
             <a:r>
@@ -4310,7 +4189,7 @@
         </p:nvSpPr>
         <p:spPr>
           <a:xfrm>
-            <a:off x="548640" y="4123944"/>
+            <a:off x="3403092" y="4134767"/>
             <a:ext cx="5385816" cy="2048256"/>
           </a:xfrm>
           <a:prstGeom prst="roundRect">
@@ -4328,6 +4207,13 @@
             <a:prstDash val="solid"/>
           </a:ln>
         </p:spPr>
+        <p:txBody>
+          <a:bodyPr/>
+          <a:lstStyle/>
+          <a:p>
+            <a:endParaRPr lang="en-US"/>
+          </a:p>
+        </p:txBody>
       </p:sp>
       <p:sp>
         <p:nvSpPr>
@@ -4337,7 +4223,7 @@
         </p:nvSpPr>
         <p:spPr>
           <a:xfrm>
-            <a:off x="804672" y="4325112"/>
+            <a:off x="3659124" y="4335935"/>
             <a:ext cx="4873752" cy="347472"/>
           </a:xfrm>
           <a:prstGeom prst="rect">
@@ -4350,7 +4236,7 @@
           <a:bodyPr wrap="square" lIns="0" tIns="0" rIns="0" bIns="0" rtlCol="0" anchor="ctr"/>
           <a:lstStyle/>
           <a:p>
-            <a:pPr indent="0" marL="0">
+            <a:pPr marL="0" indent="0">
               <a:buNone/>
             </a:pPr>
             <a:r>
@@ -4376,7 +4262,7 @@
         </p:nvSpPr>
         <p:spPr>
           <a:xfrm>
-            <a:off x="804672" y="4727448"/>
+            <a:off x="3659124" y="4738271"/>
             <a:ext cx="4873752" cy="1225296"/>
           </a:xfrm>
           <a:prstGeom prst="rect">
@@ -4434,111 +4320,6 @@
       </p:sp>
       <p:sp>
         <p:nvSpPr>
-          <p:cNvPr id="12" name="Shape 10"/>
-          <p:cNvSpPr/>
-          <p:nvPr/>
-        </p:nvSpPr>
-        <p:spPr>
-          <a:xfrm>
-            <a:off x="6227064" y="4123944"/>
-            <a:ext cx="5385816" cy="2048256"/>
-          </a:xfrm>
-          <a:prstGeom prst="roundRect">
-            <a:avLst>
-              <a:gd name="adj" fmla="val 2232"/>
-            </a:avLst>
-          </a:prstGeom>
-          <a:solidFill>
-            <a:srgbClr val="EEF4EF"/>
-          </a:solidFill>
-          <a:ln w="9525">
-            <a:solidFill>
-              <a:srgbClr val="D4E2D6"/>
-            </a:solidFill>
-            <a:prstDash val="solid"/>
-          </a:ln>
-        </p:spPr>
-      </p:sp>
-      <p:sp>
-        <p:nvSpPr>
-          <p:cNvPr id="13" name="Text 11"/>
-          <p:cNvSpPr/>
-          <p:nvPr/>
-        </p:nvSpPr>
-        <p:spPr>
-          <a:xfrm>
-            <a:off x="6483096" y="4325112"/>
-            <a:ext cx="4873752" cy="347472"/>
-          </a:xfrm>
-          <a:prstGeom prst="rect">
-            <a:avLst/>
-          </a:prstGeom>
-          <a:noFill/>
-          <a:ln/>
-        </p:spPr>
-        <p:txBody>
-          <a:bodyPr wrap="square" lIns="0" tIns="0" rIns="0" bIns="0" rtlCol="0" anchor="ctr"/>
-          <a:lstStyle/>
-          <a:p>
-            <a:pPr indent="0" marL="0">
-              <a:buNone/>
-            </a:pPr>
-            <a:r>
-              <a:rPr lang="en-US" sz="1300" b="1" dirty="0">
-                <a:solidFill>
-                  <a:srgbClr val="3F8A26"/>
-                </a:solidFill>
-                <a:latin typeface="Calibri" pitchFamily="34" charset="0"/>
-                <a:ea typeface="Calibri" pitchFamily="34" charset="-122"/>
-                <a:cs typeface="Calibri" pitchFamily="34" charset="-120"/>
-              </a:rPr>
-              <a:t>Uso de IA</a:t>
-            </a:r>
-            <a:endParaRPr lang="en-US" sz="1300" dirty="0"/>
-          </a:p>
-        </p:txBody>
-      </p:sp>
-      <p:sp>
-        <p:nvSpPr>
-          <p:cNvPr id="14" name="Text 12"/>
-          <p:cNvSpPr/>
-          <p:nvPr/>
-        </p:nvSpPr>
-        <p:spPr>
-          <a:xfrm>
-            <a:off x="6483096" y="4727448"/>
-            <a:ext cx="4873752" cy="1225296"/>
-          </a:xfrm>
-          <a:prstGeom prst="rect">
-            <a:avLst/>
-          </a:prstGeom>
-          <a:noFill/>
-          <a:ln/>
-        </p:spPr>
-        <p:txBody>
-          <a:bodyPr wrap="square" lIns="0" tIns="0" rIns="0" bIns="0" rtlCol="0" anchor="t"/>
-          <a:lstStyle/>
-          <a:p>
-            <a:pPr indent="0" marL="0">
-              <a:buNone/>
-            </a:pPr>
-            <a:r>
-              <a:rPr lang="en-US" sz="1200" dirty="0">
-                <a:solidFill>
-                  <a:srgbClr val="1E2A28"/>
-                </a:solidFill>
-                <a:latin typeface="Calibri" pitchFamily="34" charset="0"/>
-                <a:ea typeface="Calibri" pitchFamily="34" charset="-122"/>
-                <a:cs typeface="Calibri" pitchFamily="34" charset="-120"/>
-              </a:rPr>
-              <a:t>Usamos Claude Code como apoyo para escribir y depurar código y para el borrador del informe y la presentación. Revisamos, ejecutamos y verificamos todo a mano.</a:t>
-            </a:r>
-            <a:endParaRPr lang="en-US" sz="1200" dirty="0"/>
-          </a:p>
-        </p:txBody>
-      </p:sp>
-      <p:sp>
-        <p:nvSpPr>
           <p:cNvPr id="16" name="Text 13"/>
           <p:cNvSpPr/>
           <p:nvPr/>
@@ -4558,7 +4339,7 @@
           <a:bodyPr wrap="square" lIns="0" tIns="0" rIns="0" bIns="0" rtlCol="0" anchor="ctr"/>
           <a:lstStyle/>
           <a:p>
-            <a:pPr algn="r" indent="0" marL="0">
+            <a:pPr marL="0" indent="0" algn="r">
               <a:buNone/>
             </a:pPr>
             <a:r>
@@ -4573,6 +4354,38 @@
               <a:t>13</a:t>
             </a:r>
             <a:endParaRPr lang="en-US" sz="1000" dirty="0"/>
+          </a:p>
+        </p:txBody>
+      </p:sp>
+      <p:sp>
+        <p:nvSpPr>
+          <p:cNvPr id="15" name="TextBox 14">
+            <a:extLst>
+              <a:ext uri="{FF2B5EF4-FFF2-40B4-BE49-F238E27FC236}">
+                <a16:creationId xmlns:a16="http://schemas.microsoft.com/office/drawing/2014/main" id="{EBC31374-5D14-F461-251D-6583939C312F}"/>
+              </a:ext>
+            </a:extLst>
+          </p:cNvPr>
+          <p:cNvSpPr txBox="1"/>
+          <p:nvPr/>
+        </p:nvSpPr>
+        <p:spPr>
+          <a:xfrm>
+            <a:off x="6600497" y="5759669"/>
+            <a:ext cx="184731" cy="369332"/>
+          </a:xfrm>
+          <a:prstGeom prst="rect">
+            <a:avLst/>
+          </a:prstGeom>
+          <a:noFill/>
+        </p:spPr>
+        <p:txBody>
+          <a:bodyPr wrap="none" rtlCol="0">
+            <a:spAutoFit/>
+          </a:bodyPr>
+          <a:lstStyle/>
+          <a:p>
+            <a:endParaRPr lang="en-US" dirty="0"/>
           </a:p>
         </p:txBody>
       </p:sp>
@@ -4620,6 +4433,13 @@
           </a:solidFill>
           <a:ln/>
         </p:spPr>
+        <p:txBody>
+          <a:bodyPr/>
+          <a:lstStyle/>
+          <a:p>
+            <a:endParaRPr lang="en-US"/>
+          </a:p>
+        </p:txBody>
       </p:sp>
       <p:sp>
         <p:nvSpPr>
@@ -4642,7 +4462,7 @@
           <a:bodyPr wrap="square" lIns="0" tIns="0" rIns="0" bIns="0" rtlCol="0" anchor="ctr"/>
           <a:lstStyle/>
           <a:p>
-            <a:pPr algn="ctr" indent="0" marL="0">
+            <a:pPr marL="0" indent="0" algn="ctr">
               <a:buNone/>
             </a:pPr>
             <a:r>
@@ -4681,11 +4501,11 @@
           <a:bodyPr wrap="square" lIns="0" tIns="0" rIns="0" bIns="0" rtlCol="0" anchor="ctr"/>
           <a:lstStyle/>
           <a:p>
-            <a:pPr indent="0" marL="0">
-              <a:buNone/>
-            </a:pPr>
-            <a:r>
-              <a:rPr lang="en-US" sz="1100" b="1" spc="140" kern="0" dirty="0">
+            <a:pPr marL="0" indent="0">
+              <a:buNone/>
+            </a:pPr>
+            <a:r>
+              <a:rPr lang="en-US" sz="1100" b="1" kern="0" spc="140" dirty="0">
                 <a:solidFill>
                   <a:srgbClr val="3F8A26"/>
                 </a:solidFill>
@@ -4720,7 +4540,7 @@
           <a:bodyPr wrap="square" lIns="0" tIns="0" rIns="0" bIns="0" rtlCol="0" anchor="t"/>
           <a:lstStyle/>
           <a:p>
-            <a:pPr indent="0" marL="0">
+            <a:pPr marL="0" indent="0">
               <a:buNone/>
             </a:pPr>
             <a:r>
@@ -4764,6 +4584,13 @@
             <a:prstDash val="solid"/>
           </a:ln>
         </p:spPr>
+        <p:txBody>
+          <a:bodyPr/>
+          <a:lstStyle/>
+          <a:p>
+            <a:endParaRPr lang="en-US"/>
+          </a:p>
+        </p:txBody>
       </p:sp>
       <p:sp>
         <p:nvSpPr>
@@ -4786,7 +4613,7 @@
           <a:bodyPr wrap="square" lIns="0" tIns="0" rIns="0" bIns="0" rtlCol="0" anchor="ctr"/>
           <a:lstStyle/>
           <a:p>
-            <a:pPr indent="0" marL="0">
+            <a:pPr marL="0" indent="0">
               <a:buNone/>
             </a:pPr>
             <a:r>
@@ -4915,6 +4742,13 @@
             <a:prstDash val="solid"/>
           </a:ln>
         </p:spPr>
+        <p:txBody>
+          <a:bodyPr/>
+          <a:lstStyle/>
+          <a:p>
+            <a:endParaRPr lang="en-US"/>
+          </a:p>
+        </p:txBody>
       </p:sp>
       <p:sp>
         <p:nvSpPr>
@@ -4937,7 +4771,7 @@
           <a:bodyPr wrap="square" lIns="0" tIns="0" rIns="0" bIns="0" rtlCol="0" anchor="ctr"/>
           <a:lstStyle/>
           <a:p>
-            <a:pPr indent="0" marL="0">
+            <a:pPr marL="0" indent="0">
               <a:buNone/>
             </a:pPr>
             <a:r>
@@ -4976,7 +4810,7 @@
           <a:bodyPr wrap="square" lIns="0" tIns="0" rIns="0" bIns="0" rtlCol="0" anchor="t"/>
           <a:lstStyle/>
           <a:p>
-            <a:pPr indent="0" marL="0">
+            <a:pPr marL="0" indent="0">
               <a:buNone/>
             </a:pPr>
             <a:r>
@@ -5020,6 +4854,13 @@
             <a:prstDash val="solid"/>
           </a:ln>
         </p:spPr>
+        <p:txBody>
+          <a:bodyPr/>
+          <a:lstStyle/>
+          <a:p>
+            <a:endParaRPr lang="en-US"/>
+          </a:p>
+        </p:txBody>
       </p:sp>
       <p:sp>
         <p:nvSpPr>
@@ -5042,7 +4883,7 @@
           <a:bodyPr wrap="square" lIns="0" tIns="0" rIns="0" bIns="0" rtlCol="0" anchor="ctr"/>
           <a:lstStyle/>
           <a:p>
-            <a:pPr indent="0" marL="0">
+            <a:pPr marL="0" indent="0">
               <a:buNone/>
             </a:pPr>
             <a:r>
@@ -5081,7 +4922,7 @@
           <a:bodyPr wrap="square" lIns="0" tIns="0" rIns="0" bIns="0" rtlCol="0" anchor="t"/>
           <a:lstStyle/>
           <a:p>
-            <a:pPr indent="0" marL="0">
+            <a:pPr marL="0" indent="0">
               <a:buNone/>
             </a:pPr>
             <a:r>
@@ -5120,7 +4961,7 @@
           <a:bodyPr wrap="square" lIns="0" tIns="0" rIns="0" bIns="0" rtlCol="0" anchor="ctr"/>
           <a:lstStyle/>
           <a:p>
-            <a:pPr algn="r" indent="0" marL="0">
+            <a:pPr marL="0" indent="0" algn="r">
               <a:buNone/>
             </a:pPr>
             <a:r>
@@ -5182,6 +5023,13 @@
           </a:solidFill>
           <a:ln/>
         </p:spPr>
+        <p:txBody>
+          <a:bodyPr/>
+          <a:lstStyle/>
+          <a:p>
+            <a:endParaRPr lang="en-US"/>
+          </a:p>
+        </p:txBody>
       </p:sp>
       <p:sp>
         <p:nvSpPr>
@@ -5204,7 +5052,7 @@
           <a:bodyPr wrap="square" lIns="0" tIns="0" rIns="0" bIns="0" rtlCol="0" anchor="ctr"/>
           <a:lstStyle/>
           <a:p>
-            <a:pPr algn="ctr" indent="0" marL="0">
+            <a:pPr marL="0" indent="0" algn="ctr">
               <a:buNone/>
             </a:pPr>
             <a:r>
@@ -5243,11 +5091,11 @@
           <a:bodyPr wrap="square" lIns="0" tIns="0" rIns="0" bIns="0" rtlCol="0" anchor="ctr"/>
           <a:lstStyle/>
           <a:p>
-            <a:pPr indent="0" marL="0">
-              <a:buNone/>
-            </a:pPr>
-            <a:r>
-              <a:rPr lang="en-US" sz="1100" b="1" spc="140" kern="0" dirty="0">
+            <a:pPr marL="0" indent="0">
+              <a:buNone/>
+            </a:pPr>
+            <a:r>
+              <a:rPr lang="en-US" sz="1100" b="1" kern="0" spc="140" dirty="0">
                 <a:solidFill>
                   <a:srgbClr val="3F8A26"/>
                 </a:solidFill>
@@ -5282,7 +5130,7 @@
           <a:bodyPr wrap="square" lIns="0" tIns="0" rIns="0" bIns="0" rtlCol="0" anchor="t"/>
           <a:lstStyle/>
           <a:p>
-            <a:pPr indent="0" marL="0">
+            <a:pPr marL="0" indent="0">
               <a:buNone/>
             </a:pPr>
             <a:r>
@@ -5302,14 +5150,14 @@
       </p:sp>
       <p:pic>
         <p:nvPicPr>
-          <p:cNvPr id="6" name="Image 0" descr="/private/tmp/claude-501/-Users-fabianprado-Documents-projects-2026---2--ai-proyecto2/d453a1b3-ccc3-45e2-95e4-06fb0c8b1ac2/scratchpad/figs/eda_objetivo.png">    </p:cNvPr>
+          <p:cNvPr id="6" name="Image 0" descr="/private/tmp/claude-501/-Users-fabianprado-Documents-projects-2026---2--ai-proyecto2/d453a1b3-ccc3-45e2-95e4-06fb0c8b1ac2/scratchpad/figs/eda_objetivo.png"/>
           <p:cNvPicPr>
             <a:picLocks noChangeAspect="1"/>
           </p:cNvPicPr>
           <p:nvPr/>
         </p:nvPicPr>
         <p:blipFill>
-          <a:blip r:embed="rId1"/>
+          <a:blip r:embed="rId3"/>
           <a:stretch>
             <a:fillRect/>
           </a:stretch>
@@ -5350,6 +5198,13 @@
             <a:prstDash val="solid"/>
           </a:ln>
         </p:spPr>
+        <p:txBody>
+          <a:bodyPr/>
+          <a:lstStyle/>
+          <a:p>
+            <a:endParaRPr lang="en-US"/>
+          </a:p>
+        </p:txBody>
       </p:sp>
       <p:sp>
         <p:nvSpPr>
@@ -5372,7 +5227,7 @@
           <a:bodyPr wrap="square" lIns="0" tIns="0" rIns="0" bIns="0" rtlCol="0" anchor="ctr"/>
           <a:lstStyle/>
           <a:p>
-            <a:pPr indent="0" marL="0">
+            <a:pPr marL="0" indent="0">
               <a:buNone/>
             </a:pPr>
             <a:r>
@@ -5538,7 +5393,7 @@
           <a:bodyPr wrap="square" lIns="0" tIns="0" rIns="0" bIns="0" rtlCol="0" anchor="ctr"/>
           <a:lstStyle/>
           <a:p>
-            <a:pPr algn="r" indent="0" marL="0">
+            <a:pPr marL="0" indent="0" algn="r">
               <a:buNone/>
             </a:pPr>
             <a:r>
@@ -5600,6 +5455,13 @@
           </a:solidFill>
           <a:ln/>
         </p:spPr>
+        <p:txBody>
+          <a:bodyPr/>
+          <a:lstStyle/>
+          <a:p>
+            <a:endParaRPr lang="en-US"/>
+          </a:p>
+        </p:txBody>
       </p:sp>
       <p:sp>
         <p:nvSpPr>
@@ -5622,7 +5484,7 @@
           <a:bodyPr wrap="square" lIns="0" tIns="0" rIns="0" bIns="0" rtlCol="0" anchor="ctr"/>
           <a:lstStyle/>
           <a:p>
-            <a:pPr algn="ctr" indent="0" marL="0">
+            <a:pPr marL="0" indent="0" algn="ctr">
               <a:buNone/>
             </a:pPr>
             <a:r>
@@ -5661,11 +5523,11 @@
           <a:bodyPr wrap="square" lIns="0" tIns="0" rIns="0" bIns="0" rtlCol="0" anchor="ctr"/>
           <a:lstStyle/>
           <a:p>
-            <a:pPr indent="0" marL="0">
-              <a:buNone/>
-            </a:pPr>
-            <a:r>
-              <a:rPr lang="en-US" sz="1100" b="1" spc="140" kern="0" dirty="0">
+            <a:pPr marL="0" indent="0">
+              <a:buNone/>
+            </a:pPr>
+            <a:r>
+              <a:rPr lang="en-US" sz="1100" b="1" kern="0" spc="140" dirty="0">
                 <a:solidFill>
                   <a:srgbClr val="3F8A26"/>
                 </a:solidFill>
@@ -5700,7 +5562,7 @@
           <a:bodyPr wrap="square" lIns="0" tIns="0" rIns="0" bIns="0" rtlCol="0" anchor="t"/>
           <a:lstStyle/>
           <a:p>
-            <a:pPr indent="0" marL="0">
+            <a:pPr marL="0" indent="0">
               <a:buNone/>
             </a:pPr>
             <a:r>
@@ -5720,14 +5582,14 @@
       </p:sp>
       <p:pic>
         <p:nvPicPr>
-          <p:cNvPr id="6" name="Image 0" descr="/private/tmp/claude-501/-Users-fabianprado-Documents-projects-2026---2--ai-proyecto2/d453a1b3-ccc3-45e2-95e4-06fb0c8b1ac2/scratchpad/figs/eda_factores.png">    </p:cNvPr>
+          <p:cNvPr id="6" name="Image 0" descr="/private/tmp/claude-501/-Users-fabianprado-Documents-projects-2026---2--ai-proyecto2/d453a1b3-ccc3-45e2-95e4-06fb0c8b1ac2/scratchpad/figs/eda_factores.png"/>
           <p:cNvPicPr>
             <a:picLocks noChangeAspect="1"/>
           </p:cNvPicPr>
           <p:nvPr/>
         </p:nvPicPr>
         <p:blipFill>
-          <a:blip r:embed="rId1"/>
+          <a:blip r:embed="rId3"/>
           <a:stretch>
             <a:fillRect/>
           </a:stretch>
@@ -5768,6 +5630,13 @@
             <a:prstDash val="solid"/>
           </a:ln>
         </p:spPr>
+        <p:txBody>
+          <a:bodyPr/>
+          <a:lstStyle/>
+          <a:p>
+            <a:endParaRPr lang="en-US"/>
+          </a:p>
+        </p:txBody>
       </p:sp>
       <p:sp>
         <p:nvSpPr>
@@ -5790,7 +5659,7 @@
           <a:bodyPr wrap="square" lIns="0" tIns="0" rIns="0" bIns="0" rtlCol="0" anchor="ctr"/>
           <a:lstStyle/>
           <a:p>
-            <a:pPr indent="0" marL="0">
+            <a:pPr marL="0" indent="0">
               <a:buNone/>
             </a:pPr>
             <a:r>
@@ -5935,7 +5804,7 @@
           <a:bodyPr wrap="square" lIns="0" tIns="0" rIns="0" bIns="0" rtlCol="0" anchor="ctr"/>
           <a:lstStyle/>
           <a:p>
-            <a:pPr algn="r" indent="0" marL="0">
+            <a:pPr marL="0" indent="0" algn="r">
               <a:buNone/>
             </a:pPr>
             <a:r>
@@ -5997,6 +5866,13 @@
           </a:solidFill>
           <a:ln/>
         </p:spPr>
+        <p:txBody>
+          <a:bodyPr/>
+          <a:lstStyle/>
+          <a:p>
+            <a:endParaRPr lang="en-US"/>
+          </a:p>
+        </p:txBody>
       </p:sp>
       <p:sp>
         <p:nvSpPr>
@@ -6019,7 +5895,7 @@
           <a:bodyPr wrap="square" lIns="0" tIns="0" rIns="0" bIns="0" rtlCol="0" anchor="ctr"/>
           <a:lstStyle/>
           <a:p>
-            <a:pPr algn="ctr" indent="0" marL="0">
+            <a:pPr marL="0" indent="0" algn="ctr">
               <a:buNone/>
             </a:pPr>
             <a:r>
@@ -6058,11 +5934,11 @@
           <a:bodyPr wrap="square" lIns="0" tIns="0" rIns="0" bIns="0" rtlCol="0" anchor="ctr"/>
           <a:lstStyle/>
           <a:p>
-            <a:pPr indent="0" marL="0">
-              <a:buNone/>
-            </a:pPr>
-            <a:r>
-              <a:rPr lang="en-US" sz="1100" b="1" spc="140" kern="0" dirty="0">
+            <a:pPr marL="0" indent="0">
+              <a:buNone/>
+            </a:pPr>
+            <a:r>
+              <a:rPr lang="en-US" sz="1100" b="1" kern="0" spc="140" dirty="0">
                 <a:solidFill>
                   <a:srgbClr val="3F8A26"/>
                 </a:solidFill>
@@ -6097,7 +5973,7 @@
           <a:bodyPr wrap="square" lIns="0" tIns="0" rIns="0" bIns="0" rtlCol="0" anchor="t"/>
           <a:lstStyle/>
           <a:p>
-            <a:pPr indent="0" marL="0">
+            <a:pPr marL="0" indent="0">
               <a:buNone/>
             </a:pPr>
             <a:r>
@@ -6141,6 +6017,13 @@
             <a:prstDash val="solid"/>
           </a:ln>
         </p:spPr>
+        <p:txBody>
+          <a:bodyPr/>
+          <a:lstStyle/>
+          <a:p>
+            <a:endParaRPr lang="en-US"/>
+          </a:p>
+        </p:txBody>
       </p:sp>
       <p:sp>
         <p:nvSpPr>
@@ -6161,6 +6044,13 @@
           </a:solidFill>
           <a:ln/>
         </p:spPr>
+        <p:txBody>
+          <a:bodyPr/>
+          <a:lstStyle/>
+          <a:p>
+            <a:endParaRPr lang="en-US"/>
+          </a:p>
+        </p:txBody>
       </p:sp>
       <p:sp>
         <p:nvSpPr>
@@ -6183,7 +6073,7 @@
           <a:bodyPr wrap="square" lIns="0" tIns="0" rIns="0" bIns="0" rtlCol="0" anchor="ctr"/>
           <a:lstStyle/>
           <a:p>
-            <a:pPr algn="ctr" indent="0" marL="0">
+            <a:pPr marL="0" indent="0" algn="ctr">
               <a:buNone/>
             </a:pPr>
             <a:r>
@@ -6222,7 +6112,7 @@
           <a:bodyPr wrap="square" lIns="0" tIns="0" rIns="0" bIns="0" rtlCol="0" anchor="ctr"/>
           <a:lstStyle/>
           <a:p>
-            <a:pPr indent="0" marL="0">
+            <a:pPr marL="0" indent="0">
               <a:buNone/>
             </a:pPr>
             <a:r>
@@ -6351,6 +6241,13 @@
             <a:prstDash val="solid"/>
           </a:ln>
         </p:spPr>
+        <p:txBody>
+          <a:bodyPr/>
+          <a:lstStyle/>
+          <a:p>
+            <a:endParaRPr lang="en-US"/>
+          </a:p>
+        </p:txBody>
       </p:sp>
       <p:sp>
         <p:nvSpPr>
@@ -6371,6 +6268,13 @@
           </a:solidFill>
           <a:ln/>
         </p:spPr>
+        <p:txBody>
+          <a:bodyPr/>
+          <a:lstStyle/>
+          <a:p>
+            <a:endParaRPr lang="en-US"/>
+          </a:p>
+        </p:txBody>
       </p:sp>
       <p:sp>
         <p:nvSpPr>
@@ -6393,7 +6297,7 @@
           <a:bodyPr wrap="square" lIns="0" tIns="0" rIns="0" bIns="0" rtlCol="0" anchor="ctr"/>
           <a:lstStyle/>
           <a:p>
-            <a:pPr algn="ctr" indent="0" marL="0">
+            <a:pPr marL="0" indent="0" algn="ctr">
               <a:buNone/>
             </a:pPr>
             <a:r>
@@ -6432,7 +6336,7 @@
           <a:bodyPr wrap="square" lIns="0" tIns="0" rIns="0" bIns="0" rtlCol="0" anchor="ctr"/>
           <a:lstStyle/>
           <a:p>
-            <a:pPr indent="0" marL="0">
+            <a:pPr marL="0" indent="0">
               <a:buNone/>
             </a:pPr>
             <a:r>
@@ -6540,6 +6444,13 @@
             <a:prstDash val="solid"/>
           </a:ln>
         </p:spPr>
+        <p:txBody>
+          <a:bodyPr/>
+          <a:lstStyle/>
+          <a:p>
+            <a:endParaRPr lang="en-US"/>
+          </a:p>
+        </p:txBody>
       </p:sp>
       <p:sp>
         <p:nvSpPr>
@@ -6560,6 +6471,13 @@
           </a:solidFill>
           <a:ln/>
         </p:spPr>
+        <p:txBody>
+          <a:bodyPr/>
+          <a:lstStyle/>
+          <a:p>
+            <a:endParaRPr lang="en-US"/>
+          </a:p>
+        </p:txBody>
       </p:sp>
       <p:sp>
         <p:nvSpPr>
@@ -6582,7 +6500,7 @@
           <a:bodyPr wrap="square" lIns="0" tIns="0" rIns="0" bIns="0" rtlCol="0" anchor="ctr"/>
           <a:lstStyle/>
           <a:p>
-            <a:pPr algn="ctr" indent="0" marL="0">
+            <a:pPr marL="0" indent="0" algn="ctr">
               <a:buNone/>
             </a:pPr>
             <a:r>
@@ -6621,7 +6539,7 @@
           <a:bodyPr wrap="square" lIns="0" tIns="0" rIns="0" bIns="0" rtlCol="0" anchor="ctr"/>
           <a:lstStyle/>
           <a:p>
-            <a:pPr indent="0" marL="0">
+            <a:pPr marL="0" indent="0">
               <a:buNone/>
             </a:pPr>
             <a:r>
@@ -6729,6 +6647,13 @@
             <a:prstDash val="solid"/>
           </a:ln>
         </p:spPr>
+        <p:txBody>
+          <a:bodyPr/>
+          <a:lstStyle/>
+          <a:p>
+            <a:endParaRPr lang="en-US"/>
+          </a:p>
+        </p:txBody>
       </p:sp>
       <p:sp>
         <p:nvSpPr>
@@ -6749,6 +6674,13 @@
           </a:solidFill>
           <a:ln/>
         </p:spPr>
+        <p:txBody>
+          <a:bodyPr/>
+          <a:lstStyle/>
+          <a:p>
+            <a:endParaRPr lang="en-US"/>
+          </a:p>
+        </p:txBody>
       </p:sp>
       <p:sp>
         <p:nvSpPr>
@@ -6771,7 +6703,7 @@
           <a:bodyPr wrap="square" lIns="0" tIns="0" rIns="0" bIns="0" rtlCol="0" anchor="ctr"/>
           <a:lstStyle/>
           <a:p>
-            <a:pPr algn="ctr" indent="0" marL="0">
+            <a:pPr marL="0" indent="0" algn="ctr">
               <a:buNone/>
             </a:pPr>
             <a:r>
@@ -6810,7 +6742,7 @@
           <a:bodyPr wrap="square" lIns="0" tIns="0" rIns="0" bIns="0" rtlCol="0" anchor="ctr"/>
           <a:lstStyle/>
           <a:p>
-            <a:pPr indent="0" marL="0">
+            <a:pPr marL="0" indent="0">
               <a:buNone/>
             </a:pPr>
             <a:r>
@@ -6913,7 +6845,7 @@
           <a:bodyPr wrap="square" lIns="0" tIns="0" rIns="0" bIns="0" rtlCol="0" anchor="ctr"/>
           <a:lstStyle/>
           <a:p>
-            <a:pPr algn="r" indent="0" marL="0">
+            <a:pPr marL="0" indent="0" algn="r">
               <a:buNone/>
             </a:pPr>
             <a:r>
@@ -6975,6 +6907,13 @@
           </a:solidFill>
           <a:ln/>
         </p:spPr>
+        <p:txBody>
+          <a:bodyPr/>
+          <a:lstStyle/>
+          <a:p>
+            <a:endParaRPr lang="en-US"/>
+          </a:p>
+        </p:txBody>
       </p:sp>
       <p:sp>
         <p:nvSpPr>
@@ -6997,7 +6936,7 @@
           <a:bodyPr wrap="square" lIns="0" tIns="0" rIns="0" bIns="0" rtlCol="0" anchor="ctr"/>
           <a:lstStyle/>
           <a:p>
-            <a:pPr algn="ctr" indent="0" marL="0">
+            <a:pPr marL="0" indent="0" algn="ctr">
               <a:buNone/>
             </a:pPr>
             <a:r>
@@ -7036,11 +6975,11 @@
           <a:bodyPr wrap="square" lIns="0" tIns="0" rIns="0" bIns="0" rtlCol="0" anchor="ctr"/>
           <a:lstStyle/>
           <a:p>
-            <a:pPr indent="0" marL="0">
-              <a:buNone/>
-            </a:pPr>
-            <a:r>
-              <a:rPr lang="en-US" sz="1100" b="1" spc="140" kern="0" dirty="0">
+            <a:pPr marL="0" indent="0">
+              <a:buNone/>
+            </a:pPr>
+            <a:r>
+              <a:rPr lang="en-US" sz="1100" b="1" kern="0" spc="140" dirty="0">
                 <a:solidFill>
                   <a:srgbClr val="3F8A26"/>
                 </a:solidFill>
@@ -7075,7 +7014,7 @@
           <a:bodyPr wrap="square" lIns="0" tIns="0" rIns="0" bIns="0" rtlCol="0" anchor="t"/>
           <a:lstStyle/>
           <a:p>
-            <a:pPr indent="0" marL="0">
+            <a:pPr marL="0" indent="0">
               <a:buNone/>
             </a:pPr>
             <a:r>
@@ -7119,6 +7058,13 @@
             <a:prstDash val="solid"/>
           </a:ln>
         </p:spPr>
+        <p:txBody>
+          <a:bodyPr/>
+          <a:lstStyle/>
+          <a:p>
+            <a:endParaRPr lang="en-US"/>
+          </a:p>
+        </p:txBody>
       </p:sp>
       <p:sp>
         <p:nvSpPr>
@@ -7141,7 +7087,7 @@
           <a:bodyPr wrap="square" lIns="0" tIns="0" rIns="0" bIns="0" rtlCol="0" anchor="ctr"/>
           <a:lstStyle/>
           <a:p>
-            <a:pPr indent="0" marL="0">
+            <a:pPr marL="0" indent="0">
               <a:buNone/>
             </a:pPr>
             <a:r>
@@ -7270,6 +7216,13 @@
             <a:prstDash val="solid"/>
           </a:ln>
         </p:spPr>
+        <p:txBody>
+          <a:bodyPr/>
+          <a:lstStyle/>
+          <a:p>
+            <a:endParaRPr lang="en-US"/>
+          </a:p>
+        </p:txBody>
       </p:sp>
       <p:sp>
         <p:nvSpPr>
@@ -7292,7 +7245,7 @@
           <a:bodyPr wrap="square" lIns="0" tIns="0" rIns="0" bIns="0" rtlCol="0" anchor="ctr"/>
           <a:lstStyle/>
           <a:p>
-            <a:pPr indent="0" marL="0">
+            <a:pPr marL="0" indent="0">
               <a:buNone/>
             </a:pPr>
             <a:r>
@@ -7442,6 +7395,13 @@
             <a:prstDash val="solid"/>
           </a:ln>
         </p:spPr>
+        <p:txBody>
+          <a:bodyPr/>
+          <a:lstStyle/>
+          <a:p>
+            <a:endParaRPr lang="en-US"/>
+          </a:p>
+        </p:txBody>
       </p:sp>
       <p:sp>
         <p:nvSpPr>
@@ -7464,7 +7424,7 @@
           <a:bodyPr wrap="square" lIns="0" tIns="0" rIns="0" bIns="0" rtlCol="0" anchor="ctr"/>
           <a:lstStyle/>
           <a:p>
-            <a:pPr indent="0" marL="0">
+            <a:pPr marL="0" indent="0">
               <a:buNone/>
             </a:pPr>
             <a:r>
@@ -7609,7 +7569,7 @@
           <a:bodyPr wrap="square" lIns="0" tIns="0" rIns="0" bIns="0" rtlCol="0" anchor="ctr"/>
           <a:lstStyle/>
           <a:p>
-            <a:pPr algn="r" indent="0" marL="0">
+            <a:pPr marL="0" indent="0" algn="r">
               <a:buNone/>
             </a:pPr>
             <a:r>
@@ -7671,6 +7631,13 @@
           </a:solidFill>
           <a:ln/>
         </p:spPr>
+        <p:txBody>
+          <a:bodyPr/>
+          <a:lstStyle/>
+          <a:p>
+            <a:endParaRPr lang="en-US"/>
+          </a:p>
+        </p:txBody>
       </p:sp>
       <p:sp>
         <p:nvSpPr>
@@ -7693,7 +7660,7 @@
           <a:bodyPr wrap="square" lIns="0" tIns="0" rIns="0" bIns="0" rtlCol="0" anchor="ctr"/>
           <a:lstStyle/>
           <a:p>
-            <a:pPr algn="ctr" indent="0" marL="0">
+            <a:pPr marL="0" indent="0" algn="ctr">
               <a:buNone/>
             </a:pPr>
             <a:r>
@@ -7732,11 +7699,11 @@
           <a:bodyPr wrap="square" lIns="0" tIns="0" rIns="0" bIns="0" rtlCol="0" anchor="ctr"/>
           <a:lstStyle/>
           <a:p>
-            <a:pPr indent="0" marL="0">
-              <a:buNone/>
-            </a:pPr>
-            <a:r>
-              <a:rPr lang="en-US" sz="1100" b="1" spc="140" kern="0" dirty="0">
+            <a:pPr marL="0" indent="0">
+              <a:buNone/>
+            </a:pPr>
+            <a:r>
+              <a:rPr lang="en-US" sz="1100" b="1" kern="0" spc="140" dirty="0">
                 <a:solidFill>
                   <a:srgbClr val="3F8A26"/>
                 </a:solidFill>
@@ -7771,7 +7738,7 @@
           <a:bodyPr wrap="square" lIns="0" tIns="0" rIns="0" bIns="0" rtlCol="0" anchor="t"/>
           <a:lstStyle/>
           <a:p>
-            <a:pPr indent="0" marL="0">
+            <a:pPr marL="0" indent="0">
               <a:buNone/>
             </a:pPr>
             <a:r>
@@ -7815,6 +7782,13 @@
             <a:prstDash val="solid"/>
           </a:ln>
         </p:spPr>
+        <p:txBody>
+          <a:bodyPr/>
+          <a:lstStyle/>
+          <a:p>
+            <a:endParaRPr lang="en-US"/>
+          </a:p>
+        </p:txBody>
       </p:sp>
       <p:sp>
         <p:nvSpPr>
@@ -7837,7 +7811,7 @@
           <a:bodyPr wrap="square" lIns="0" tIns="0" rIns="0" bIns="0" rtlCol="0" anchor="ctr"/>
           <a:lstStyle/>
           <a:p>
-            <a:pPr indent="0" marL="0">
+            <a:pPr marL="0" indent="0">
               <a:buNone/>
             </a:pPr>
             <a:r>
@@ -7876,7 +7850,7 @@
           <a:bodyPr wrap="square" lIns="0" tIns="0" rIns="0" bIns="0" rtlCol="0" anchor="t"/>
           <a:lstStyle/>
           <a:p>
-            <a:pPr indent="0" marL="0">
+            <a:pPr marL="0" indent="0">
               <a:lnSpc>
                 <a:spcPts val="1620"/>
               </a:lnSpc>
@@ -7896,7 +7870,7 @@
             <a:endParaRPr lang="en-US" sz="1200" dirty="0"/>
           </a:p>
           <a:p>
-            <a:pPr indent="0" marL="0">
+            <a:pPr marL="0" indent="0">
               <a:lnSpc>
                 <a:spcPts val="1620"/>
               </a:lnSpc>
@@ -7916,7 +7890,7 @@
             <a:endParaRPr lang="en-US" sz="1200" dirty="0"/>
           </a:p>
           <a:p>
-            <a:pPr indent="0" marL="0">
+            <a:pPr marL="0" indent="0">
               <a:lnSpc>
                 <a:spcPts val="1620"/>
               </a:lnSpc>
@@ -7936,7 +7910,7 @@
             <a:endParaRPr lang="en-US" sz="1200" dirty="0"/>
           </a:p>
           <a:p>
-            <a:pPr indent="0" marL="0">
+            <a:pPr marL="0" indent="0">
               <a:lnSpc>
                 <a:spcPts val="1620"/>
               </a:lnSpc>
@@ -7956,7 +7930,7 @@
             <a:endParaRPr lang="en-US" sz="1200" dirty="0"/>
           </a:p>
           <a:p>
-            <a:pPr indent="0" marL="0">
+            <a:pPr marL="0" indent="0">
               <a:lnSpc>
                 <a:spcPts val="1620"/>
               </a:lnSpc>
@@ -7976,7 +7950,7 @@
             <a:endParaRPr lang="en-US" sz="1200" dirty="0"/>
           </a:p>
           <a:p>
-            <a:pPr indent="0" marL="0">
+            <a:pPr marL="0" indent="0">
               <a:lnSpc>
                 <a:spcPts val="1620"/>
               </a:lnSpc>
@@ -7996,7 +7970,7 @@
             <a:endParaRPr lang="en-US" sz="1200" dirty="0"/>
           </a:p>
           <a:p>
-            <a:pPr indent="0" marL="0">
+            <a:pPr marL="0" indent="0">
               <a:lnSpc>
                 <a:spcPts val="1620"/>
               </a:lnSpc>
@@ -8043,6 +8017,13 @@
             <a:prstDash val="solid"/>
           </a:ln>
         </p:spPr>
+        <p:txBody>
+          <a:bodyPr/>
+          <a:lstStyle/>
+          <a:p>
+            <a:endParaRPr lang="en-US"/>
+          </a:p>
+        </p:txBody>
       </p:sp>
       <p:sp>
         <p:nvSpPr>
@@ -8065,7 +8046,7 @@
           <a:bodyPr wrap="square" lIns="0" tIns="0" rIns="0" bIns="0" rtlCol="0" anchor="ctr"/>
           <a:lstStyle/>
           <a:p>
-            <a:pPr indent="0" marL="0">
+            <a:pPr marL="0" indent="0">
               <a:buNone/>
             </a:pPr>
             <a:r>
@@ -8104,7 +8085,7 @@
           <a:bodyPr wrap="square" lIns="0" tIns="0" rIns="0" bIns="0" rtlCol="0" anchor="t"/>
           <a:lstStyle/>
           <a:p>
-            <a:pPr indent="0" marL="0">
+            <a:pPr marL="0" indent="0">
               <a:buNone/>
             </a:pPr>
             <a:r>
@@ -8148,6 +8129,13 @@
             <a:prstDash val="solid"/>
           </a:ln>
         </p:spPr>
+        <p:txBody>
+          <a:bodyPr/>
+          <a:lstStyle/>
+          <a:p>
+            <a:endParaRPr lang="en-US"/>
+          </a:p>
+        </p:txBody>
       </p:sp>
       <p:sp>
         <p:nvSpPr>
@@ -8170,7 +8158,7 @@
           <a:bodyPr wrap="square" lIns="0" tIns="0" rIns="0" bIns="0" rtlCol="0" anchor="ctr"/>
           <a:lstStyle/>
           <a:p>
-            <a:pPr indent="0" marL="0">
+            <a:pPr marL="0" indent="0">
               <a:buNone/>
             </a:pPr>
             <a:r>
@@ -8209,7 +8197,7 @@
           <a:bodyPr wrap="square" lIns="0" tIns="0" rIns="0" bIns="0" rtlCol="0" anchor="t"/>
           <a:lstStyle/>
           <a:p>
-            <a:pPr indent="0" marL="0">
+            <a:pPr marL="0" indent="0">
               <a:buNone/>
             </a:pPr>
             <a:r>
@@ -8253,6 +8241,13 @@
             <a:prstDash val="solid"/>
           </a:ln>
         </p:spPr>
+        <p:txBody>
+          <a:bodyPr/>
+          <a:lstStyle/>
+          <a:p>
+            <a:endParaRPr lang="en-US"/>
+          </a:p>
+        </p:txBody>
       </p:sp>
       <p:sp>
         <p:nvSpPr>
@@ -8275,7 +8270,7 @@
           <a:bodyPr wrap="square" lIns="0" tIns="0" rIns="0" bIns="0" rtlCol="0" anchor="ctr"/>
           <a:lstStyle/>
           <a:p>
-            <a:pPr indent="0" marL="0">
+            <a:pPr marL="0" indent="0">
               <a:buNone/>
             </a:pPr>
             <a:r>
@@ -8314,7 +8309,7 @@
           <a:bodyPr wrap="square" lIns="0" tIns="0" rIns="0" bIns="0" rtlCol="0" anchor="t"/>
           <a:lstStyle/>
           <a:p>
-            <a:pPr indent="0" marL="0">
+            <a:pPr marL="0" indent="0">
               <a:buNone/>
             </a:pPr>
             <a:r>
@@ -8353,7 +8348,7 @@
           <a:bodyPr wrap="square" lIns="0" tIns="0" rIns="0" bIns="0" rtlCol="0" anchor="ctr"/>
           <a:lstStyle/>
           <a:p>
-            <a:pPr algn="r" indent="0" marL="0">
+            <a:pPr marL="0" indent="0" algn="r">
               <a:buNone/>
             </a:pPr>
             <a:r>
@@ -8415,6 +8410,13 @@
           </a:solidFill>
           <a:ln/>
         </p:spPr>
+        <p:txBody>
+          <a:bodyPr/>
+          <a:lstStyle/>
+          <a:p>
+            <a:endParaRPr lang="en-US"/>
+          </a:p>
+        </p:txBody>
       </p:sp>
       <p:sp>
         <p:nvSpPr>
@@ -8437,7 +8439,7 @@
           <a:bodyPr wrap="square" lIns="0" tIns="0" rIns="0" bIns="0" rtlCol="0" anchor="ctr"/>
           <a:lstStyle/>
           <a:p>
-            <a:pPr algn="ctr" indent="0" marL="0">
+            <a:pPr marL="0" indent="0" algn="ctr">
               <a:buNone/>
             </a:pPr>
             <a:r>
@@ -8476,11 +8478,11 @@
           <a:bodyPr wrap="square" lIns="0" tIns="0" rIns="0" bIns="0" rtlCol="0" anchor="ctr"/>
           <a:lstStyle/>
           <a:p>
-            <a:pPr indent="0" marL="0">
-              <a:buNone/>
-            </a:pPr>
-            <a:r>
-              <a:rPr lang="en-US" sz="1100" b="1" spc="140" kern="0" dirty="0">
+            <a:pPr marL="0" indent="0">
+              <a:buNone/>
+            </a:pPr>
+            <a:r>
+              <a:rPr lang="en-US" sz="1100" b="1" kern="0" spc="140" dirty="0">
                 <a:solidFill>
                   <a:srgbClr val="3F8A26"/>
                 </a:solidFill>
@@ -8515,7 +8517,7 @@
           <a:bodyPr wrap="square" lIns="0" tIns="0" rIns="0" bIns="0" rtlCol="0" anchor="t"/>
           <a:lstStyle/>
           <a:p>
-            <a:pPr indent="0" marL="0">
+            <a:pPr marL="0" indent="0">
               <a:buNone/>
             </a:pPr>
             <a:r>
@@ -8535,14 +8537,14 @@
       </p:sp>
       <p:pic>
         <p:nvPicPr>
-          <p:cNvPr id="6" name="Image 0" descr="/Users/fabianprado/Documents/projects/2026 - 2 /ai/proyecto2/resultados/figuras/comparacion_modelos.png">    </p:cNvPr>
+          <p:cNvPr id="6" name="Image 0" descr="/Users/fabianprado/Documents/projects/2026 - 2 /ai/proyecto2/resultados/figuras/comparacion_modelos.png"/>
           <p:cNvPicPr>
             <a:picLocks noChangeAspect="1"/>
           </p:cNvPicPr>
           <p:nvPr/>
         </p:nvPicPr>
         <p:blipFill>
-          <a:blip r:embed="rId1"/>
+          <a:blip r:embed="rId3"/>
           <a:stretch>
             <a:fillRect/>
           </a:stretch>
@@ -8583,6 +8585,13 @@
             <a:prstDash val="solid"/>
           </a:ln>
         </p:spPr>
+        <p:txBody>
+          <a:bodyPr/>
+          <a:lstStyle/>
+          <a:p>
+            <a:endParaRPr lang="en-US"/>
+          </a:p>
+        </p:txBody>
       </p:sp>
       <p:sp>
         <p:nvSpPr>
@@ -8605,7 +8614,7 @@
           <a:bodyPr wrap="square" lIns="0" tIns="0" rIns="0" bIns="0" rtlCol="0" anchor="ctr"/>
           <a:lstStyle/>
           <a:p>
-            <a:pPr indent="0" marL="0">
+            <a:pPr marL="0" indent="0">
               <a:buNone/>
             </a:pPr>
             <a:r>
@@ -8644,7 +8653,7 @@
           <a:bodyPr wrap="square" lIns="0" tIns="0" rIns="0" bIns="0" rtlCol="0" anchor="t"/>
           <a:lstStyle/>
           <a:p>
-            <a:pPr indent="0" marL="0">
+            <a:pPr marL="0" indent="0">
               <a:buNone/>
             </a:pPr>
             <a:r>
@@ -8683,7 +8692,7 @@
           <a:bodyPr wrap="square" lIns="0" tIns="0" rIns="0" bIns="0" rtlCol="0" anchor="ctr"/>
           <a:lstStyle/>
           <a:p>
-            <a:pPr algn="r" indent="0" marL="0">
+            <a:pPr marL="0" indent="0" algn="r">
               <a:buNone/>
             </a:pPr>
             <a:r>
@@ -8745,6 +8754,13 @@
           </a:solidFill>
           <a:ln/>
         </p:spPr>
+        <p:txBody>
+          <a:bodyPr/>
+          <a:lstStyle/>
+          <a:p>
+            <a:endParaRPr lang="en-US"/>
+          </a:p>
+        </p:txBody>
       </p:sp>
       <p:sp>
         <p:nvSpPr>
@@ -8767,7 +8783,7 @@
           <a:bodyPr wrap="square" lIns="0" tIns="0" rIns="0" bIns="0" rtlCol="0" anchor="ctr"/>
           <a:lstStyle/>
           <a:p>
-            <a:pPr algn="ctr" indent="0" marL="0">
+            <a:pPr marL="0" indent="0" algn="ctr">
               <a:buNone/>
             </a:pPr>
             <a:r>
@@ -8806,11 +8822,11 @@
           <a:bodyPr wrap="square" lIns="0" tIns="0" rIns="0" bIns="0" rtlCol="0" anchor="ctr"/>
           <a:lstStyle/>
           <a:p>
-            <a:pPr indent="0" marL="0">
-              <a:buNone/>
-            </a:pPr>
-            <a:r>
-              <a:rPr lang="en-US" sz="1100" b="1" spc="140" kern="0" dirty="0">
+            <a:pPr marL="0" indent="0">
+              <a:buNone/>
+            </a:pPr>
+            <a:r>
+              <a:rPr lang="en-US" sz="1100" b="1" kern="0" spc="140" dirty="0">
                 <a:solidFill>
                   <a:srgbClr val="3F8A26"/>
                 </a:solidFill>
@@ -8845,7 +8861,7 @@
           <a:bodyPr wrap="square" lIns="0" tIns="0" rIns="0" bIns="0" rtlCol="0" anchor="t"/>
           <a:lstStyle/>
           <a:p>
-            <a:pPr indent="0" marL="0">
+            <a:pPr marL="0" indent="0">
               <a:buNone/>
             </a:pPr>
             <a:r>
@@ -8865,14 +8881,14 @@
       </p:sp>
       <p:pic>
         <p:nvPicPr>
-          <p:cNvPr id="6" name="Image 0" descr="/Users/fabianprado/Documents/projects/2026 - 2 /ai/proyecto2/resultados/figuras/matriz_confusion_test.png">    </p:cNvPr>
+          <p:cNvPr id="6" name="Image 0" descr="/Users/fabianprado/Documents/projects/2026 - 2 /ai/proyecto2/resultados/figuras/matriz_confusion_test.png"/>
           <p:cNvPicPr>
             <a:picLocks noChangeAspect="1"/>
           </p:cNvPicPr>
           <p:nvPr/>
         </p:nvPicPr>
         <p:blipFill>
-          <a:blip r:embed="rId1"/>
+          <a:blip r:embed="rId3"/>
           <a:stretch>
             <a:fillRect/>
           </a:stretch>
@@ -8913,6 +8929,13 @@
             <a:prstDash val="solid"/>
           </a:ln>
         </p:spPr>
+        <p:txBody>
+          <a:bodyPr/>
+          <a:lstStyle/>
+          <a:p>
+            <a:endParaRPr lang="en-US"/>
+          </a:p>
+        </p:txBody>
       </p:sp>
       <p:sp>
         <p:nvSpPr>
@@ -8935,7 +8958,7 @@
           <a:bodyPr wrap="square" lIns="0" tIns="0" rIns="0" bIns="0" rtlCol="0" anchor="ctr"/>
           <a:lstStyle/>
           <a:p>
-            <a:pPr indent="0" marL="0">
+            <a:pPr marL="0" indent="0">
               <a:buNone/>
             </a:pPr>
             <a:r>
@@ -8974,7 +8997,7 @@
           <a:bodyPr wrap="square" lIns="0" tIns="0" rIns="0" bIns="0" rtlCol="0" anchor="t"/>
           <a:lstStyle/>
           <a:p>
-            <a:pPr indent="0" marL="0">
+            <a:pPr marL="0" indent="0">
               <a:buNone/>
             </a:pPr>
             <a:r>
@@ -9013,7 +9036,7 @@
           <a:bodyPr wrap="square" lIns="0" tIns="0" rIns="0" bIns="0" rtlCol="0" anchor="ctr"/>
           <a:lstStyle/>
           <a:p>
-            <a:pPr algn="r" indent="0" marL="0">
+            <a:pPr marL="0" indent="0" algn="r">
               <a:buNone/>
             </a:pPr>
             <a:r>
@@ -9332,4 +9355,319 @@
     </a:ext>
   </a:extLst>
 </a:theme>
+</file>
+
+<file path=ppt/theme/theme2.xml><?xml version="1.0" encoding="utf-8"?>
+<a:theme xmlns:a="http://schemas.openxmlformats.org/drawingml/2006/main" name="Office Theme">
+  <a:themeElements>
+    <a:clrScheme name="Office">
+      <a:dk1>
+        <a:sysClr val="windowText" lastClr="000000"/>
+      </a:dk1>
+      <a:lt1>
+        <a:sysClr val="window" lastClr="FFFFFF"/>
+      </a:lt1>
+      <a:dk2>
+        <a:srgbClr val="0E2841"/>
+      </a:dk2>
+      <a:lt2>
+        <a:srgbClr val="E8E8E8"/>
+      </a:lt2>
+      <a:accent1>
+        <a:srgbClr val="156082"/>
+      </a:accent1>
+      <a:accent2>
+        <a:srgbClr val="E97132"/>
+      </a:accent2>
+      <a:accent3>
+        <a:srgbClr val="196B24"/>
+      </a:accent3>
+      <a:accent4>
+        <a:srgbClr val="0F9ED5"/>
+      </a:accent4>
+      <a:accent5>
+        <a:srgbClr val="A02B93"/>
+      </a:accent5>
+      <a:accent6>
+        <a:srgbClr val="4EA72E"/>
+      </a:accent6>
+      <a:hlink>
+        <a:srgbClr val="467886"/>
+      </a:hlink>
+      <a:folHlink>
+        <a:srgbClr val="96607D"/>
+      </a:folHlink>
+    </a:clrScheme>
+    <a:fontScheme name="Office">
+      <a:majorFont>
+        <a:latin typeface="Aptos Display" panose="02110004020202020204"/>
+        <a:ea typeface=""/>
+        <a:cs typeface=""/>
+        <a:font script="Jpan" typeface="游ゴシック Light"/>
+        <a:font script="Hang" typeface="맑은 고딕"/>
+        <a:font script="Hans" typeface="等线 Light"/>
+        <a:font script="Hant" typeface="新細明體"/>
+        <a:font script="Arab" typeface="Times New Roman"/>
+        <a:font script="Hebr" typeface="Times New Roman"/>
+        <a:font script="Thai" typeface="Angsana New"/>
+        <a:font script="Ethi" typeface="Nyala"/>
+        <a:font script="Beng" typeface="Vrinda"/>
+        <a:font script="Gujr" typeface="Shruti"/>
+        <a:font script="Khmr" typeface="MoolBoran"/>
+        <a:font script="Knda" typeface="Tunga"/>
+        <a:font script="Guru" typeface="Raavi"/>
+        <a:font script="Cans" typeface="Euphemia"/>
+        <a:font script="Cher" typeface="Plantagenet Cherokee"/>
+        <a:font script="Yiii" typeface="Microsoft Yi Baiti"/>
+        <a:font script="Tibt" typeface="Microsoft Himalaya"/>
+        <a:font script="Thaa" typeface="MV Boli"/>
+        <a:font script="Deva" typeface="Mangal"/>
+        <a:font script="Telu" typeface="Gautami"/>
+        <a:font script="Taml" typeface="Latha"/>
+        <a:font script="Syrc" typeface="Estrangelo Edessa"/>
+        <a:font script="Orya" typeface="Kalinga"/>
+        <a:font script="Mlym" typeface="Kartika"/>
+        <a:font script="Laoo" typeface="DokChampa"/>
+        <a:font script="Sinh" typeface="Iskoola Pota"/>
+        <a:font script="Mong" typeface="Mongolian Baiti"/>
+        <a:font script="Viet" typeface="Times New Roman"/>
+        <a:font script="Uigh" typeface="Microsoft Uighur"/>
+        <a:font script="Geor" typeface="Sylfaen"/>
+        <a:font script="Armn" typeface="Arial"/>
+        <a:font script="Bugi" typeface="Leelawadee UI"/>
+        <a:font script="Bopo" typeface="Microsoft JhengHei"/>
+        <a:font script="Java" typeface="Javanese Text"/>
+        <a:font script="Lisu" typeface="Segoe UI"/>
+        <a:font script="Mymr" typeface="Myanmar Text"/>
+        <a:font script="Nkoo" typeface="Ebrima"/>
+        <a:font script="Olck" typeface="Nirmala UI"/>
+        <a:font script="Osma" typeface="Ebrima"/>
+        <a:font script="Phag" typeface="Phagspa"/>
+        <a:font script="Syrn" typeface="Estrangelo Edessa"/>
+        <a:font script="Syrj" typeface="Estrangelo Edessa"/>
+        <a:font script="Syre" typeface="Estrangelo Edessa"/>
+        <a:font script="Sora" typeface="Nirmala UI"/>
+        <a:font script="Tale" typeface="Microsoft Tai Le"/>
+        <a:font script="Talu" typeface="Microsoft New Tai Lue"/>
+        <a:font script="Tfng" typeface="Ebrima"/>
+      </a:majorFont>
+      <a:minorFont>
+        <a:latin typeface="Aptos" panose="02110004020202020204"/>
+        <a:ea typeface=""/>
+        <a:cs typeface=""/>
+        <a:font script="Jpan" typeface="游ゴシック"/>
+        <a:font script="Hang" typeface="맑은 고딕"/>
+        <a:font script="Hans" typeface="等线"/>
+        <a:font script="Hant" typeface="新細明體"/>
+        <a:font script="Arab" typeface="Arial"/>
+        <a:font script="Hebr" typeface="Arial"/>
+        <a:font script="Thai" typeface="Cordia New"/>
+        <a:font script="Ethi" typeface="Nyala"/>
+        <a:font script="Beng" typeface="Vrinda"/>
+        <a:font script="Gujr" typeface="Shruti"/>
+        <a:font script="Khmr" typeface="DaunPenh"/>
+        <a:font script="Knda" typeface="Tunga"/>
+        <a:font script="Guru" typeface="Raavi"/>
+        <a:font script="Cans" typeface="Euphemia"/>
+        <a:font script="Cher" typeface="Plantagenet Cherokee"/>
+        <a:font script="Yiii" typeface="Microsoft Yi Baiti"/>
+        <a:font script="Tibt" typeface="Microsoft Himalaya"/>
+        <a:font script="Thaa" typeface="MV Boli"/>
+        <a:font script="Deva" typeface="Mangal"/>
+        <a:font script="Telu" typeface="Gautami"/>
+        <a:font script="Taml" typeface="Latha"/>
+        <a:font script="Syrc" typeface="Estrangelo Edessa"/>
+        <a:font script="Orya" typeface="Kalinga"/>
+        <a:font script="Mlym" typeface="Kartika"/>
+        <a:font script="Laoo" typeface="DokChampa"/>
+        <a:font script="Sinh" typeface="Iskoola Pota"/>
+        <a:font script="Mong" typeface="Mongolian Baiti"/>
+        <a:font script="Viet" typeface="Arial"/>
+        <a:font script="Uigh" typeface="Microsoft Uighur"/>
+        <a:font script="Geor" typeface="Sylfaen"/>
+        <a:font script="Armn" typeface="Arial"/>
+        <a:font script="Bugi" typeface="Leelawadee UI"/>
+        <a:font script="Bopo" typeface="Microsoft JhengHei"/>
+        <a:font script="Java" typeface="Javanese Text"/>
+        <a:font script="Lisu" typeface="Segoe UI"/>
+        <a:font script="Mymr" typeface="Myanmar Text"/>
+        <a:font script="Nkoo" typeface="Ebrima"/>
+        <a:font script="Olck" typeface="Nirmala UI"/>
+        <a:font script="Osma" typeface="Ebrima"/>
+        <a:font script="Phag" typeface="Phagspa"/>
+        <a:font script="Syrn" typeface="Estrangelo Edessa"/>
+        <a:font script="Syrj" typeface="Estrangelo Edessa"/>
+        <a:font script="Syre" typeface="Estrangelo Edessa"/>
+        <a:font script="Sora" typeface="Nirmala UI"/>
+        <a:font script="Tale" typeface="Microsoft Tai Le"/>
+        <a:font script="Talu" typeface="Microsoft New Tai Lue"/>
+        <a:font script="Tfng" typeface="Ebrima"/>
+      </a:minorFont>
+    </a:fontScheme>
+    <a:fmtScheme name="Office">
+      <a:fillStyleLst>
+        <a:solidFill>
+          <a:schemeClr val="phClr"/>
+        </a:solidFill>
+        <a:gradFill rotWithShape="1">
+          <a:gsLst>
+            <a:gs pos="0">
+              <a:schemeClr val="phClr">
+                <a:lumMod val="110000"/>
+                <a:satMod val="105000"/>
+                <a:tint val="67000"/>
+              </a:schemeClr>
+            </a:gs>
+            <a:gs pos="50000">
+              <a:schemeClr val="phClr">
+                <a:lumMod val="105000"/>
+                <a:satMod val="103000"/>
+                <a:tint val="73000"/>
+              </a:schemeClr>
+            </a:gs>
+            <a:gs pos="100000">
+              <a:schemeClr val="phClr">
+                <a:lumMod val="105000"/>
+                <a:satMod val="109000"/>
+                <a:tint val="81000"/>
+              </a:schemeClr>
+            </a:gs>
+          </a:gsLst>
+          <a:lin ang="5400000" scaled="0"/>
+        </a:gradFill>
+        <a:gradFill rotWithShape="1">
+          <a:gsLst>
+            <a:gs pos="0">
+              <a:schemeClr val="phClr">
+                <a:satMod val="103000"/>
+                <a:lumMod val="102000"/>
+                <a:tint val="94000"/>
+              </a:schemeClr>
+            </a:gs>
+            <a:gs pos="50000">
+              <a:schemeClr val="phClr">
+                <a:satMod val="110000"/>
+                <a:lumMod val="100000"/>
+                <a:shade val="100000"/>
+              </a:schemeClr>
+            </a:gs>
+            <a:gs pos="100000">
+              <a:schemeClr val="phClr">
+                <a:lumMod val="99000"/>
+                <a:satMod val="120000"/>
+                <a:shade val="78000"/>
+              </a:schemeClr>
+            </a:gs>
+          </a:gsLst>
+          <a:lin ang="5400000" scaled="0"/>
+        </a:gradFill>
+      </a:fillStyleLst>
+      <a:lnStyleLst>
+        <a:ln w="12700" cap="flat" cmpd="sng" algn="ctr">
+          <a:solidFill>
+            <a:schemeClr val="phClr"/>
+          </a:solidFill>
+          <a:prstDash val="solid"/>
+          <a:miter lim="800000"/>
+        </a:ln>
+        <a:ln w="19050" cap="flat" cmpd="sng" algn="ctr">
+          <a:solidFill>
+            <a:schemeClr val="phClr"/>
+          </a:solidFill>
+          <a:prstDash val="solid"/>
+          <a:miter lim="800000"/>
+        </a:ln>
+        <a:ln w="25400" cap="flat" cmpd="sng" algn="ctr">
+          <a:solidFill>
+            <a:schemeClr val="phClr"/>
+          </a:solidFill>
+          <a:prstDash val="solid"/>
+          <a:miter lim="800000"/>
+        </a:ln>
+      </a:lnStyleLst>
+      <a:effectStyleLst>
+        <a:effectStyle>
+          <a:effectLst/>
+        </a:effectStyle>
+        <a:effectStyle>
+          <a:effectLst/>
+        </a:effectStyle>
+        <a:effectStyle>
+          <a:effectLst>
+            <a:outerShdw blurRad="57150" dist="19050" dir="5400000" algn="ctr" rotWithShape="0">
+              <a:srgbClr val="000000">
+                <a:alpha val="63000"/>
+              </a:srgbClr>
+            </a:outerShdw>
+          </a:effectLst>
+        </a:effectStyle>
+      </a:effectStyleLst>
+      <a:bgFillStyleLst>
+        <a:solidFill>
+          <a:schemeClr val="phClr"/>
+        </a:solidFill>
+        <a:solidFill>
+          <a:schemeClr val="phClr">
+            <a:tint val="95000"/>
+            <a:satMod val="170000"/>
+          </a:schemeClr>
+        </a:solidFill>
+        <a:gradFill rotWithShape="1">
+          <a:gsLst>
+            <a:gs pos="0">
+              <a:schemeClr val="phClr">
+                <a:tint val="93000"/>
+                <a:satMod val="150000"/>
+                <a:shade val="98000"/>
+                <a:lumMod val="102000"/>
+              </a:schemeClr>
+            </a:gs>
+            <a:gs pos="50000">
+              <a:schemeClr val="phClr">
+                <a:tint val="98000"/>
+                <a:satMod val="130000"/>
+                <a:shade val="90000"/>
+                <a:lumMod val="103000"/>
+              </a:schemeClr>
+            </a:gs>
+            <a:gs pos="100000">
+              <a:schemeClr val="phClr">
+                <a:shade val="63000"/>
+                <a:satMod val="120000"/>
+              </a:schemeClr>
+            </a:gs>
+          </a:gsLst>
+          <a:lin ang="5400000" scaled="0"/>
+        </a:gradFill>
+      </a:bgFillStyleLst>
+    </a:fmtScheme>
+  </a:themeElements>
+  <a:objectDefaults>
+    <a:lnDef>
+      <a:spPr/>
+      <a:bodyPr/>
+      <a:lstStyle/>
+      <a:style>
+        <a:lnRef idx="2">
+          <a:schemeClr val="accent1"/>
+        </a:lnRef>
+        <a:fillRef idx="0">
+          <a:schemeClr val="accent1"/>
+        </a:fillRef>
+        <a:effectRef idx="1">
+          <a:schemeClr val="accent1"/>
+        </a:effectRef>
+        <a:fontRef idx="minor">
+          <a:schemeClr val="tx1"/>
+        </a:fontRef>
+      </a:style>
+    </a:lnDef>
+  </a:objectDefaults>
+  <a:extraClrSchemeLst/>
+  <a:extLst>
+    <a:ext uri="{05A4C25C-085E-4340-85A3-A5531E510DB2}">
+      <thm15:themeFamily xmlns:thm15="http://schemas.microsoft.com/office/thememl/2012/main" name="Office Theme" id="{2E142A2C-CD16-42D6-873A-C26D2A0506FA}" vid="{1BDDFF52-6CD6-40A5-AB3C-68EB2F1E4D0A}"/>
+    </a:ext>
+  </a:extLst>
+</a:theme>
 </file>
</xml_diff>